<commit_message>
Fix BPMN slide: grid-aligned layout, proper swimlanes
Complete rewrite of BPMN process diagram:
- 4 swimlanes with consistent heights (User/Backend/ES/Redis)
- Grid-based positioning: 7 columns, elements centered in lanes
- Proper gateway diamond with "Да/Нет" labels for short/full mode
- Arrows strictly aligned to element edges (no floating lines)
- Clear flow: Input → Normalize → Spell → Gateway → Search → Score → RAG → End
- Cross-lane arrows: Backend↔ES, Backend↔Redis connections

Co-Authored-By: Claude Opus 4.6 (1M context) <noreply@anthropic.com>
</commit_message>
<xml_diff>
--- a/docs/TenderHack2026_Presentation.pptx
+++ b/docs/TenderHack2026_Presentation.pptx
@@ -5225,8 +5225,8 @@
         </p:nvSpPr>
         <p:spPr>
           <a:xfrm>
-            <a:off x="548640" y="914400"/>
-            <a:ext cx="10972800" cy="1280160"/>
+            <a:off x="365760" y="914400"/>
+            <a:ext cx="11430000" cy="1188720"/>
           </a:xfrm>
           <a:prstGeom prst="rect">
             <a:avLst/>
@@ -5270,8 +5270,8 @@
         </p:nvSpPr>
         <p:spPr>
           <a:xfrm>
-            <a:off x="640080" y="960120"/>
-            <a:ext cx="1188720" cy="274320"/>
+            <a:off x="411480" y="932688"/>
+            <a:ext cx="1005840" cy="228600"/>
           </a:xfrm>
           <a:prstGeom prst="rect">
             <a:avLst/>
@@ -5285,7 +5285,7 @@
           <a:lstStyle/>
           <a:p>
             <a:pPr algn="l">
-              <a:defRPr sz="900" b="1">
+              <a:defRPr sz="800" b="1">
                 <a:solidFill>
                   <a:srgbClr val="334059"/>
                 </a:solidFill>
@@ -5305,8 +5305,8 @@
         </p:nvSpPr>
         <p:spPr>
           <a:xfrm>
-            <a:off x="548640" y="2377440"/>
-            <a:ext cx="10972800" cy="1280160"/>
+            <a:off x="365760" y="2286000"/>
+            <a:ext cx="11430000" cy="1188720"/>
           </a:xfrm>
           <a:prstGeom prst="rect">
             <a:avLst/>
@@ -5350,8 +5350,8 @@
         </p:nvSpPr>
         <p:spPr>
           <a:xfrm>
-            <a:off x="640080" y="2423160"/>
-            <a:ext cx="1188720" cy="274320"/>
+            <a:off x="411480" y="2304288"/>
+            <a:ext cx="1005840" cy="228600"/>
           </a:xfrm>
           <a:prstGeom prst="rect">
             <a:avLst/>
@@ -5365,14 +5365,14 @@
           <a:lstStyle/>
           <a:p>
             <a:pPr algn="l">
-              <a:defRPr sz="900" b="1">
+              <a:defRPr sz="800" b="1">
                 <a:solidFill>
                   <a:srgbClr val="334059"/>
                 </a:solidFill>
               </a:defRPr>
             </a:pPr>
             <a:r>
-              <a:t>Backend</a:t>
+              <a:t>Backend (FastAPI)</a:t>
             </a:r>
           </a:p>
         </p:txBody>
@@ -5385,8 +5385,8 @@
         </p:nvSpPr>
         <p:spPr>
           <a:xfrm>
-            <a:off x="548640" y="3840480"/>
-            <a:ext cx="10972800" cy="1280160"/>
+            <a:off x="365760" y="3657600"/>
+            <a:ext cx="11430000" cy="1188720"/>
           </a:xfrm>
           <a:prstGeom prst="rect">
             <a:avLst/>
@@ -5430,8 +5430,8 @@
         </p:nvSpPr>
         <p:spPr>
           <a:xfrm>
-            <a:off x="640080" y="3886200"/>
-            <a:ext cx="1188720" cy="274320"/>
+            <a:off x="411480" y="3675888"/>
+            <a:ext cx="1005840" cy="228600"/>
           </a:xfrm>
           <a:prstGeom prst="rect">
             <a:avLst/>
@@ -5445,7 +5445,7 @@
           <a:lstStyle/>
           <a:p>
             <a:pPr algn="l">
-              <a:defRPr sz="900" b="1">
+              <a:defRPr sz="800" b="1">
                 <a:solidFill>
                   <a:srgbClr val="334059"/>
                 </a:solidFill>
@@ -5465,8 +5465,8 @@
         </p:nvSpPr>
         <p:spPr>
           <a:xfrm>
-            <a:off x="548640" y="5303520"/>
-            <a:ext cx="10972800" cy="1280160"/>
+            <a:off x="365760" y="5029200"/>
+            <a:ext cx="11430000" cy="1188720"/>
           </a:xfrm>
           <a:prstGeom prst="rect">
             <a:avLst/>
@@ -5510,8 +5510,8 @@
         </p:nvSpPr>
         <p:spPr>
           <a:xfrm>
-            <a:off x="640080" y="5349240"/>
-            <a:ext cx="1188720" cy="274320"/>
+            <a:off x="411480" y="5047488"/>
+            <a:ext cx="1005840" cy="228600"/>
           </a:xfrm>
           <a:prstGeom prst="rect">
             <a:avLst/>
@@ -5525,14 +5525,14 @@
           <a:lstStyle/>
           <a:p>
             <a:pPr algn="l">
-              <a:defRPr sz="900" b="1">
+              <a:defRPr sz="800" b="1">
                 <a:solidFill>
                   <a:srgbClr val="334059"/>
                 </a:solidFill>
               </a:defRPr>
             </a:pPr>
             <a:r>
-              <a:t>Redis / PG</a:t>
+              <a:t>Redis / PostgreSQL</a:t>
             </a:r>
           </a:p>
         </p:txBody>
@@ -5545,8 +5545,8 @@
         </p:nvSpPr>
         <p:spPr>
           <a:xfrm>
-            <a:off x="1828800" y="1234440"/>
-            <a:ext cx="411480" cy="411480"/>
+            <a:off x="1645920" y="1325880"/>
+            <a:ext cx="365760" cy="365760"/>
           </a:xfrm>
           <a:prstGeom prst="ellipse">
             <a:avLst/>
@@ -5588,8 +5588,8 @@
         </p:nvSpPr>
         <p:spPr>
           <a:xfrm>
-            <a:off x="2560320" y="1143000"/>
-            <a:ext cx="1188720" cy="502920"/>
+            <a:off x="3200400" y="1234440"/>
+            <a:ext cx="1280160" cy="548640"/>
           </a:xfrm>
           <a:prstGeom prst="roundRect">
             <a:avLst/>
@@ -5631,44 +5631,58 @@
             <a:r>
               <a:t>Ввод запроса</a:t>
             </a:r>
-          </a:p>
-        </p:txBody>
-      </p:sp>
-      <p:cxnSp>
-        <p:nvCxnSpPr>
-          <p:cNvPr id="16" name="Connector 15"/>
-          <p:cNvCxnSpPr/>
-          <p:nvPr/>
-        </p:nvCxnSpPr>
-        <p:spPr>
-          <a:xfrm>
-            <a:off x="2240280" y="1417320"/>
-            <a:ext cx="320040" cy="0"/>
-          </a:xfrm>
-          <a:prstGeom prst="line">
-            <a:avLst/>
-          </a:prstGeom>
-          <a:ln w="19050">
+            <a:br/>
+            <a:r>
+              <a:t>в строку поиска</a:t>
+            </a:r>
+          </a:p>
+        </p:txBody>
+      </p:sp>
+      <p:sp>
+        <p:nvSpPr>
+          <p:cNvPr id="16" name="Oval 15"/>
+          <p:cNvSpPr/>
+          <p:nvPr/>
+        </p:nvSpPr>
+        <p:spPr>
+          <a:xfrm>
+            <a:off x="10515600" y="1325880"/>
+            <a:ext cx="365760" cy="365760"/>
+          </a:xfrm>
+          <a:prstGeom prst="ellipse">
+            <a:avLst/>
+          </a:prstGeom>
+          <a:solidFill>
+            <a:srgbClr val="E53935"/>
+          </a:solidFill>
+          <a:ln w="38100">
             <a:solidFill>
-              <a:srgbClr val="999999"/>
+              <a:srgbClr val="E53935"/>
             </a:solidFill>
           </a:ln>
         </p:spPr>
         <p:style>
-          <a:lnRef idx="2">
+          <a:lnRef idx="1">
             <a:schemeClr val="accent1"/>
           </a:lnRef>
-          <a:fillRef idx="0">
+          <a:fillRef idx="3">
             <a:schemeClr val="accent1"/>
           </a:fillRef>
-          <a:effectRef idx="1">
+          <a:effectRef idx="2">
             <a:schemeClr val="accent1"/>
           </a:effectRef>
           <a:fontRef idx="minor">
-            <a:schemeClr val="tx1"/>
+            <a:schemeClr val="lt1"/>
           </a:fontRef>
         </p:style>
-      </p:cxnSp>
+        <p:txBody>
+          <a:bodyPr rtlCol="0" anchor="ctr"/>
+          <a:lstStyle/>
+          <a:p>
+            <a:pPr algn="ctr"/>
+          </a:p>
+        </p:txBody>
+      </p:sp>
       <p:sp>
         <p:nvSpPr>
           <p:cNvPr id="17" name="Rounded Rectangle 16"/>
@@ -5677,8 +5691,8 @@
         </p:nvSpPr>
         <p:spPr>
           <a:xfrm>
-            <a:off x="2560320" y="2606040"/>
-            <a:ext cx="1005840" cy="502920"/>
+            <a:off x="1645920" y="2606040"/>
+            <a:ext cx="1280160" cy="548640"/>
           </a:xfrm>
           <a:prstGeom prst="roundRect">
             <a:avLst/>
@@ -5722,7 +5736,7 @@
             </a:r>
             <a:br/>
             <a:r>
-              <a:t>раскладка</a:t>
+              <a:t>EN→RU раскладка</a:t>
             </a:r>
           </a:p>
         </p:txBody>
@@ -5735,8 +5749,8 @@
         </p:nvSpPr>
         <p:spPr>
           <a:xfrm>
-            <a:off x="3749039" y="2606040"/>
-            <a:ext cx="1005840" cy="502920"/>
+            <a:off x="3200400" y="2606040"/>
+            <a:ext cx="1280160" cy="548640"/>
           </a:xfrm>
           <a:prstGeom prst="roundRect">
             <a:avLst/>
@@ -5793,8 +5807,8 @@
         </p:nvSpPr>
         <p:spPr>
           <a:xfrm>
-            <a:off x="4983480" y="2514600"/>
-            <a:ext cx="548640" cy="548640"/>
+            <a:off x="5120640" y="2628900"/>
+            <a:ext cx="502920" cy="502920"/>
           </a:xfrm>
           <a:prstGeom prst="diamond">
             <a:avLst/>
@@ -5834,11 +5848,7 @@
               </a:defRPr>
             </a:pPr>
             <a:r>
-              <a:t>≤6</a:t>
-            </a:r>
-            <a:br/>
-            <a:r>
-              <a:t>симв?</a:t>
+              <a:t>≤6?</a:t>
             </a:r>
           </a:p>
         </p:txBody>
@@ -5851,8 +5861,8 @@
         </p:nvSpPr>
         <p:spPr>
           <a:xfrm>
-            <a:off x="5760720" y="2423160"/>
-            <a:ext cx="1097280" cy="502920"/>
+            <a:off x="5852160" y="2286000"/>
+            <a:ext cx="1280160" cy="548640"/>
           </a:xfrm>
           <a:prstGeom prst="roundRect">
             <a:avLst/>
@@ -5892,7 +5902,7 @@
               </a:defRPr>
             </a:pPr>
             <a:r>
-              <a:t>Prefix</a:t>
+              <a:t>Prefix поиск</a:t>
             </a:r>
             <a:br/>
             <a:r>
@@ -5909,8 +5919,8 @@
         </p:nvSpPr>
         <p:spPr>
           <a:xfrm>
-            <a:off x="5760720" y="2971800"/>
-            <a:ext cx="1097280" cy="502920"/>
+            <a:off x="5852160" y="2926080"/>
+            <a:ext cx="1280160" cy="548640"/>
           </a:xfrm>
           <a:prstGeom prst="roundRect">
             <a:avLst/>
@@ -5967,8 +5977,8 @@
         </p:nvSpPr>
         <p:spPr>
           <a:xfrm>
-            <a:off x="7132320" y="2606040"/>
-            <a:ext cx="1097280" cy="502920"/>
+            <a:off x="7406640" y="2606040"/>
+            <a:ext cx="1280160" cy="548640"/>
           </a:xfrm>
           <a:prstGeom prst="roundRect">
             <a:avLst/>
@@ -6008,11 +6018,11 @@
               </a:defRPr>
             </a:pPr>
             <a:r>
-              <a:t>Function</a:t>
+              <a:t>Function score</a:t>
             </a:r>
             <a:br/>
             <a:r>
-              <a:t>score</a:t>
+              <a:t>+ бусты</a:t>
             </a:r>
           </a:p>
         </p:txBody>
@@ -6025,8 +6035,8 @@
         </p:nvSpPr>
         <p:spPr>
           <a:xfrm>
-            <a:off x="8412480" y="2606040"/>
-            <a:ext cx="1005840" cy="502920"/>
+            <a:off x="8961120" y="2606040"/>
+            <a:ext cx="1280160" cy="548640"/>
           </a:xfrm>
           <a:prstGeom prst="roundRect">
             <a:avLst/>
@@ -6083,8 +6093,8 @@
         </p:nvSpPr>
         <p:spPr>
           <a:xfrm>
-            <a:off x="9601200" y="2606040"/>
-            <a:ext cx="1005840" cy="502920"/>
+            <a:off x="5852160" y="3977640"/>
+            <a:ext cx="1280160" cy="548640"/>
           </a:xfrm>
           <a:prstGeom prst="roundRect">
             <a:avLst/>
@@ -6124,11 +6134,11 @@
               </a:defRPr>
             </a:pPr>
             <a:r>
-              <a:t>Формирование</a:t>
+              <a:t>BM25 + fuzzy</a:t>
             </a:r>
             <a:br/>
             <a:r>
-              <a:t>ответа</a:t>
+              <a:t>synonyms</a:t>
             </a:r>
           </a:p>
         </p:txBody>
@@ -6141,8 +6151,8 @@
         </p:nvSpPr>
         <p:spPr>
           <a:xfrm>
-            <a:off x="7132320" y="4069080"/>
-            <a:ext cx="1097280" cy="502920"/>
+            <a:off x="7406640" y="3977640"/>
+            <a:ext cx="1280160" cy="548640"/>
           </a:xfrm>
           <a:prstGeom prst="roundRect">
             <a:avLst/>
@@ -6182,11 +6192,11 @@
               </a:defRPr>
             </a:pPr>
             <a:r>
-              <a:t>BM25 + fuzzy</a:t>
+              <a:t>Aggregation</a:t>
             </a:r>
             <a:br/>
             <a:r>
-              <a:t>+ synonyms</a:t>
+              <a:t>категорий</a:t>
             </a:r>
           </a:p>
         </p:txBody>
@@ -6199,8 +6209,8 @@
         </p:nvSpPr>
         <p:spPr>
           <a:xfrm>
-            <a:off x="8412480" y="4069080"/>
-            <a:ext cx="1005840" cy="502920"/>
+            <a:off x="8961120" y="3977640"/>
+            <a:ext cx="1280160" cy="548640"/>
           </a:xfrm>
           <a:prstGeom prst="roundRect">
             <a:avLst/>
@@ -6240,11 +6250,11 @@
               </a:defRPr>
             </a:pPr>
             <a:r>
-              <a:t>Category</a:t>
+              <a:t>Filtered</a:t>
             </a:r>
             <a:br/>
             <a:r>
-              <a:t>aggregation</a:t>
+              <a:t>search</a:t>
             </a:r>
           </a:p>
         </p:txBody>
@@ -6257,8 +6267,8 @@
         </p:nvSpPr>
         <p:spPr>
           <a:xfrm>
-            <a:off x="9601200" y="4069080"/>
-            <a:ext cx="1005840" cy="502920"/>
+            <a:off x="1645920" y="5349240"/>
+            <a:ext cx="1280160" cy="548640"/>
           </a:xfrm>
           <a:prstGeom prst="roundRect">
             <a:avLst/>
@@ -6298,11 +6308,11 @@
               </a:defRPr>
             </a:pPr>
             <a:r>
-              <a:t>Filtered</a:t>
+              <a:t>Cold start</a:t>
             </a:r>
             <a:br/>
             <a:r>
-              <a:t>search</a:t>
+              <a:t>PG → Redis</a:t>
             </a:r>
           </a:p>
         </p:txBody>
@@ -6315,8 +6325,8 @@
         </p:nvSpPr>
         <p:spPr>
           <a:xfrm>
-            <a:off x="3749039" y="5532120"/>
-            <a:ext cx="1005840" cy="502920"/>
+            <a:off x="3200400" y="5349240"/>
+            <a:ext cx="1280160" cy="548640"/>
           </a:xfrm>
           <a:prstGeom prst="roundRect">
             <a:avLst/>
@@ -6356,11 +6366,11 @@
               </a:defRPr>
             </a:pPr>
             <a:r>
-              <a:t>Cold start</a:t>
+              <a:t>Product</a:t>
             </a:r>
             <a:br/>
             <a:r>
-              <a:t>PG → Redis</a:t>
+              <a:t>boosts</a:t>
             </a:r>
           </a:p>
         </p:txBody>
@@ -6373,8 +6383,8 @@
         </p:nvSpPr>
         <p:spPr>
           <a:xfrm>
-            <a:off x="5029200" y="5532120"/>
-            <a:ext cx="1005840" cy="502920"/>
+            <a:off x="4754880" y="5349240"/>
+            <a:ext cx="1280160" cy="548640"/>
           </a:xfrm>
           <a:prstGeom prst="roundRect">
             <a:avLst/>
@@ -6414,7 +6424,7 @@
               </a:defRPr>
             </a:pPr>
             <a:r>
-              <a:t>Product</a:t>
+              <a:t>Category</a:t>
             </a:r>
             <a:br/>
             <a:r>
@@ -6431,8 +6441,8 @@
         </p:nvSpPr>
         <p:spPr>
           <a:xfrm>
-            <a:off x="6309360" y="5532120"/>
-            <a:ext cx="1005840" cy="502920"/>
+            <a:off x="8961120" y="5349240"/>
+            <a:ext cx="1280160" cy="548640"/>
           </a:xfrm>
           <a:prstGeom prst="roundRect">
             <a:avLst/>
@@ -6472,118 +6482,85 @@
               </a:defRPr>
             </a:pPr>
             <a:r>
-              <a:t>Category</a:t>
+              <a:t>Track events</a:t>
             </a:r>
             <a:br/>
             <a:r>
-              <a:t>boosts</a:t>
-            </a:r>
-          </a:p>
-        </p:txBody>
-      </p:sp>
-      <p:sp>
-        <p:nvSpPr>
-          <p:cNvPr id="31" name="Rounded Rectangle 30"/>
-          <p:cNvSpPr/>
-          <p:nvPr/>
-        </p:nvSpPr>
-        <p:spPr>
-          <a:xfrm>
-            <a:off x="9601200" y="5532120"/>
-            <a:ext cx="1005840" cy="502920"/>
-          </a:xfrm>
-          <a:prstGeom prst="roundRect">
-            <a:avLst/>
-          </a:prstGeom>
-          <a:solidFill>
-            <a:srgbClr val="FFFFFF"/>
-          </a:solidFill>
+              <a:t>log + session</a:t>
+            </a:r>
+          </a:p>
+        </p:txBody>
+      </p:sp>
+      <p:cxnSp>
+        <p:nvCxnSpPr>
+          <p:cNvPr id="31" name="Connector 30"/>
+          <p:cNvCxnSpPr/>
+          <p:nvPr/>
+        </p:nvCxnSpPr>
+        <p:spPr>
+          <a:xfrm>
+            <a:off x="2011680" y="1508760.0"/>
+            <a:ext cx="1188720" cy="0.0"/>
+          </a:xfrm>
+          <a:prstGeom prst="line">
+            <a:avLst/>
+          </a:prstGeom>
           <a:ln w="19050">
             <a:solidFill>
-              <a:srgbClr val="BBBBBB"/>
+              <a:srgbClr val="888888"/>
             </a:solidFill>
           </a:ln>
         </p:spPr>
         <p:style>
-          <a:lnRef idx="1">
+          <a:lnRef idx="2">
             <a:schemeClr val="accent1"/>
           </a:lnRef>
-          <a:fillRef idx="3">
+          <a:fillRef idx="0">
             <a:schemeClr val="accent1"/>
           </a:fillRef>
-          <a:effectRef idx="2">
+          <a:effectRef idx="1">
             <a:schemeClr val="accent1"/>
           </a:effectRef>
           <a:fontRef idx="minor">
-            <a:schemeClr val="lt1"/>
+            <a:schemeClr val="tx1"/>
           </a:fontRef>
         </p:style>
-        <p:txBody>
-          <a:bodyPr rtlCol="0" anchor="ctr" wrap="square"/>
-          <a:lstStyle/>
-          <a:p>
-            <a:pPr algn="ctr">
-              <a:defRPr sz="800">
-                <a:solidFill>
-                  <a:srgbClr val="334059"/>
-                </a:solidFill>
-              </a:defRPr>
-            </a:pPr>
-            <a:r>
-              <a:t>Track event</a:t>
-            </a:r>
-            <a:br/>
-            <a:r>
-              <a:t>log</a:t>
-            </a:r>
-          </a:p>
-        </p:txBody>
-      </p:sp>
-      <p:sp>
-        <p:nvSpPr>
-          <p:cNvPr id="32" name="Oval 31"/>
-          <p:cNvSpPr/>
-          <p:nvPr/>
-        </p:nvSpPr>
-        <p:spPr>
-          <a:xfrm>
-            <a:off x="10835640" y="1234440"/>
-            <a:ext cx="411480" cy="411480"/>
-          </a:xfrm>
-          <a:prstGeom prst="ellipse">
-            <a:avLst/>
-          </a:prstGeom>
-          <a:solidFill>
-            <a:srgbClr val="E53935"/>
-          </a:solidFill>
-          <a:ln w="38100">
+      </p:cxnSp>
+      <p:cxnSp>
+        <p:nvCxnSpPr>
+          <p:cNvPr id="32" name="Connector 31"/>
+          <p:cNvCxnSpPr/>
+          <p:nvPr/>
+        </p:nvCxnSpPr>
+        <p:spPr>
+          <a:xfrm flipV="1">
+            <a:off x="10241280" y="1508760.0"/>
+            <a:ext cx="274320" cy="1371600.0"/>
+          </a:xfrm>
+          <a:prstGeom prst="line">
+            <a:avLst/>
+          </a:prstGeom>
+          <a:ln w="19050">
             <a:solidFill>
-              <a:srgbClr val="C62828"/>
+              <a:srgbClr val="888888"/>
             </a:solidFill>
           </a:ln>
         </p:spPr>
         <p:style>
-          <a:lnRef idx="1">
+          <a:lnRef idx="2">
             <a:schemeClr val="accent1"/>
           </a:lnRef>
-          <a:fillRef idx="3">
+          <a:fillRef idx="0">
             <a:schemeClr val="accent1"/>
           </a:fillRef>
-          <a:effectRef idx="2">
+          <a:effectRef idx="1">
             <a:schemeClr val="accent1"/>
           </a:effectRef>
           <a:fontRef idx="minor">
-            <a:schemeClr val="lt1"/>
+            <a:schemeClr val="tx1"/>
           </a:fontRef>
         </p:style>
-        <p:txBody>
-          <a:bodyPr rtlCol="0" anchor="ctr"/>
-          <a:lstStyle/>
-          <a:p>
-            <a:pPr algn="ctr"/>
-          </a:p>
-        </p:txBody>
-      </p:sp>
+      </p:cxnSp>
       <p:cxnSp>
         <p:nvCxnSpPr>
           <p:cNvPr id="33" name="Connector 32"/>
@@ -6592,15 +6569,15 @@
         </p:nvCxnSpPr>
         <p:spPr>
           <a:xfrm>
-            <a:off x="3063240" y="1645920"/>
-            <a:ext cx="0" cy="960120"/>
+            <a:off x="3840480.0" y="1783080.0"/>
+            <a:ext cx="0.0" cy="822960.0"/>
           </a:xfrm>
           <a:prstGeom prst="line">
             <a:avLst/>
           </a:prstGeom>
           <a:ln w="19050">
             <a:solidFill>
-              <a:srgbClr val="999999"/>
+              <a:srgbClr val="888888"/>
             </a:solidFill>
           </a:ln>
         </p:spPr>
@@ -6627,15 +6604,15 @@
         </p:nvCxnSpPr>
         <p:spPr>
           <a:xfrm>
-            <a:off x="7680960" y="3108960"/>
-            <a:ext cx="0" cy="960120"/>
+            <a:off x="2286000.0" y="1783080.0"/>
+            <a:ext cx="0.0" cy="822960.0"/>
           </a:xfrm>
           <a:prstGeom prst="line">
             <a:avLst/>
           </a:prstGeom>
           <a:ln w="19050">
             <a:solidFill>
-              <a:srgbClr val="999999"/>
+              <a:srgbClr val="888888"/>
             </a:solidFill>
           </a:ln>
         </p:spPr>
@@ -6662,15 +6639,15 @@
         </p:nvCxnSpPr>
         <p:spPr>
           <a:xfrm>
-            <a:off x="5029200" y="3108960"/>
-            <a:ext cx="0" cy="2423160"/>
+            <a:off x="2926080" y="2880360.0"/>
+            <a:ext cx="274320" cy="0.0"/>
           </a:xfrm>
           <a:prstGeom prst="line">
             <a:avLst/>
           </a:prstGeom>
           <a:ln w="19050">
             <a:solidFill>
-              <a:srgbClr val="999999"/>
+              <a:srgbClr val="888888"/>
             </a:solidFill>
           </a:ln>
         </p:spPr>
@@ -6697,15 +6674,15 @@
         </p:nvCxnSpPr>
         <p:spPr>
           <a:xfrm>
-            <a:off x="10104120" y="3108960"/>
-            <a:ext cx="0" cy="2194560"/>
+            <a:off x="4480560" y="2880360.0"/>
+            <a:ext cx="640080" cy="0.0"/>
           </a:xfrm>
           <a:prstGeom prst="line">
             <a:avLst/>
           </a:prstGeom>
           <a:ln w="19050">
             <a:solidFill>
-              <a:srgbClr val="999999"/>
+              <a:srgbClr val="888888"/>
             </a:solidFill>
           </a:ln>
         </p:spPr>
@@ -6731,16 +6708,16 @@
           <p:nvPr/>
         </p:nvCxnSpPr>
         <p:spPr>
-          <a:xfrm>
-            <a:off x="10104120" y="1417320"/>
-            <a:ext cx="731520" cy="0"/>
+          <a:xfrm flipV="1">
+            <a:off x="5623560" y="2560320.0"/>
+            <a:ext cx="228600" cy="182880.0"/>
           </a:xfrm>
           <a:prstGeom prst="line">
             <a:avLst/>
           </a:prstGeom>
           <a:ln w="19050">
             <a:solidFill>
-              <a:srgbClr val="999999"/>
+              <a:srgbClr val="888888"/>
             </a:solidFill>
           </a:ln>
         </p:spPr>
@@ -6767,15 +6744,15 @@
         </p:nvCxnSpPr>
         <p:spPr>
           <a:xfrm>
-            <a:off x="3749039" y="1417320"/>
-            <a:ext cx="0" cy="0"/>
+            <a:off x="5623560" y="3017520.0"/>
+            <a:ext cx="228600" cy="182880.0"/>
           </a:xfrm>
           <a:prstGeom prst="line">
             <a:avLst/>
           </a:prstGeom>
           <a:ln w="19050">
             <a:solidFill>
-              <a:srgbClr val="999999"/>
+              <a:srgbClr val="888888"/>
             </a:solidFill>
           </a:ln>
         </p:spPr>
@@ -6802,15 +6779,15 @@
         </p:nvCxnSpPr>
         <p:spPr>
           <a:xfrm>
-            <a:off x="3566160" y="2834640"/>
-            <a:ext cx="182879" cy="0"/>
+            <a:off x="7132320" y="2560320.0"/>
+            <a:ext cx="274320" cy="320040.0"/>
           </a:xfrm>
           <a:prstGeom prst="line">
             <a:avLst/>
           </a:prstGeom>
           <a:ln w="19050">
             <a:solidFill>
-              <a:srgbClr val="999999"/>
+              <a:srgbClr val="888888"/>
             </a:solidFill>
           </a:ln>
         </p:spPr>
@@ -6836,16 +6813,16 @@
           <p:nvPr/>
         </p:nvCxnSpPr>
         <p:spPr>
-          <a:xfrm>
-            <a:off x="4754880" y="2834640"/>
-            <a:ext cx="228600" cy="0"/>
+          <a:xfrm flipV="1">
+            <a:off x="7132320" y="2880360.0"/>
+            <a:ext cx="274320" cy="320040.0"/>
           </a:xfrm>
           <a:prstGeom prst="line">
             <a:avLst/>
           </a:prstGeom>
           <a:ln w="19050">
             <a:solidFill>
-              <a:srgbClr val="999999"/>
+              <a:srgbClr val="888888"/>
             </a:solidFill>
           </a:ln>
         </p:spPr>
@@ -6872,15 +6849,15 @@
         </p:nvCxnSpPr>
         <p:spPr>
           <a:xfrm>
-            <a:off x="5532120" y="2651760"/>
-            <a:ext cx="228600" cy="0"/>
+            <a:off x="8686800" y="2880360.0"/>
+            <a:ext cx="274320" cy="0.0"/>
           </a:xfrm>
           <a:prstGeom prst="line">
             <a:avLst/>
           </a:prstGeom>
           <a:ln w="19050">
             <a:solidFill>
-              <a:srgbClr val="999999"/>
+              <a:srgbClr val="888888"/>
             </a:solidFill>
           </a:ln>
         </p:spPr>
@@ -6907,15 +6884,15 @@
         </p:nvCxnSpPr>
         <p:spPr>
           <a:xfrm>
-            <a:off x="5532120" y="3200400"/>
-            <a:ext cx="228600" cy="0"/>
+            <a:off x="6492240.0" y="3474720.0"/>
+            <a:ext cx="0.0" cy="502920.0"/>
           </a:xfrm>
           <a:prstGeom prst="line">
             <a:avLst/>
           </a:prstGeom>
           <a:ln w="19050">
             <a:solidFill>
-              <a:srgbClr val="999999"/>
+              <a:srgbClr val="888888"/>
             </a:solidFill>
           </a:ln>
         </p:spPr>
@@ -6942,15 +6919,15 @@
         </p:nvCxnSpPr>
         <p:spPr>
           <a:xfrm>
-            <a:off x="6858000" y="2834640"/>
-            <a:ext cx="274320" cy="0"/>
+            <a:off x="8046720.0" y="3154680.0"/>
+            <a:ext cx="0.0" cy="822960.0"/>
           </a:xfrm>
           <a:prstGeom prst="line">
             <a:avLst/>
           </a:prstGeom>
           <a:ln w="19050">
             <a:solidFill>
-              <a:srgbClr val="999999"/>
+              <a:srgbClr val="888888"/>
             </a:solidFill>
           </a:ln>
         </p:spPr>
@@ -6977,15 +6954,15 @@
         </p:nvCxnSpPr>
         <p:spPr>
           <a:xfrm>
-            <a:off x="8229600" y="2834640"/>
-            <a:ext cx="182880" cy="0"/>
+            <a:off x="9601200.0" y="3154680.0"/>
+            <a:ext cx="0.0" cy="822960.0"/>
           </a:xfrm>
           <a:prstGeom prst="line">
             <a:avLst/>
           </a:prstGeom>
           <a:ln w="19050">
             <a:solidFill>
-              <a:srgbClr val="999999"/>
+              <a:srgbClr val="888888"/>
             </a:solidFill>
           </a:ln>
         </p:spPr>
@@ -7012,15 +6989,15 @@
         </p:nvCxnSpPr>
         <p:spPr>
           <a:xfrm>
-            <a:off x="9418320" y="2834640"/>
-            <a:ext cx="182880" cy="0"/>
+            <a:off x="7132320" y="4251960.0"/>
+            <a:ext cx="274320" cy="0.0"/>
           </a:xfrm>
           <a:prstGeom prst="line">
             <a:avLst/>
           </a:prstGeom>
           <a:ln w="19050">
             <a:solidFill>
-              <a:srgbClr val="999999"/>
+              <a:srgbClr val="888888"/>
             </a:solidFill>
           </a:ln>
         </p:spPr>
@@ -7047,15 +7024,15 @@
         </p:nvCxnSpPr>
         <p:spPr>
           <a:xfrm>
-            <a:off x="9418320" y="4297680"/>
-            <a:ext cx="182880" cy="0"/>
+            <a:off x="8686800" y="4251960.0"/>
+            <a:ext cx="274320" cy="0.0"/>
           </a:xfrm>
           <a:prstGeom prst="line">
             <a:avLst/>
           </a:prstGeom>
           <a:ln w="19050">
             <a:solidFill>
-              <a:srgbClr val="999999"/>
+              <a:srgbClr val="888888"/>
             </a:solidFill>
           </a:ln>
         </p:spPr>
@@ -7082,15 +7059,15 @@
         </p:nvCxnSpPr>
         <p:spPr>
           <a:xfrm>
-            <a:off x="8229600" y="4297680"/>
-            <a:ext cx="182880" cy="0"/>
+            <a:off x="2286000.0" y="3154680.0"/>
+            <a:ext cx="0.0" cy="2194560.0"/>
           </a:xfrm>
           <a:prstGeom prst="line">
             <a:avLst/>
           </a:prstGeom>
           <a:ln w="19050">
             <a:solidFill>
-              <a:srgbClr val="999999"/>
+              <a:srgbClr val="888888"/>
             </a:solidFill>
           </a:ln>
         </p:spPr>
@@ -7117,15 +7094,15 @@
         </p:nvCxnSpPr>
         <p:spPr>
           <a:xfrm>
-            <a:off x="7315200" y="5760720"/>
-            <a:ext cx="365760" cy="0"/>
+            <a:off x="9601200.0" y="3154680.0"/>
+            <a:ext cx="0.0" cy="2194560.0"/>
           </a:xfrm>
           <a:prstGeom prst="line">
             <a:avLst/>
           </a:prstGeom>
           <a:ln w="19050">
             <a:solidFill>
-              <a:srgbClr val="999999"/>
+              <a:srgbClr val="888888"/>
             </a:solidFill>
           </a:ln>
         </p:spPr>
@@ -7152,15 +7129,15 @@
         </p:nvCxnSpPr>
         <p:spPr>
           <a:xfrm>
-            <a:off x="5486400" y="5760720"/>
-            <a:ext cx="274320" cy="0"/>
+            <a:off x="2926080" y="5623560.0"/>
+            <a:ext cx="274320" cy="0.0"/>
           </a:xfrm>
           <a:prstGeom prst="line">
             <a:avLst/>
           </a:prstGeom>
           <a:ln w="19050">
             <a:solidFill>
-              <a:srgbClr val="999999"/>
+              <a:srgbClr val="888888"/>
             </a:solidFill>
           </a:ln>
         </p:spPr>
@@ -7179,6 +7156,111 @@
           </a:fontRef>
         </p:style>
       </p:cxnSp>
+      <p:cxnSp>
+        <p:nvCxnSpPr>
+          <p:cNvPr id="50" name="Connector 49"/>
+          <p:cNvCxnSpPr/>
+          <p:nvPr/>
+        </p:nvCxnSpPr>
+        <p:spPr>
+          <a:xfrm>
+            <a:off x="4480560" y="5623560.0"/>
+            <a:ext cx="274320" cy="0.0"/>
+          </a:xfrm>
+          <a:prstGeom prst="line">
+            <a:avLst/>
+          </a:prstGeom>
+          <a:ln w="19050">
+            <a:solidFill>
+              <a:srgbClr val="888888"/>
+            </a:solidFill>
+          </a:ln>
+        </p:spPr>
+        <p:style>
+          <a:lnRef idx="2">
+            <a:schemeClr val="accent1"/>
+          </a:lnRef>
+          <a:fillRef idx="0">
+            <a:schemeClr val="accent1"/>
+          </a:fillRef>
+          <a:effectRef idx="1">
+            <a:schemeClr val="accent1"/>
+          </a:effectRef>
+          <a:fontRef idx="minor">
+            <a:schemeClr val="tx1"/>
+          </a:fontRef>
+        </p:style>
+      </p:cxnSp>
+      <p:sp>
+        <p:nvSpPr>
+          <p:cNvPr id="51" name="TextBox 50"/>
+          <p:cNvSpPr txBox="1"/>
+          <p:nvPr/>
+        </p:nvSpPr>
+        <p:spPr>
+          <a:xfrm>
+            <a:off x="5257800" y="2103120"/>
+            <a:ext cx="457200" cy="182880"/>
+          </a:xfrm>
+          <a:prstGeom prst="rect">
+            <a:avLst/>
+          </a:prstGeom>
+          <a:noFill/>
+        </p:spPr>
+        <p:txBody>
+          <a:bodyPr wrap="square">
+            <a:spAutoFit/>
+          </a:bodyPr>
+          <a:lstStyle/>
+          <a:p>
+            <a:pPr algn="l">
+              <a:defRPr sz="700" b="1">
+                <a:solidFill>
+                  <a:srgbClr val="43A047"/>
+                </a:solidFill>
+              </a:defRPr>
+            </a:pPr>
+            <a:r>
+              <a:t>Да</a:t>
+            </a:r>
+          </a:p>
+        </p:txBody>
+      </p:sp>
+      <p:sp>
+        <p:nvSpPr>
+          <p:cNvPr id="52" name="TextBox 51"/>
+          <p:cNvSpPr txBox="1"/>
+          <p:nvPr/>
+        </p:nvSpPr>
+        <p:spPr>
+          <a:xfrm>
+            <a:off x="5257800" y="3246120"/>
+            <a:ext cx="457200" cy="182880"/>
+          </a:xfrm>
+          <a:prstGeom prst="rect">
+            <a:avLst/>
+          </a:prstGeom>
+          <a:noFill/>
+        </p:spPr>
+        <p:txBody>
+          <a:bodyPr wrap="square">
+            <a:spAutoFit/>
+          </a:bodyPr>
+          <a:lstStyle/>
+          <a:p>
+            <a:pPr algn="l">
+              <a:defRPr sz="700" b="1">
+                <a:solidFill>
+                  <a:srgbClr val="E53935"/>
+                </a:solidFill>
+              </a:defRPr>
+            </a:pPr>
+            <a:r>
+              <a:t>Нет</a:t>
+            </a:r>
+          </a:p>
+        </p:txBody>
+      </p:sp>
     </p:spTree>
   </p:cSld>
   <p:clrMapOvr>
@@ -11667,7 +11749,7 @@
           </a:prstGeom>
           <a:ln w="19050">
             <a:solidFill>
-              <a:srgbClr val="999999"/>
+              <a:srgbClr val="888888"/>
             </a:solidFill>
           </a:ln>
         </p:spPr>
@@ -11702,7 +11784,7 @@
           </a:prstGeom>
           <a:ln w="19050">
             <a:solidFill>
-              <a:srgbClr val="999999"/>
+              <a:srgbClr val="888888"/>
             </a:solidFill>
           </a:ln>
         </p:spPr>
@@ -11737,7 +11819,7 @@
           </a:prstGeom>
           <a:ln w="19050">
             <a:solidFill>
-              <a:srgbClr val="999999"/>
+              <a:srgbClr val="888888"/>
             </a:solidFill>
           </a:ln>
         </p:spPr>
@@ -11772,7 +11854,7 @@
           </a:prstGeom>
           <a:ln w="19050">
             <a:solidFill>
-              <a:srgbClr val="999999"/>
+              <a:srgbClr val="888888"/>
             </a:solidFill>
           </a:ln>
         </p:spPr>
@@ -11807,7 +11889,7 @@
           </a:prstGeom>
           <a:ln w="19050">
             <a:solidFill>
-              <a:srgbClr val="999999"/>
+              <a:srgbClr val="888888"/>
             </a:solidFill>
           </a:ln>
         </p:spPr>

</xml_diff>

<commit_message>
Negation detection + PPTX ranking signals slide + bolder fonts
Search:
- Detect "не X", "без X", "кроме X", "исключая X" → must_not
- Root-based exclusion on name.ngram (match_phrase_prefix) to handle
  stemmer inconsistencies (масляная vs маслянных)
- "рыбов не маслянных" → excludes "Рыба масляная", shows Судак, Путассу
- "перчатки кроме латексных" → only non-latex gloves

PPTX (slide 8 — new):
- Two-column layout: Positive signals (green) / Negative signals (red)
- 6 positive: subject match, phrase, history, cart/favorite, view, popularity
- 5 negative: negation, bounce, attribute-not-subject, decay, historical discount
- Full ranking formula at bottom

PPTX style fixes:
- Header bar thicker (0.12"), fonts 30pt (was 24)
- Stat cards: 36pt values (was 32), 13pt labels (was 11)
- Thicker accent bars on cards

Co-Authored-By: Claude Opus 4.6 (1M context) <noreply@anthropic.com>
</commit_message>
<xml_diff>
--- a/docs/TenderHack2026_Presentation.pptx
+++ b/docs/TenderHack2026_Presentation.pptx
@@ -14,6 +14,7 @@
     <p:sldId id="262" r:id="rId13"/>
     <p:sldId id="263" r:id="rId14"/>
     <p:sldId id="264" r:id="rId15"/>
+    <p:sldId id="265" r:id="rId16"/>
   </p:sldIdLst>
   <p:sldSz cx="12191695" cy="6858000" type="screen4x3"/>
   <p:notesSz cx="6858000" cy="9144000"/>
@@ -3373,6 +3374,573 @@
 </p:sld>
 </file>
 
+<file path=ppt/slides/slide10.xml><?xml version="1.0" encoding="utf-8"?>
+<p:sld xmlns:a="http://schemas.openxmlformats.org/drawingml/2006/main" xmlns:p="http://schemas.openxmlformats.org/presentationml/2006/main" xmlns:r="http://schemas.openxmlformats.org/officeDocument/2006/relationships">
+  <p:cSld>
+    <p:bg>
+      <p:bgPr>
+        <a:solidFill>
+          <a:srgbClr val="334059"/>
+        </a:solidFill>
+        <a:effectLst/>
+      </p:bgPr>
+    </p:bg>
+    <p:spTree>
+      <p:nvGrpSpPr>
+        <p:cNvPr id="1" name=""/>
+        <p:cNvGrpSpPr/>
+        <p:nvPr/>
+      </p:nvGrpSpPr>
+      <p:grpSpPr/>
+      <p:sp>
+        <p:nvSpPr>
+          <p:cNvPr id="2" name="Rectangle 1"/>
+          <p:cNvSpPr/>
+          <p:nvPr/>
+        </p:nvSpPr>
+        <p:spPr>
+          <a:xfrm>
+            <a:off x="0" y="0"/>
+            <a:ext cx="12191695" cy="109728"/>
+          </a:xfrm>
+          <a:prstGeom prst="rect">
+            <a:avLst/>
+          </a:prstGeom>
+          <a:solidFill>
+            <a:srgbClr val="E53935"/>
+          </a:solidFill>
+          <a:ln>
+            <a:noFill/>
+          </a:ln>
+        </p:spPr>
+        <p:style>
+          <a:lnRef idx="1">
+            <a:schemeClr val="accent1"/>
+          </a:lnRef>
+          <a:fillRef idx="3">
+            <a:schemeClr val="accent1"/>
+          </a:fillRef>
+          <a:effectRef idx="2">
+            <a:schemeClr val="accent1"/>
+          </a:effectRef>
+          <a:fontRef idx="minor">
+            <a:schemeClr val="lt1"/>
+          </a:fontRef>
+        </p:style>
+        <p:txBody>
+          <a:bodyPr rtlCol="0" anchor="ctr"/>
+          <a:lstStyle/>
+          <a:p>
+            <a:pPr algn="ctr"/>
+          </a:p>
+        </p:txBody>
+      </p:sp>
+      <p:sp>
+        <p:nvSpPr>
+          <p:cNvPr id="3" name="TextBox 2"/>
+          <p:cNvSpPr txBox="1"/>
+          <p:nvPr/>
+        </p:nvSpPr>
+        <p:spPr>
+          <a:xfrm>
+            <a:off x="1371600" y="1371600"/>
+            <a:ext cx="9144000" cy="731520"/>
+          </a:xfrm>
+          <a:prstGeom prst="rect">
+            <a:avLst/>
+          </a:prstGeom>
+          <a:noFill/>
+        </p:spPr>
+        <p:txBody>
+          <a:bodyPr wrap="square">
+            <a:spAutoFit/>
+          </a:bodyPr>
+          <a:lstStyle/>
+          <a:p>
+            <a:pPr algn="l">
+              <a:defRPr sz="4800" b="1">
+                <a:solidFill>
+                  <a:srgbClr val="FFFFFF"/>
+                </a:solidFill>
+              </a:defRPr>
+            </a:pPr>
+            <a:r>
+              <a:t>СПАСИБО</a:t>
+            </a:r>
+          </a:p>
+        </p:txBody>
+      </p:sp>
+      <p:sp>
+        <p:nvSpPr>
+          <p:cNvPr id="4" name="Rectangle 3"/>
+          <p:cNvSpPr/>
+          <p:nvPr/>
+        </p:nvSpPr>
+        <p:spPr>
+          <a:xfrm>
+            <a:off x="1371600" y="2377440"/>
+            <a:ext cx="2743200" cy="36576"/>
+          </a:xfrm>
+          <a:prstGeom prst="rect">
+            <a:avLst/>
+          </a:prstGeom>
+          <a:solidFill>
+            <a:srgbClr val="E53935"/>
+          </a:solidFill>
+          <a:ln>
+            <a:noFill/>
+          </a:ln>
+        </p:spPr>
+        <p:style>
+          <a:lnRef idx="1">
+            <a:schemeClr val="accent1"/>
+          </a:lnRef>
+          <a:fillRef idx="3">
+            <a:schemeClr val="accent1"/>
+          </a:fillRef>
+          <a:effectRef idx="2">
+            <a:schemeClr val="accent1"/>
+          </a:effectRef>
+          <a:fontRef idx="minor">
+            <a:schemeClr val="lt1"/>
+          </a:fontRef>
+        </p:style>
+        <p:txBody>
+          <a:bodyPr rtlCol="0" anchor="ctr"/>
+          <a:lstStyle/>
+          <a:p>
+            <a:pPr algn="ctr"/>
+          </a:p>
+        </p:txBody>
+      </p:sp>
+      <p:sp>
+        <p:nvSpPr>
+          <p:cNvPr id="5" name="TextBox 4"/>
+          <p:cNvSpPr txBox="1"/>
+          <p:nvPr/>
+        </p:nvSpPr>
+        <p:spPr>
+          <a:xfrm>
+            <a:off x="1371600" y="2926080"/>
+            <a:ext cx="1828800" cy="365760"/>
+          </a:xfrm>
+          <a:prstGeom prst="rect">
+            <a:avLst/>
+          </a:prstGeom>
+          <a:noFill/>
+        </p:spPr>
+        <p:txBody>
+          <a:bodyPr wrap="square">
+            <a:spAutoFit/>
+          </a:bodyPr>
+          <a:lstStyle/>
+          <a:p>
+            <a:pPr algn="l">
+              <a:defRPr sz="1600" b="0">
+                <a:solidFill>
+                  <a:srgbClr val="999999"/>
+                </a:solidFill>
+              </a:defRPr>
+            </a:pPr>
+            <a:r>
+              <a:t>Демо:</a:t>
+            </a:r>
+          </a:p>
+        </p:txBody>
+      </p:sp>
+      <p:sp>
+        <p:nvSpPr>
+          <p:cNvPr id="6" name="TextBox 5"/>
+          <p:cNvSpPr txBox="1"/>
+          <p:nvPr/>
+        </p:nvSpPr>
+        <p:spPr>
+          <a:xfrm>
+            <a:off x="3200400" y="2926080"/>
+            <a:ext cx="7315200" cy="365760"/>
+          </a:xfrm>
+          <a:prstGeom prst="rect">
+            <a:avLst/>
+          </a:prstGeom>
+          <a:noFill/>
+        </p:spPr>
+        <p:txBody>
+          <a:bodyPr wrap="square">
+            <a:spAutoFit/>
+          </a:bodyPr>
+          <a:lstStyle/>
+          <a:p>
+            <a:pPr algn="l">
+              <a:defRPr sz="1600" b="1">
+                <a:solidFill>
+                  <a:srgbClr val="1976D2"/>
+                </a:solidFill>
+              </a:defRPr>
+            </a:pPr>
+            <a:r>
+              <a:t>tenderhack.extra.moscow</a:t>
+            </a:r>
+          </a:p>
+        </p:txBody>
+      </p:sp>
+      <p:sp>
+        <p:nvSpPr>
+          <p:cNvPr id="7" name="TextBox 6"/>
+          <p:cNvSpPr txBox="1"/>
+          <p:nvPr/>
+        </p:nvSpPr>
+        <p:spPr>
+          <a:xfrm>
+            <a:off x="1371600" y="3429000"/>
+            <a:ext cx="1828800" cy="365760"/>
+          </a:xfrm>
+          <a:prstGeom prst="rect">
+            <a:avLst/>
+          </a:prstGeom>
+          <a:noFill/>
+        </p:spPr>
+        <p:txBody>
+          <a:bodyPr wrap="square">
+            <a:spAutoFit/>
+          </a:bodyPr>
+          <a:lstStyle/>
+          <a:p>
+            <a:pPr algn="l">
+              <a:defRPr sz="1600" b="0">
+                <a:solidFill>
+                  <a:srgbClr val="999999"/>
+                </a:solidFill>
+              </a:defRPr>
+            </a:pPr>
+            <a:r>
+              <a:t>SonarQube:</a:t>
+            </a:r>
+          </a:p>
+        </p:txBody>
+      </p:sp>
+      <p:sp>
+        <p:nvSpPr>
+          <p:cNvPr id="8" name="TextBox 7"/>
+          <p:cNvSpPr txBox="1"/>
+          <p:nvPr/>
+        </p:nvSpPr>
+        <p:spPr>
+          <a:xfrm>
+            <a:off x="3200400" y="3429000"/>
+            <a:ext cx="7315200" cy="365760"/>
+          </a:xfrm>
+          <a:prstGeom prst="rect">
+            <a:avLst/>
+          </a:prstGeom>
+          <a:noFill/>
+        </p:spPr>
+        <p:txBody>
+          <a:bodyPr wrap="square">
+            <a:spAutoFit/>
+          </a:bodyPr>
+          <a:lstStyle/>
+          <a:p>
+            <a:pPr algn="l">
+              <a:defRPr sz="1600" b="1">
+                <a:solidFill>
+                  <a:srgbClr val="1976D2"/>
+                </a:solidFill>
+              </a:defRPr>
+            </a:pPr>
+            <a:r>
+              <a:t>tenderhack.extra.moscow/sonar/</a:t>
+            </a:r>
+          </a:p>
+        </p:txBody>
+      </p:sp>
+      <p:sp>
+        <p:nvSpPr>
+          <p:cNvPr id="9" name="TextBox 8"/>
+          <p:cNvSpPr txBox="1"/>
+          <p:nvPr/>
+        </p:nvSpPr>
+        <p:spPr>
+          <a:xfrm>
+            <a:off x="1371600" y="3931920"/>
+            <a:ext cx="1828800" cy="365760"/>
+          </a:xfrm>
+          <a:prstGeom prst="rect">
+            <a:avLst/>
+          </a:prstGeom>
+          <a:noFill/>
+        </p:spPr>
+        <p:txBody>
+          <a:bodyPr wrap="square">
+            <a:spAutoFit/>
+          </a:bodyPr>
+          <a:lstStyle/>
+          <a:p>
+            <a:pPr algn="l">
+              <a:defRPr sz="1600" b="0">
+                <a:solidFill>
+                  <a:srgbClr val="999999"/>
+                </a:solidFill>
+              </a:defRPr>
+            </a:pPr>
+            <a:r>
+              <a:t>GitHub:</a:t>
+            </a:r>
+          </a:p>
+        </p:txBody>
+      </p:sp>
+      <p:sp>
+        <p:nvSpPr>
+          <p:cNvPr id="10" name="TextBox 9"/>
+          <p:cNvSpPr txBox="1"/>
+          <p:nvPr/>
+        </p:nvSpPr>
+        <p:spPr>
+          <a:xfrm>
+            <a:off x="3200400" y="3931920"/>
+            <a:ext cx="7315200" cy="365760"/>
+          </a:xfrm>
+          <a:prstGeom prst="rect">
+            <a:avLst/>
+          </a:prstGeom>
+          <a:noFill/>
+        </p:spPr>
+        <p:txBody>
+          <a:bodyPr wrap="square">
+            <a:spAutoFit/>
+          </a:bodyPr>
+          <a:lstStyle/>
+          <a:p>
+            <a:pPr algn="l">
+              <a:defRPr sz="1600" b="1">
+                <a:solidFill>
+                  <a:srgbClr val="1976D2"/>
+                </a:solidFill>
+              </a:defRPr>
+            </a:pPr>
+            <a:r>
+              <a:t>github.com/Shadowru/tenderhack2026</a:t>
+            </a:r>
+          </a:p>
+        </p:txBody>
+      </p:sp>
+      <p:sp>
+        <p:nvSpPr>
+          <p:cNvPr id="11" name="TextBox 10"/>
+          <p:cNvSpPr txBox="1"/>
+          <p:nvPr/>
+        </p:nvSpPr>
+        <p:spPr>
+          <a:xfrm>
+            <a:off x="1371600" y="5029200"/>
+            <a:ext cx="2286000" cy="365760"/>
+          </a:xfrm>
+          <a:prstGeom prst="rect">
+            <a:avLst/>
+          </a:prstGeom>
+          <a:noFill/>
+        </p:spPr>
+        <p:txBody>
+          <a:bodyPr wrap="square">
+            <a:spAutoFit/>
+          </a:bodyPr>
+          <a:lstStyle/>
+          <a:p>
+            <a:pPr algn="ctr">
+              <a:defRPr sz="1400" b="0">
+                <a:solidFill>
+                  <a:srgbClr val="999999"/>
+                </a:solidFill>
+              </a:defRPr>
+            </a:pPr>
+            <a:r>
+              <a:t>537K товаров</a:t>
+            </a:r>
+          </a:p>
+        </p:txBody>
+      </p:sp>
+      <p:sp>
+        <p:nvSpPr>
+          <p:cNvPr id="12" name="TextBox 11"/>
+          <p:cNvSpPr txBox="1"/>
+          <p:nvPr/>
+        </p:nvSpPr>
+        <p:spPr>
+          <a:xfrm>
+            <a:off x="3657600" y="5029200"/>
+            <a:ext cx="2286000" cy="365760"/>
+          </a:xfrm>
+          <a:prstGeom prst="rect">
+            <a:avLst/>
+          </a:prstGeom>
+          <a:noFill/>
+        </p:spPr>
+        <p:txBody>
+          <a:bodyPr wrap="square">
+            <a:spAutoFit/>
+          </a:bodyPr>
+          <a:lstStyle/>
+          <a:p>
+            <a:pPr algn="ctr">
+              <a:defRPr sz="1400" b="0">
+                <a:solidFill>
+                  <a:srgbClr val="999999"/>
+                </a:solidFill>
+              </a:defRPr>
+            </a:pPr>
+            <a:r>
+              <a:t>2M контрактов</a:t>
+            </a:r>
+          </a:p>
+        </p:txBody>
+      </p:sp>
+      <p:sp>
+        <p:nvSpPr>
+          <p:cNvPr id="13" name="TextBox 12"/>
+          <p:cNvSpPr txBox="1"/>
+          <p:nvPr/>
+        </p:nvSpPr>
+        <p:spPr>
+          <a:xfrm>
+            <a:off x="5943600" y="5029200"/>
+            <a:ext cx="2286000" cy="365760"/>
+          </a:xfrm>
+          <a:prstGeom prst="rect">
+            <a:avLst/>
+          </a:prstGeom>
+          <a:noFill/>
+        </p:spPr>
+        <p:txBody>
+          <a:bodyPr wrap="square">
+            <a:spAutoFit/>
+          </a:bodyPr>
+          <a:lstStyle/>
+          <a:p>
+            <a:pPr algn="ctr">
+              <a:defRPr sz="1400" b="0">
+                <a:solidFill>
+                  <a:srgbClr val="999999"/>
+                </a:solidFill>
+              </a:defRPr>
+            </a:pPr>
+            <a:r>
+              <a:t>4190 профилей</a:t>
+            </a:r>
+          </a:p>
+        </p:txBody>
+      </p:sp>
+      <p:sp>
+        <p:nvSpPr>
+          <p:cNvPr id="14" name="TextBox 13"/>
+          <p:cNvSpPr txBox="1"/>
+          <p:nvPr/>
+        </p:nvSpPr>
+        <p:spPr>
+          <a:xfrm>
+            <a:off x="8229600" y="5029200"/>
+            <a:ext cx="2286000" cy="365760"/>
+          </a:xfrm>
+          <a:prstGeom prst="rect">
+            <a:avLst/>
+          </a:prstGeom>
+          <a:noFill/>
+        </p:spPr>
+        <p:txBody>
+          <a:bodyPr wrap="square">
+            <a:spAutoFit/>
+          </a:bodyPr>
+          <a:lstStyle/>
+          <a:p>
+            <a:pPr algn="ctr">
+              <a:defRPr sz="1400" b="0">
+                <a:solidFill>
+                  <a:srgbClr val="999999"/>
+                </a:solidFill>
+              </a:defRPr>
+            </a:pPr>
+            <a:r>
+              <a:t>93% качество</a:t>
+            </a:r>
+          </a:p>
+        </p:txBody>
+      </p:sp>
+      <p:sp>
+        <p:nvSpPr>
+          <p:cNvPr id="15" name="TextBox 14"/>
+          <p:cNvSpPr txBox="1"/>
+          <p:nvPr/>
+        </p:nvSpPr>
+        <p:spPr>
+          <a:xfrm>
+            <a:off x="10058400" y="5029200"/>
+            <a:ext cx="2286000" cy="365760"/>
+          </a:xfrm>
+          <a:prstGeom prst="rect">
+            <a:avLst/>
+          </a:prstGeom>
+          <a:noFill/>
+        </p:spPr>
+        <p:txBody>
+          <a:bodyPr wrap="square">
+            <a:spAutoFit/>
+          </a:bodyPr>
+          <a:lstStyle/>
+          <a:p>
+            <a:pPr algn="ctr">
+              <a:defRPr sz="1400" b="0">
+                <a:solidFill>
+                  <a:srgbClr val="999999"/>
+                </a:solidFill>
+              </a:defRPr>
+            </a:pPr>
+            <a:r>
+              <a:t>30мс ответ</a:t>
+            </a:r>
+          </a:p>
+        </p:txBody>
+      </p:sp>
+      <p:sp>
+        <p:nvSpPr>
+          <p:cNvPr id="16" name="TextBox 15"/>
+          <p:cNvSpPr txBox="1"/>
+          <p:nvPr/>
+        </p:nvSpPr>
+        <p:spPr>
+          <a:xfrm>
+            <a:off x="1371600" y="5760720"/>
+            <a:ext cx="9144000" cy="365760"/>
+          </a:xfrm>
+          <a:prstGeom prst="rect">
+            <a:avLst/>
+          </a:prstGeom>
+          <a:noFill/>
+        </p:spPr>
+        <p:txBody>
+          <a:bodyPr wrap="square">
+            <a:spAutoFit/>
+          </a:bodyPr>
+          <a:lstStyle/>
+          <a:p>
+            <a:pPr algn="l">
+              <a:defRPr sz="1400" b="0">
+                <a:solidFill>
+                  <a:srgbClr val="999999"/>
+                </a:solidFill>
+              </a:defRPr>
+            </a:pPr>
+            <a:r>
+              <a:t>TenderHack 2026</a:t>
+            </a:r>
+          </a:p>
+        </p:txBody>
+      </p:sp>
+    </p:spTree>
+  </p:cSld>
+  <p:clrMapOvr>
+    <a:masterClrMapping/>
+  </p:clrMapOvr>
+</p:sld>
+</file>
+
 <file path=ppt/slides/slide2.xml><?xml version="1.0" encoding="utf-8"?>
 <p:sld xmlns:a="http://schemas.openxmlformats.org/drawingml/2006/main" xmlns:p="http://schemas.openxmlformats.org/presentationml/2006/main" xmlns:r="http://schemas.openxmlformats.org/officeDocument/2006/relationships">
   <p:cSld>
@@ -3400,7 +3968,7 @@
         <p:spPr>
           <a:xfrm>
             <a:off x="0" y="0"/>
-            <a:ext cx="12191695" cy="73152"/>
+            <a:ext cx="12191695" cy="109728"/>
           </a:xfrm>
           <a:prstGeom prst="rect">
             <a:avLst/>
@@ -3443,7 +4011,7 @@
         <p:spPr>
           <a:xfrm>
             <a:off x="731520" y="274320"/>
-            <a:ext cx="914400" cy="365760"/>
+            <a:ext cx="914400" cy="457200"/>
           </a:xfrm>
           <a:prstGeom prst="rect">
             <a:avLst/>
@@ -3457,7 +4025,7 @@
           <a:lstStyle/>
           <a:p>
             <a:pPr algn="l">
-              <a:defRPr sz="1400" b="1">
+              <a:defRPr sz="1800" b="1">
                 <a:solidFill>
                   <a:srgbClr val="E53935"/>
                 </a:solidFill>
@@ -3477,8 +4045,8 @@
         </p:nvSpPr>
         <p:spPr>
           <a:xfrm>
-            <a:off x="1188720" y="228600"/>
-            <a:ext cx="9144000" cy="457200"/>
+            <a:off x="1280160" y="201168"/>
+            <a:ext cx="9144000" cy="548640"/>
           </a:xfrm>
           <a:prstGeom prst="rect">
             <a:avLst/>
@@ -3492,7 +4060,7 @@
           <a:lstStyle/>
           <a:p>
             <a:pPr algn="l">
-              <a:defRPr sz="2400" b="1">
+              <a:defRPr sz="3000" b="1">
                 <a:solidFill>
                   <a:srgbClr val="334059"/>
                 </a:solidFill>
@@ -3512,8 +4080,8 @@
         </p:nvSpPr>
         <p:spPr>
           <a:xfrm>
-            <a:off x="731520" y="685800"/>
-            <a:ext cx="10698480" cy="18288"/>
+            <a:off x="731520" y="777240"/>
+            <a:ext cx="10698480" cy="36576"/>
           </a:xfrm>
           <a:prstGeom prst="rect">
             <a:avLst/>
@@ -4149,7 +4717,7 @@
         <p:spPr>
           <a:xfrm>
             <a:off x="0" y="0"/>
-            <a:ext cx="12191695" cy="73152"/>
+            <a:ext cx="12191695" cy="109728"/>
           </a:xfrm>
           <a:prstGeom prst="rect">
             <a:avLst/>
@@ -4192,7 +4760,7 @@
         <p:spPr>
           <a:xfrm>
             <a:off x="731520" y="274320"/>
-            <a:ext cx="914400" cy="365760"/>
+            <a:ext cx="914400" cy="457200"/>
           </a:xfrm>
           <a:prstGeom prst="rect">
             <a:avLst/>
@@ -4206,7 +4774,7 @@
           <a:lstStyle/>
           <a:p>
             <a:pPr algn="l">
-              <a:defRPr sz="1400" b="1">
+              <a:defRPr sz="1800" b="1">
                 <a:solidFill>
                   <a:srgbClr val="E53935"/>
                 </a:solidFill>
@@ -4226,8 +4794,8 @@
         </p:nvSpPr>
         <p:spPr>
           <a:xfrm>
-            <a:off x="1188720" y="228600"/>
-            <a:ext cx="9144000" cy="457200"/>
+            <a:off x="1280160" y="201168"/>
+            <a:ext cx="9144000" cy="548640"/>
           </a:xfrm>
           <a:prstGeom prst="rect">
             <a:avLst/>
@@ -4241,7 +4809,7 @@
           <a:lstStyle/>
           <a:p>
             <a:pPr algn="l">
-              <a:defRPr sz="2400" b="1">
+              <a:defRPr sz="3000" b="1">
                 <a:solidFill>
                   <a:srgbClr val="334059"/>
                 </a:solidFill>
@@ -4261,8 +4829,8 @@
         </p:nvSpPr>
         <p:spPr>
           <a:xfrm>
-            <a:off x="731520" y="685800"/>
-            <a:ext cx="10698480" cy="18288"/>
+            <a:off x="731520" y="777240"/>
+            <a:ext cx="10698480" cy="36576"/>
           </a:xfrm>
           <a:prstGeom prst="rect">
             <a:avLst/>
@@ -5070,7 +5638,7 @@
         <p:spPr>
           <a:xfrm>
             <a:off x="0" y="0"/>
-            <a:ext cx="12191695" cy="73152"/>
+            <a:ext cx="12191695" cy="109728"/>
           </a:xfrm>
           <a:prstGeom prst="rect">
             <a:avLst/>
@@ -5113,7 +5681,7 @@
         <p:spPr>
           <a:xfrm>
             <a:off x="731520" y="274320"/>
-            <a:ext cx="914400" cy="365760"/>
+            <a:ext cx="914400" cy="457200"/>
           </a:xfrm>
           <a:prstGeom prst="rect">
             <a:avLst/>
@@ -5127,7 +5695,7 @@
           <a:lstStyle/>
           <a:p>
             <a:pPr algn="l">
-              <a:defRPr sz="1400" b="1">
+              <a:defRPr sz="1800" b="1">
                 <a:solidFill>
                   <a:srgbClr val="E53935"/>
                 </a:solidFill>
@@ -5147,8 +5715,8 @@
         </p:nvSpPr>
         <p:spPr>
           <a:xfrm>
-            <a:off x="1188720" y="228600"/>
-            <a:ext cx="9144000" cy="457200"/>
+            <a:off x="1280160" y="201168"/>
+            <a:ext cx="9144000" cy="548640"/>
           </a:xfrm>
           <a:prstGeom prst="rect">
             <a:avLst/>
@@ -5162,7 +5730,7 @@
           <a:lstStyle/>
           <a:p>
             <a:pPr algn="l">
-              <a:defRPr sz="2400" b="1">
+              <a:defRPr sz="3000" b="1">
                 <a:solidFill>
                   <a:srgbClr val="334059"/>
                 </a:solidFill>
@@ -5182,8 +5750,8 @@
         </p:nvSpPr>
         <p:spPr>
           <a:xfrm>
-            <a:off x="731520" y="685800"/>
-            <a:ext cx="10698480" cy="18288"/>
+            <a:off x="731520" y="777240"/>
+            <a:ext cx="10698480" cy="36576"/>
           </a:xfrm>
           <a:prstGeom prst="rect">
             <a:avLst/>
@@ -7296,7 +7864,7 @@
         <p:spPr>
           <a:xfrm>
             <a:off x="0" y="0"/>
-            <a:ext cx="12191695" cy="73152"/>
+            <a:ext cx="12191695" cy="109728"/>
           </a:xfrm>
           <a:prstGeom prst="rect">
             <a:avLst/>
@@ -7339,7 +7907,7 @@
         <p:spPr>
           <a:xfrm>
             <a:off x="731520" y="274320"/>
-            <a:ext cx="914400" cy="365760"/>
+            <a:ext cx="914400" cy="457200"/>
           </a:xfrm>
           <a:prstGeom prst="rect">
             <a:avLst/>
@@ -7353,7 +7921,7 @@
           <a:lstStyle/>
           <a:p>
             <a:pPr algn="l">
-              <a:defRPr sz="1400" b="1">
+              <a:defRPr sz="1800" b="1">
                 <a:solidFill>
                   <a:srgbClr val="E53935"/>
                 </a:solidFill>
@@ -7373,8 +7941,8 @@
         </p:nvSpPr>
         <p:spPr>
           <a:xfrm>
-            <a:off x="1188720" y="228600"/>
-            <a:ext cx="9144000" cy="457200"/>
+            <a:off x="1280160" y="201168"/>
+            <a:ext cx="9144000" cy="548640"/>
           </a:xfrm>
           <a:prstGeom prst="rect">
             <a:avLst/>
@@ -7388,7 +7956,7 @@
           <a:lstStyle/>
           <a:p>
             <a:pPr algn="l">
-              <a:defRPr sz="2400" b="1">
+              <a:defRPr sz="3000" b="1">
                 <a:solidFill>
                   <a:srgbClr val="334059"/>
                 </a:solidFill>
@@ -7408,8 +7976,8 @@
         </p:nvSpPr>
         <p:spPr>
           <a:xfrm>
-            <a:off x="731520" y="685800"/>
-            <a:ext cx="10698480" cy="18288"/>
+            <a:off x="731520" y="777240"/>
+            <a:ext cx="10698480" cy="36576"/>
           </a:xfrm>
           <a:prstGeom prst="rect">
             <a:avLst/>
@@ -8664,7 +9232,7 @@
         <p:spPr>
           <a:xfrm>
             <a:off x="0" y="0"/>
-            <a:ext cx="12191695" cy="73152"/>
+            <a:ext cx="12191695" cy="109728"/>
           </a:xfrm>
           <a:prstGeom prst="rect">
             <a:avLst/>
@@ -8707,7 +9275,7 @@
         <p:spPr>
           <a:xfrm>
             <a:off x="731520" y="274320"/>
-            <a:ext cx="914400" cy="365760"/>
+            <a:ext cx="914400" cy="457200"/>
           </a:xfrm>
           <a:prstGeom prst="rect">
             <a:avLst/>
@@ -8721,7 +9289,7 @@
           <a:lstStyle/>
           <a:p>
             <a:pPr algn="l">
-              <a:defRPr sz="1400" b="1">
+              <a:defRPr sz="1800" b="1">
                 <a:solidFill>
                   <a:srgbClr val="E53935"/>
                 </a:solidFill>
@@ -8741,8 +9309,8 @@
         </p:nvSpPr>
         <p:spPr>
           <a:xfrm>
-            <a:off x="1188720" y="228600"/>
-            <a:ext cx="9144000" cy="457200"/>
+            <a:off x="1280160" y="201168"/>
+            <a:ext cx="9144000" cy="548640"/>
           </a:xfrm>
           <a:prstGeom prst="rect">
             <a:avLst/>
@@ -8756,7 +9324,7 @@
           <a:lstStyle/>
           <a:p>
             <a:pPr algn="l">
-              <a:defRPr sz="2400" b="1">
+              <a:defRPr sz="3000" b="1">
                 <a:solidFill>
                   <a:srgbClr val="334059"/>
                 </a:solidFill>
@@ -8776,8 +9344,8 @@
         </p:nvSpPr>
         <p:spPr>
           <a:xfrm>
-            <a:off x="731520" y="685800"/>
-            <a:ext cx="10698480" cy="18288"/>
+            <a:off x="731520" y="777240"/>
+            <a:ext cx="10698480" cy="36576"/>
           </a:xfrm>
           <a:prstGeom prst="rect">
             <a:avLst/>
@@ -8820,7 +9388,7 @@
         <p:spPr>
           <a:xfrm>
             <a:off x="548640" y="1097280"/>
-            <a:ext cx="2194560" cy="1280160"/>
+            <a:ext cx="2194560" cy="1371600"/>
           </a:xfrm>
           <a:prstGeom prst="roundRect">
             <a:avLst/>
@@ -8830,7 +9398,7 @@
           </a:solidFill>
           <a:ln w="19050">
             <a:solidFill>
-              <a:srgbClr val="E0E0E0"/>
+              <a:srgbClr val="D0D0D0"/>
             </a:solidFill>
           </a:ln>
         </p:spPr>
@@ -8865,7 +9433,7 @@
         <p:spPr>
           <a:xfrm>
             <a:off x="566928" y="1115568"/>
-            <a:ext cx="2157984" cy="54864"/>
+            <a:ext cx="2157984" cy="91440"/>
           </a:xfrm>
           <a:prstGeom prst="rect">
             <a:avLst/>
@@ -8907,7 +9475,7 @@
         </p:nvSpPr>
         <p:spPr>
           <a:xfrm>
-            <a:off x="822960" y="1325880"/>
+            <a:off x="822960" y="1371600"/>
             <a:ext cx="1645920" cy="548640"/>
           </a:xfrm>
           <a:prstGeom prst="rect">
@@ -8922,7 +9490,7 @@
           <a:lstStyle/>
           <a:p>
             <a:pPr algn="ctr">
-              <a:defRPr sz="3200" b="1">
+              <a:defRPr sz="3600" b="1">
                 <a:solidFill>
                   <a:srgbClr val="334059"/>
                 </a:solidFill>
@@ -8942,7 +9510,7 @@
         </p:nvSpPr>
         <p:spPr>
           <a:xfrm>
-            <a:off x="731520" y="1874520"/>
+            <a:off x="731520" y="1965960"/>
             <a:ext cx="1828800" cy="365760"/>
           </a:xfrm>
           <a:prstGeom prst="rect">
@@ -8957,7 +9525,7 @@
           <a:lstStyle/>
           <a:p>
             <a:pPr algn="ctr">
-              <a:defRPr sz="1100" b="0">
+              <a:defRPr sz="1300" b="1">
                 <a:solidFill>
                   <a:srgbClr val="666666"/>
                 </a:solidFill>
@@ -8978,7 +9546,7 @@
         <p:spPr>
           <a:xfrm>
             <a:off x="3017520" y="1097280"/>
-            <a:ext cx="2194560" cy="1280160"/>
+            <a:ext cx="2194560" cy="1371600"/>
           </a:xfrm>
           <a:prstGeom prst="roundRect">
             <a:avLst/>
@@ -8988,7 +9556,7 @@
           </a:solidFill>
           <a:ln w="19050">
             <a:solidFill>
-              <a:srgbClr val="E0E0E0"/>
+              <a:srgbClr val="D0D0D0"/>
             </a:solidFill>
           </a:ln>
         </p:spPr>
@@ -9023,7 +9591,7 @@
         <p:spPr>
           <a:xfrm>
             <a:off x="3035808" y="1115568"/>
-            <a:ext cx="2157984" cy="54864"/>
+            <a:ext cx="2157984" cy="91440"/>
           </a:xfrm>
           <a:prstGeom prst="rect">
             <a:avLst/>
@@ -9065,7 +9633,7 @@
         </p:nvSpPr>
         <p:spPr>
           <a:xfrm>
-            <a:off x="3291840" y="1325880"/>
+            <a:off x="3291840" y="1371600"/>
             <a:ext cx="1645920" cy="548640"/>
           </a:xfrm>
           <a:prstGeom prst="rect">
@@ -9080,7 +9648,7 @@
           <a:lstStyle/>
           <a:p>
             <a:pPr algn="ctr">
-              <a:defRPr sz="3200" b="1">
+              <a:defRPr sz="3600" b="1">
                 <a:solidFill>
                   <a:srgbClr val="334059"/>
                 </a:solidFill>
@@ -9100,7 +9668,7 @@
         </p:nvSpPr>
         <p:spPr>
           <a:xfrm>
-            <a:off x="3200400" y="1874520"/>
+            <a:off x="3200400" y="1965960"/>
             <a:ext cx="1828800" cy="365760"/>
           </a:xfrm>
           <a:prstGeom prst="rect">
@@ -9115,7 +9683,7 @@
           <a:lstStyle/>
           <a:p>
             <a:pPr algn="ctr">
-              <a:defRPr sz="1100" b="0">
+              <a:defRPr sz="1300" b="1">
                 <a:solidFill>
                   <a:srgbClr val="666666"/>
                 </a:solidFill>
@@ -9136,7 +9704,7 @@
         <p:spPr>
           <a:xfrm>
             <a:off x="5486400" y="1097280"/>
-            <a:ext cx="2194560" cy="1280160"/>
+            <a:ext cx="2194560" cy="1371600"/>
           </a:xfrm>
           <a:prstGeom prst="roundRect">
             <a:avLst/>
@@ -9146,7 +9714,7 @@
           </a:solidFill>
           <a:ln w="19050">
             <a:solidFill>
-              <a:srgbClr val="E0E0E0"/>
+              <a:srgbClr val="D0D0D0"/>
             </a:solidFill>
           </a:ln>
         </p:spPr>
@@ -9181,7 +9749,7 @@
         <p:spPr>
           <a:xfrm>
             <a:off x="5504688" y="1115568"/>
-            <a:ext cx="2157984" cy="54864"/>
+            <a:ext cx="2157984" cy="91440"/>
           </a:xfrm>
           <a:prstGeom prst="rect">
             <a:avLst/>
@@ -9223,7 +9791,7 @@
         </p:nvSpPr>
         <p:spPr>
           <a:xfrm>
-            <a:off x="5760720" y="1325880"/>
+            <a:off x="5760720" y="1371600"/>
             <a:ext cx="1645920" cy="548640"/>
           </a:xfrm>
           <a:prstGeom prst="rect">
@@ -9238,7 +9806,7 @@
           <a:lstStyle/>
           <a:p>
             <a:pPr algn="ctr">
-              <a:defRPr sz="3200" b="1">
+              <a:defRPr sz="3600" b="1">
                 <a:solidFill>
                   <a:srgbClr val="334059"/>
                 </a:solidFill>
@@ -9258,7 +9826,7 @@
         </p:nvSpPr>
         <p:spPr>
           <a:xfrm>
-            <a:off x="5669280" y="1874520"/>
+            <a:off x="5669280" y="1965960"/>
             <a:ext cx="1828800" cy="365760"/>
           </a:xfrm>
           <a:prstGeom prst="rect">
@@ -9273,7 +9841,7 @@
           <a:lstStyle/>
           <a:p>
             <a:pPr algn="ctr">
-              <a:defRPr sz="1100" b="0">
+              <a:defRPr sz="1300" b="1">
                 <a:solidFill>
                   <a:srgbClr val="666666"/>
                 </a:solidFill>
@@ -9294,7 +9862,7 @@
         <p:spPr>
           <a:xfrm>
             <a:off x="7955279" y="1097280"/>
-            <a:ext cx="2194560" cy="1280160"/>
+            <a:ext cx="2194560" cy="1371600"/>
           </a:xfrm>
           <a:prstGeom prst="roundRect">
             <a:avLst/>
@@ -9304,7 +9872,7 @@
           </a:solidFill>
           <a:ln w="19050">
             <a:solidFill>
-              <a:srgbClr val="E0E0E0"/>
+              <a:srgbClr val="D0D0D0"/>
             </a:solidFill>
           </a:ln>
         </p:spPr>
@@ -9339,7 +9907,7 @@
         <p:spPr>
           <a:xfrm>
             <a:off x="7973567" y="1115568"/>
-            <a:ext cx="2157984" cy="54864"/>
+            <a:ext cx="2157984" cy="91440"/>
           </a:xfrm>
           <a:prstGeom prst="rect">
             <a:avLst/>
@@ -9381,7 +9949,7 @@
         </p:nvSpPr>
         <p:spPr>
           <a:xfrm>
-            <a:off x="8229599" y="1325880"/>
+            <a:off x="8229599" y="1371600"/>
             <a:ext cx="1645920" cy="548640"/>
           </a:xfrm>
           <a:prstGeom prst="rect">
@@ -9396,7 +9964,7 @@
           <a:lstStyle/>
           <a:p>
             <a:pPr algn="ctr">
-              <a:defRPr sz="3200" b="1">
+              <a:defRPr sz="3600" b="1">
                 <a:solidFill>
                   <a:srgbClr val="334059"/>
                 </a:solidFill>
@@ -9416,7 +9984,7 @@
         </p:nvSpPr>
         <p:spPr>
           <a:xfrm>
-            <a:off x="8138159" y="1874520"/>
+            <a:off x="8138159" y="1965960"/>
             <a:ext cx="1828800" cy="365760"/>
           </a:xfrm>
           <a:prstGeom prst="rect">
@@ -9431,7 +9999,7 @@
           <a:lstStyle/>
           <a:p>
             <a:pPr algn="ctr">
-              <a:defRPr sz="1100" b="0">
+              <a:defRPr sz="1300" b="1">
                 <a:solidFill>
                   <a:srgbClr val="666666"/>
                 </a:solidFill>
@@ -9452,7 +10020,7 @@
         <p:spPr>
           <a:xfrm>
             <a:off x="10424160" y="1097280"/>
-            <a:ext cx="2194560" cy="1280160"/>
+            <a:ext cx="2194560" cy="1371600"/>
           </a:xfrm>
           <a:prstGeom prst="roundRect">
             <a:avLst/>
@@ -9462,7 +10030,7 @@
           </a:solidFill>
           <a:ln w="19050">
             <a:solidFill>
-              <a:srgbClr val="E0E0E0"/>
+              <a:srgbClr val="D0D0D0"/>
             </a:solidFill>
           </a:ln>
         </p:spPr>
@@ -9497,7 +10065,7 @@
         <p:spPr>
           <a:xfrm>
             <a:off x="10442448" y="1115568"/>
-            <a:ext cx="2157984" cy="54864"/>
+            <a:ext cx="2157984" cy="91440"/>
           </a:xfrm>
           <a:prstGeom prst="rect">
             <a:avLst/>
@@ -9539,7 +10107,7 @@
         </p:nvSpPr>
         <p:spPr>
           <a:xfrm>
-            <a:off x="10698480" y="1325880"/>
+            <a:off x="10698480" y="1371600"/>
             <a:ext cx="1645920" cy="548640"/>
           </a:xfrm>
           <a:prstGeom prst="rect">
@@ -9554,7 +10122,7 @@
           <a:lstStyle/>
           <a:p>
             <a:pPr algn="ctr">
-              <a:defRPr sz="3200" b="1">
+              <a:defRPr sz="3600" b="1">
                 <a:solidFill>
                   <a:srgbClr val="334059"/>
                 </a:solidFill>
@@ -9574,7 +10142,7 @@
         </p:nvSpPr>
         <p:spPr>
           <a:xfrm>
-            <a:off x="10607040" y="1874520"/>
+            <a:off x="10607040" y="1965960"/>
             <a:ext cx="1828800" cy="365760"/>
           </a:xfrm>
           <a:prstGeom prst="rect">
@@ -9589,7 +10157,7 @@
           <a:lstStyle/>
           <a:p>
             <a:pPr algn="ctr">
-              <a:defRPr sz="1100" b="0">
+              <a:defRPr sz="1300" b="1">
                 <a:solidFill>
                   <a:srgbClr val="666666"/>
                 </a:solidFill>
@@ -10559,7 +11127,7 @@
         <p:spPr>
           <a:xfrm>
             <a:off x="0" y="0"/>
-            <a:ext cx="12191695" cy="73152"/>
+            <a:ext cx="12191695" cy="109728"/>
           </a:xfrm>
           <a:prstGeom prst="rect">
             <a:avLst/>
@@ -10602,7 +11170,7 @@
         <p:spPr>
           <a:xfrm>
             <a:off x="731520" y="274320"/>
-            <a:ext cx="914400" cy="365760"/>
+            <a:ext cx="914400" cy="457200"/>
           </a:xfrm>
           <a:prstGeom prst="rect">
             <a:avLst/>
@@ -10616,7 +11184,7 @@
           <a:lstStyle/>
           <a:p>
             <a:pPr algn="l">
-              <a:defRPr sz="1400" b="1">
+              <a:defRPr sz="1800" b="1">
                 <a:solidFill>
                   <a:srgbClr val="E53935"/>
                 </a:solidFill>
@@ -10636,8 +11204,8 @@
         </p:nvSpPr>
         <p:spPr>
           <a:xfrm>
-            <a:off x="1188720" y="228600"/>
-            <a:ext cx="9144000" cy="457200"/>
+            <a:off x="1280160" y="201168"/>
+            <a:ext cx="9144000" cy="548640"/>
           </a:xfrm>
           <a:prstGeom prst="rect">
             <a:avLst/>
@@ -10651,7 +11219,7 @@
           <a:lstStyle/>
           <a:p>
             <a:pPr algn="l">
-              <a:defRPr sz="2400" b="1">
+              <a:defRPr sz="3000" b="1">
                 <a:solidFill>
                   <a:srgbClr val="334059"/>
                 </a:solidFill>
@@ -10671,8 +11239,8 @@
         </p:nvSpPr>
         <p:spPr>
           <a:xfrm>
-            <a:off x="731520" y="685800"/>
-            <a:ext cx="10698480" cy="18288"/>
+            <a:off x="731520" y="777240"/>
+            <a:ext cx="10698480" cy="36576"/>
           </a:xfrm>
           <a:prstGeom prst="rect">
             <a:avLst/>
@@ -11943,7 +12511,7 @@
         <p:spPr>
           <a:xfrm>
             <a:off x="0" y="0"/>
-            <a:ext cx="12191695" cy="73152"/>
+            <a:ext cx="12191695" cy="109728"/>
           </a:xfrm>
           <a:prstGeom prst="rect">
             <a:avLst/>
@@ -11986,7 +12554,7 @@
         <p:spPr>
           <a:xfrm>
             <a:off x="731520" y="274320"/>
-            <a:ext cx="914400" cy="365760"/>
+            <a:ext cx="914400" cy="457200"/>
           </a:xfrm>
           <a:prstGeom prst="rect">
             <a:avLst/>
@@ -12000,7 +12568,7 @@
           <a:lstStyle/>
           <a:p>
             <a:pPr algn="l">
-              <a:defRPr sz="1400" b="1">
+              <a:defRPr sz="1800" b="1">
                 <a:solidFill>
                   <a:srgbClr val="E53935"/>
                 </a:solidFill>
@@ -12020,8 +12588,8 @@
         </p:nvSpPr>
         <p:spPr>
           <a:xfrm>
-            <a:off x="1188720" y="228600"/>
-            <a:ext cx="9144000" cy="457200"/>
+            <a:off x="1280160" y="201168"/>
+            <a:ext cx="9144000" cy="548640"/>
           </a:xfrm>
           <a:prstGeom prst="rect">
             <a:avLst/>
@@ -12035,7 +12603,7 @@
           <a:lstStyle/>
           <a:p>
             <a:pPr algn="l">
-              <a:defRPr sz="2400" b="1">
+              <a:defRPr sz="3000" b="1">
                 <a:solidFill>
                   <a:srgbClr val="334059"/>
                 </a:solidFill>
@@ -12055,8 +12623,8 @@
         </p:nvSpPr>
         <p:spPr>
           <a:xfrm>
-            <a:off x="731520" y="685800"/>
-            <a:ext cx="10698480" cy="18288"/>
+            <a:off x="731520" y="777240"/>
+            <a:ext cx="10698480" cy="36576"/>
           </a:xfrm>
           <a:prstGeom prst="rect">
             <a:avLst/>
@@ -12714,7 +13282,7 @@
     <p:bg>
       <p:bgPr>
         <a:solidFill>
-          <a:srgbClr val="334059"/>
+          <a:srgbClr val="FFFFFF"/>
         </a:solidFill>
         <a:effectLst/>
       </p:bgPr>
@@ -12777,8 +13345,8 @@
         </p:nvSpPr>
         <p:spPr>
           <a:xfrm>
-            <a:off x="1371600" y="1371600"/>
-            <a:ext cx="9144000" cy="731520"/>
+            <a:off x="731520" y="274320"/>
+            <a:ext cx="914400" cy="457200"/>
           </a:xfrm>
           <a:prstGeom prst="rect">
             <a:avLst/>
@@ -12792,28 +13360,1107 @@
           <a:lstStyle/>
           <a:p>
             <a:pPr algn="l">
-              <a:defRPr sz="4800" b="1">
-                <a:solidFill>
-                  <a:srgbClr val="FFFFFF"/>
-                </a:solidFill>
-              </a:defRPr>
-            </a:pPr>
-            <a:r>
-              <a:t>СПАСИБО</a:t>
-            </a:r>
-          </a:p>
-        </p:txBody>
-      </p:sp>
-      <p:sp>
-        <p:nvSpPr>
-          <p:cNvPr id="4" name="Rectangle 3"/>
+              <a:defRPr sz="1800" b="1">
+                <a:solidFill>
+                  <a:srgbClr val="E53935"/>
+                </a:solidFill>
+              </a:defRPr>
+            </a:pPr>
+            <a:r>
+              <a:t>08</a:t>
+            </a:r>
+          </a:p>
+        </p:txBody>
+      </p:sp>
+      <p:sp>
+        <p:nvSpPr>
+          <p:cNvPr id="4" name="TextBox 3"/>
+          <p:cNvSpPr txBox="1"/>
+          <p:nvPr/>
+        </p:nvSpPr>
+        <p:spPr>
+          <a:xfrm>
+            <a:off x="1280160" y="201168"/>
+            <a:ext cx="9144000" cy="548640"/>
+          </a:xfrm>
+          <a:prstGeom prst="rect">
+            <a:avLst/>
+          </a:prstGeom>
+          <a:noFill/>
+        </p:spPr>
+        <p:txBody>
+          <a:bodyPr wrap="square">
+            <a:spAutoFit/>
+          </a:bodyPr>
+          <a:lstStyle/>
+          <a:p>
+            <a:pPr algn="l">
+              <a:defRPr sz="3000" b="1">
+                <a:solidFill>
+                  <a:srgbClr val="334059"/>
+                </a:solidFill>
+              </a:defRPr>
+            </a:pPr>
+            <a:r>
+              <a:t>СИГНАЛЫ РАНЖИРОВАНИЯ</a:t>
+            </a:r>
+          </a:p>
+        </p:txBody>
+      </p:sp>
+      <p:sp>
+        <p:nvSpPr>
+          <p:cNvPr id="5" name="Rectangle 4"/>
           <p:cNvSpPr/>
           <p:nvPr/>
         </p:nvSpPr>
         <p:spPr>
           <a:xfrm>
-            <a:off x="1371600" y="2377440"/>
-            <a:ext cx="2743200" cy="36576"/>
+            <a:off x="731520" y="777240"/>
+            <a:ext cx="10698480" cy="36576"/>
+          </a:xfrm>
+          <a:prstGeom prst="rect">
+            <a:avLst/>
+          </a:prstGeom>
+          <a:solidFill>
+            <a:srgbClr val="E0E0E0"/>
+          </a:solidFill>
+          <a:ln>
+            <a:noFill/>
+          </a:ln>
+        </p:spPr>
+        <p:style>
+          <a:lnRef idx="1">
+            <a:schemeClr val="accent1"/>
+          </a:lnRef>
+          <a:fillRef idx="3">
+            <a:schemeClr val="accent1"/>
+          </a:fillRef>
+          <a:effectRef idx="2">
+            <a:schemeClr val="accent1"/>
+          </a:effectRef>
+          <a:fontRef idx="minor">
+            <a:schemeClr val="lt1"/>
+          </a:fontRef>
+        </p:style>
+        <p:txBody>
+          <a:bodyPr rtlCol="0" anchor="ctr"/>
+          <a:lstStyle/>
+          <a:p>
+            <a:pPr algn="ctr"/>
+          </a:p>
+        </p:txBody>
+      </p:sp>
+      <p:sp>
+        <p:nvSpPr>
+          <p:cNvPr id="6" name="TextBox 5"/>
+          <p:cNvSpPr txBox="1"/>
+          <p:nvPr/>
+        </p:nvSpPr>
+        <p:spPr>
+          <a:xfrm>
+            <a:off x="731520" y="1097280"/>
+            <a:ext cx="5029200" cy="457200"/>
+          </a:xfrm>
+          <a:prstGeom prst="rect">
+            <a:avLst/>
+          </a:prstGeom>
+          <a:noFill/>
+        </p:spPr>
+        <p:txBody>
+          <a:bodyPr wrap="square">
+            <a:spAutoFit/>
+          </a:bodyPr>
+          <a:lstStyle/>
+          <a:p>
+            <a:pPr algn="l">
+              <a:defRPr sz="2000" b="1">
+                <a:solidFill>
+                  <a:srgbClr val="43A047"/>
+                </a:solidFill>
+              </a:defRPr>
+            </a:pPr>
+            <a:r>
+              <a:t>ПОЗИТИВНЫЕ (повышают позицию)</a:t>
+            </a:r>
+          </a:p>
+        </p:txBody>
+      </p:sp>
+      <p:sp>
+        <p:nvSpPr>
+          <p:cNvPr id="7" name="Rectangle 6"/>
+          <p:cNvSpPr/>
+          <p:nvPr/>
+        </p:nvSpPr>
+        <p:spPr>
+          <a:xfrm>
+            <a:off x="731520" y="1554480"/>
+            <a:ext cx="5029200" cy="45720"/>
+          </a:xfrm>
+          <a:prstGeom prst="rect">
+            <a:avLst/>
+          </a:prstGeom>
+          <a:solidFill>
+            <a:srgbClr val="43A047"/>
+          </a:solidFill>
+          <a:ln>
+            <a:noFill/>
+          </a:ln>
+        </p:spPr>
+        <p:style>
+          <a:lnRef idx="1">
+            <a:schemeClr val="accent1"/>
+          </a:lnRef>
+          <a:fillRef idx="3">
+            <a:schemeClr val="accent1"/>
+          </a:fillRef>
+          <a:effectRef idx="2">
+            <a:schemeClr val="accent1"/>
+          </a:effectRef>
+          <a:fontRef idx="minor">
+            <a:schemeClr val="lt1"/>
+          </a:fontRef>
+        </p:style>
+        <p:txBody>
+          <a:bodyPr rtlCol="0" anchor="ctr"/>
+          <a:lstStyle/>
+          <a:p>
+            <a:pPr algn="ctr"/>
+          </a:p>
+        </p:txBody>
+      </p:sp>
+      <p:sp>
+        <p:nvSpPr>
+          <p:cNvPr id="8" name="Rectangle 7"/>
+          <p:cNvSpPr/>
+          <p:nvPr/>
+        </p:nvSpPr>
+        <p:spPr>
+          <a:xfrm>
+            <a:off x="731520" y="1783080"/>
+            <a:ext cx="5029200" cy="548640"/>
+          </a:xfrm>
+          <a:prstGeom prst="rect">
+            <a:avLst/>
+          </a:prstGeom>
+          <a:solidFill>
+            <a:srgbClr val="F5F5F5"/>
+          </a:solidFill>
+          <a:ln>
+            <a:noFill/>
+          </a:ln>
+        </p:spPr>
+        <p:style>
+          <a:lnRef idx="1">
+            <a:schemeClr val="accent1"/>
+          </a:lnRef>
+          <a:fillRef idx="3">
+            <a:schemeClr val="accent1"/>
+          </a:fillRef>
+          <a:effectRef idx="2">
+            <a:schemeClr val="accent1"/>
+          </a:effectRef>
+          <a:fontRef idx="minor">
+            <a:schemeClr val="lt1"/>
+          </a:fontRef>
+        </p:style>
+        <p:txBody>
+          <a:bodyPr rtlCol="0" anchor="ctr"/>
+          <a:lstStyle/>
+          <a:p>
+            <a:pPr algn="ctr"/>
+          </a:p>
+        </p:txBody>
+      </p:sp>
+      <p:sp>
+        <p:nvSpPr>
+          <p:cNvPr id="9" name="TextBox 8"/>
+          <p:cNvSpPr txBox="1"/>
+          <p:nvPr/>
+        </p:nvSpPr>
+        <p:spPr>
+          <a:xfrm>
+            <a:off x="914400" y="1828800"/>
+            <a:ext cx="3200400" cy="228600"/>
+          </a:xfrm>
+          <a:prstGeom prst="rect">
+            <a:avLst/>
+          </a:prstGeom>
+          <a:noFill/>
+        </p:spPr>
+        <p:txBody>
+          <a:bodyPr wrap="square">
+            <a:spAutoFit/>
+          </a:bodyPr>
+          <a:lstStyle/>
+          <a:p>
+            <a:pPr algn="l">
+              <a:defRPr sz="1300" b="1">
+                <a:solidFill>
+                  <a:srgbClr val="334059"/>
+                </a:solidFill>
+              </a:defRPr>
+            </a:pPr>
+            <a:r>
+              <a:t>Совпадение с предметом товара</a:t>
+            </a:r>
+          </a:p>
+        </p:txBody>
+      </p:sp>
+      <p:sp>
+        <p:nvSpPr>
+          <p:cNvPr id="10" name="TextBox 9"/>
+          <p:cNvSpPr txBox="1"/>
+          <p:nvPr/>
+        </p:nvSpPr>
+        <p:spPr>
+          <a:xfrm>
+            <a:off x="914400" y="2057400"/>
+            <a:ext cx="3657600" cy="228600"/>
+          </a:xfrm>
+          <a:prstGeom prst="rect">
+            <a:avLst/>
+          </a:prstGeom>
+          <a:noFill/>
+        </p:spPr>
+        <p:txBody>
+          <a:bodyPr wrap="square">
+            <a:spAutoFit/>
+          </a:bodyPr>
+          <a:lstStyle/>
+          <a:p>
+            <a:pPr algn="l">
+              <a:defRPr sz="1000" b="0">
+                <a:solidFill>
+                  <a:srgbClr val="666666"/>
+                </a:solidFill>
+              </a:defRPr>
+            </a:pPr>
+            <a:r>
+              <a:t>Subject extraction: поиск «ручка» → товары где ручка = предмет</a:t>
+            </a:r>
+          </a:p>
+        </p:txBody>
+      </p:sp>
+      <p:sp>
+        <p:nvSpPr>
+          <p:cNvPr id="11" name="TextBox 10"/>
+          <p:cNvSpPr txBox="1"/>
+          <p:nvPr/>
+        </p:nvSpPr>
+        <p:spPr>
+          <a:xfrm>
+            <a:off x="4754880" y="1874520"/>
+            <a:ext cx="914400" cy="320040"/>
+          </a:xfrm>
+          <a:prstGeom prst="rect">
+            <a:avLst/>
+          </a:prstGeom>
+          <a:noFill/>
+        </p:spPr>
+        <p:txBody>
+          <a:bodyPr wrap="square">
+            <a:spAutoFit/>
+          </a:bodyPr>
+          <a:lstStyle/>
+          <a:p>
+            <a:pPr algn="r">
+              <a:defRPr sz="1400" b="1">
+                <a:solidFill>
+                  <a:srgbClr val="43A047"/>
+                </a:solidFill>
+              </a:defRPr>
+            </a:pPr>
+            <a:r>
+              <a:t>x5</a:t>
+            </a:r>
+          </a:p>
+        </p:txBody>
+      </p:sp>
+      <p:sp>
+        <p:nvSpPr>
+          <p:cNvPr id="12" name="Rectangle 11"/>
+          <p:cNvSpPr/>
+          <p:nvPr/>
+        </p:nvSpPr>
+        <p:spPr>
+          <a:xfrm>
+            <a:off x="731520" y="2423160"/>
+            <a:ext cx="5029200" cy="548640"/>
+          </a:xfrm>
+          <a:prstGeom prst="rect">
+            <a:avLst/>
+          </a:prstGeom>
+          <a:solidFill>
+            <a:srgbClr val="FFFFFF"/>
+          </a:solidFill>
+          <a:ln>
+            <a:noFill/>
+          </a:ln>
+        </p:spPr>
+        <p:style>
+          <a:lnRef idx="1">
+            <a:schemeClr val="accent1"/>
+          </a:lnRef>
+          <a:fillRef idx="3">
+            <a:schemeClr val="accent1"/>
+          </a:fillRef>
+          <a:effectRef idx="2">
+            <a:schemeClr val="accent1"/>
+          </a:effectRef>
+          <a:fontRef idx="minor">
+            <a:schemeClr val="lt1"/>
+          </a:fontRef>
+        </p:style>
+        <p:txBody>
+          <a:bodyPr rtlCol="0" anchor="ctr"/>
+          <a:lstStyle/>
+          <a:p>
+            <a:pPr algn="ctr"/>
+          </a:p>
+        </p:txBody>
+      </p:sp>
+      <p:sp>
+        <p:nvSpPr>
+          <p:cNvPr id="13" name="TextBox 12"/>
+          <p:cNvSpPr txBox="1"/>
+          <p:nvPr/>
+        </p:nvSpPr>
+        <p:spPr>
+          <a:xfrm>
+            <a:off x="914400" y="2468880"/>
+            <a:ext cx="3200400" cy="228600"/>
+          </a:xfrm>
+          <a:prstGeom prst="rect">
+            <a:avLst/>
+          </a:prstGeom>
+          <a:noFill/>
+        </p:spPr>
+        <p:txBody>
+          <a:bodyPr wrap="square">
+            <a:spAutoFit/>
+          </a:bodyPr>
+          <a:lstStyle/>
+          <a:p>
+            <a:pPr algn="l">
+              <a:defRPr sz="1300" b="1">
+                <a:solidFill>
+                  <a:srgbClr val="334059"/>
+                </a:solidFill>
+              </a:defRPr>
+            </a:pPr>
+            <a:r>
+              <a:t>Точная фраза в названии</a:t>
+            </a:r>
+          </a:p>
+        </p:txBody>
+      </p:sp>
+      <p:sp>
+        <p:nvSpPr>
+          <p:cNvPr id="14" name="TextBox 13"/>
+          <p:cNvSpPr txBox="1"/>
+          <p:nvPr/>
+        </p:nvSpPr>
+        <p:spPr>
+          <a:xfrm>
+            <a:off x="914400" y="2697480"/>
+            <a:ext cx="3657600" cy="228600"/>
+          </a:xfrm>
+          <a:prstGeom prst="rect">
+            <a:avLst/>
+          </a:prstGeom>
+          <a:noFill/>
+        </p:spPr>
+        <p:txBody>
+          <a:bodyPr wrap="square">
+            <a:spAutoFit/>
+          </a:bodyPr>
+          <a:lstStyle/>
+          <a:p>
+            <a:pPr algn="l">
+              <a:defRPr sz="1000" b="0">
+                <a:solidFill>
+                  <a:srgbClr val="666666"/>
+                </a:solidFill>
+              </a:defRPr>
+            </a:pPr>
+            <a:r>
+              <a:t>match_phrase slop:1 — «100 листов» выше «500 листов»</a:t>
+            </a:r>
+          </a:p>
+        </p:txBody>
+      </p:sp>
+      <p:sp>
+        <p:nvSpPr>
+          <p:cNvPr id="15" name="TextBox 14"/>
+          <p:cNvSpPr txBox="1"/>
+          <p:nvPr/>
+        </p:nvSpPr>
+        <p:spPr>
+          <a:xfrm>
+            <a:off x="4754880" y="2514600"/>
+            <a:ext cx="914400" cy="320040"/>
+          </a:xfrm>
+          <a:prstGeom prst="rect">
+            <a:avLst/>
+          </a:prstGeom>
+          <a:noFill/>
+        </p:spPr>
+        <p:txBody>
+          <a:bodyPr wrap="square">
+            <a:spAutoFit/>
+          </a:bodyPr>
+          <a:lstStyle/>
+          <a:p>
+            <a:pPr algn="r">
+              <a:defRPr sz="1400" b="1">
+                <a:solidFill>
+                  <a:srgbClr val="43A047"/>
+                </a:solidFill>
+              </a:defRPr>
+            </a:pPr>
+            <a:r>
+              <a:t>x20</a:t>
+            </a:r>
+          </a:p>
+        </p:txBody>
+      </p:sp>
+      <p:sp>
+        <p:nvSpPr>
+          <p:cNvPr id="16" name="Rectangle 15"/>
+          <p:cNvSpPr/>
+          <p:nvPr/>
+        </p:nvSpPr>
+        <p:spPr>
+          <a:xfrm>
+            <a:off x="731520" y="3063239"/>
+            <a:ext cx="5029200" cy="548640"/>
+          </a:xfrm>
+          <a:prstGeom prst="rect">
+            <a:avLst/>
+          </a:prstGeom>
+          <a:solidFill>
+            <a:srgbClr val="F5F5F5"/>
+          </a:solidFill>
+          <a:ln>
+            <a:noFill/>
+          </a:ln>
+        </p:spPr>
+        <p:style>
+          <a:lnRef idx="1">
+            <a:schemeClr val="accent1"/>
+          </a:lnRef>
+          <a:fillRef idx="3">
+            <a:schemeClr val="accent1"/>
+          </a:fillRef>
+          <a:effectRef idx="2">
+            <a:schemeClr val="accent1"/>
+          </a:effectRef>
+          <a:fontRef idx="minor">
+            <a:schemeClr val="lt1"/>
+          </a:fontRef>
+        </p:style>
+        <p:txBody>
+          <a:bodyPr rtlCol="0" anchor="ctr"/>
+          <a:lstStyle/>
+          <a:p>
+            <a:pPr algn="ctr"/>
+          </a:p>
+        </p:txBody>
+      </p:sp>
+      <p:sp>
+        <p:nvSpPr>
+          <p:cNvPr id="17" name="TextBox 16"/>
+          <p:cNvSpPr txBox="1"/>
+          <p:nvPr/>
+        </p:nvSpPr>
+        <p:spPr>
+          <a:xfrm>
+            <a:off x="914400" y="3108959"/>
+            <a:ext cx="3200400" cy="228600"/>
+          </a:xfrm>
+          <a:prstGeom prst="rect">
+            <a:avLst/>
+          </a:prstGeom>
+          <a:noFill/>
+        </p:spPr>
+        <p:txBody>
+          <a:bodyPr wrap="square">
+            <a:spAutoFit/>
+          </a:bodyPr>
+          <a:lstStyle/>
+          <a:p>
+            <a:pPr algn="l">
+              <a:defRPr sz="1300" b="1">
+                <a:solidFill>
+                  <a:srgbClr val="334059"/>
+                </a:solidFill>
+              </a:defRPr>
+            </a:pPr>
+            <a:r>
+              <a:t>История закупок организации</a:t>
+            </a:r>
+          </a:p>
+        </p:txBody>
+      </p:sp>
+      <p:sp>
+        <p:nvSpPr>
+          <p:cNvPr id="18" name="TextBox 17"/>
+          <p:cNvSpPr txBox="1"/>
+          <p:nvPr/>
+        </p:nvSpPr>
+        <p:spPr>
+          <a:xfrm>
+            <a:off x="914400" y="3337559"/>
+            <a:ext cx="3657600" cy="228600"/>
+          </a:xfrm>
+          <a:prstGeom prst="rect">
+            <a:avLst/>
+          </a:prstGeom>
+          <a:noFill/>
+        </p:spPr>
+        <p:txBody>
+          <a:bodyPr wrap="square">
+            <a:spAutoFit/>
+          </a:bodyPr>
+          <a:lstStyle/>
+          <a:p>
+            <a:pPr algn="l">
+              <a:defRPr sz="1000" b="0">
+                <a:solidFill>
+                  <a:srgbClr val="666666"/>
+                </a:solidFill>
+              </a:defRPr>
+            </a:pPr>
+            <a:r>
+              <a:t>Cold start из контрактов: школа → бланки, больница → офисная</a:t>
+            </a:r>
+          </a:p>
+        </p:txBody>
+      </p:sp>
+      <p:sp>
+        <p:nvSpPr>
+          <p:cNvPr id="19" name="TextBox 18"/>
+          <p:cNvSpPr txBox="1"/>
+          <p:nvPr/>
+        </p:nvSpPr>
+        <p:spPr>
+          <a:xfrm>
+            <a:off x="4754880" y="3154679"/>
+            <a:ext cx="914400" cy="320040"/>
+          </a:xfrm>
+          <a:prstGeom prst="rect">
+            <a:avLst/>
+          </a:prstGeom>
+          <a:noFill/>
+        </p:spPr>
+        <p:txBody>
+          <a:bodyPr wrap="square">
+            <a:spAutoFit/>
+          </a:bodyPr>
+          <a:lstStyle/>
+          <a:p>
+            <a:pPr algn="r">
+              <a:defRPr sz="1400" b="1">
+                <a:solidFill>
+                  <a:srgbClr val="43A047"/>
+                </a:solidFill>
+              </a:defRPr>
+            </a:pPr>
+            <a:r>
+              <a:t>x1.05</a:t>
+            </a:r>
+          </a:p>
+        </p:txBody>
+      </p:sp>
+      <p:sp>
+        <p:nvSpPr>
+          <p:cNvPr id="20" name="Rectangle 19"/>
+          <p:cNvSpPr/>
+          <p:nvPr/>
+        </p:nvSpPr>
+        <p:spPr>
+          <a:xfrm>
+            <a:off x="731520" y="3703320"/>
+            <a:ext cx="5029200" cy="548640"/>
+          </a:xfrm>
+          <a:prstGeom prst="rect">
+            <a:avLst/>
+          </a:prstGeom>
+          <a:solidFill>
+            <a:srgbClr val="FFFFFF"/>
+          </a:solidFill>
+          <a:ln>
+            <a:noFill/>
+          </a:ln>
+        </p:spPr>
+        <p:style>
+          <a:lnRef idx="1">
+            <a:schemeClr val="accent1"/>
+          </a:lnRef>
+          <a:fillRef idx="3">
+            <a:schemeClr val="accent1"/>
+          </a:fillRef>
+          <a:effectRef idx="2">
+            <a:schemeClr val="accent1"/>
+          </a:effectRef>
+          <a:fontRef idx="minor">
+            <a:schemeClr val="lt1"/>
+          </a:fontRef>
+        </p:style>
+        <p:txBody>
+          <a:bodyPr rtlCol="0" anchor="ctr"/>
+          <a:lstStyle/>
+          <a:p>
+            <a:pPr algn="ctr"/>
+          </a:p>
+        </p:txBody>
+      </p:sp>
+      <p:sp>
+        <p:nvSpPr>
+          <p:cNvPr id="21" name="TextBox 20"/>
+          <p:cNvSpPr txBox="1"/>
+          <p:nvPr/>
+        </p:nvSpPr>
+        <p:spPr>
+          <a:xfrm>
+            <a:off x="914400" y="3749040"/>
+            <a:ext cx="3200400" cy="228600"/>
+          </a:xfrm>
+          <a:prstGeom prst="rect">
+            <a:avLst/>
+          </a:prstGeom>
+          <a:noFill/>
+        </p:spPr>
+        <p:txBody>
+          <a:bodyPr wrap="square">
+            <a:spAutoFit/>
+          </a:bodyPr>
+          <a:lstStyle/>
+          <a:p>
+            <a:pPr algn="l">
+              <a:defRPr sz="1300" b="1">
+                <a:solidFill>
+                  <a:srgbClr val="334059"/>
+                </a:solidFill>
+              </a:defRPr>
+            </a:pPr>
+            <a:r>
+              <a:t>Добавлен в корзину / избранное</a:t>
+            </a:r>
+          </a:p>
+        </p:txBody>
+      </p:sp>
+      <p:sp>
+        <p:nvSpPr>
+          <p:cNvPr id="22" name="TextBox 21"/>
+          <p:cNvSpPr txBox="1"/>
+          <p:nvPr/>
+        </p:nvSpPr>
+        <p:spPr>
+          <a:xfrm>
+            <a:off x="914400" y="3977640"/>
+            <a:ext cx="3657600" cy="228600"/>
+          </a:xfrm>
+          <a:prstGeom prst="rect">
+            <a:avLst/>
+          </a:prstGeom>
+          <a:noFill/>
+        </p:spPr>
+        <p:txBody>
+          <a:bodyPr wrap="square">
+            <a:spAutoFit/>
+          </a:bodyPr>
+          <a:lstStyle/>
+          <a:p>
+            <a:pPr algn="l">
+              <a:defRPr sz="1000" b="0">
+                <a:solidFill>
+                  <a:srgbClr val="666666"/>
+                </a:solidFill>
+              </a:defRPr>
+            </a:pPr>
+            <a:r>
+              <a:t>Event cart (вес 5.0) → мгновенный product boost</a:t>
+            </a:r>
+          </a:p>
+        </p:txBody>
+      </p:sp>
+      <p:sp>
+        <p:nvSpPr>
+          <p:cNvPr id="23" name="TextBox 22"/>
+          <p:cNvSpPr txBox="1"/>
+          <p:nvPr/>
+        </p:nvSpPr>
+        <p:spPr>
+          <a:xfrm>
+            <a:off x="4754880" y="3794760"/>
+            <a:ext cx="914400" cy="320040"/>
+          </a:xfrm>
+          <a:prstGeom prst="rect">
+            <a:avLst/>
+          </a:prstGeom>
+          <a:noFill/>
+        </p:spPr>
+        <p:txBody>
+          <a:bodyPr wrap="square">
+            <a:spAutoFit/>
+          </a:bodyPr>
+          <a:lstStyle/>
+          <a:p>
+            <a:pPr algn="r">
+              <a:defRPr sz="1400" b="1">
+                <a:solidFill>
+                  <a:srgbClr val="43A047"/>
+                </a:solidFill>
+              </a:defRPr>
+            </a:pPr>
+            <a:r>
+              <a:t>x2.0</a:t>
+            </a:r>
+          </a:p>
+        </p:txBody>
+      </p:sp>
+      <p:sp>
+        <p:nvSpPr>
+          <p:cNvPr id="24" name="Rectangle 23"/>
+          <p:cNvSpPr/>
+          <p:nvPr/>
+        </p:nvSpPr>
+        <p:spPr>
+          <a:xfrm>
+            <a:off x="731520" y="4343400"/>
+            <a:ext cx="5029200" cy="548640"/>
+          </a:xfrm>
+          <a:prstGeom prst="rect">
+            <a:avLst/>
+          </a:prstGeom>
+          <a:solidFill>
+            <a:srgbClr val="F5F5F5"/>
+          </a:solidFill>
+          <a:ln>
+            <a:noFill/>
+          </a:ln>
+        </p:spPr>
+        <p:style>
+          <a:lnRef idx="1">
+            <a:schemeClr val="accent1"/>
+          </a:lnRef>
+          <a:fillRef idx="3">
+            <a:schemeClr val="accent1"/>
+          </a:fillRef>
+          <a:effectRef idx="2">
+            <a:schemeClr val="accent1"/>
+          </a:effectRef>
+          <a:fontRef idx="minor">
+            <a:schemeClr val="lt1"/>
+          </a:fontRef>
+        </p:style>
+        <p:txBody>
+          <a:bodyPr rtlCol="0" anchor="ctr"/>
+          <a:lstStyle/>
+          <a:p>
+            <a:pPr algn="ctr"/>
+          </a:p>
+        </p:txBody>
+      </p:sp>
+      <p:sp>
+        <p:nvSpPr>
+          <p:cNvPr id="25" name="TextBox 24"/>
+          <p:cNvSpPr txBox="1"/>
+          <p:nvPr/>
+        </p:nvSpPr>
+        <p:spPr>
+          <a:xfrm>
+            <a:off x="914400" y="4389120"/>
+            <a:ext cx="3200400" cy="228600"/>
+          </a:xfrm>
+          <a:prstGeom prst="rect">
+            <a:avLst/>
+          </a:prstGeom>
+          <a:noFill/>
+        </p:spPr>
+        <p:txBody>
+          <a:bodyPr wrap="square">
+            <a:spAutoFit/>
+          </a:bodyPr>
+          <a:lstStyle/>
+          <a:p>
+            <a:pPr algn="l">
+              <a:defRPr sz="1300" b="1">
+                <a:solidFill>
+                  <a:srgbClr val="334059"/>
+                </a:solidFill>
+              </a:defRPr>
+            </a:pPr>
+            <a:r>
+              <a:t>Просмотр карточки &gt; 3 сек</a:t>
+            </a:r>
+          </a:p>
+        </p:txBody>
+      </p:sp>
+      <p:sp>
+        <p:nvSpPr>
+          <p:cNvPr id="26" name="TextBox 25"/>
+          <p:cNvSpPr txBox="1"/>
+          <p:nvPr/>
+        </p:nvSpPr>
+        <p:spPr>
+          <a:xfrm>
+            <a:off x="914400" y="4617720"/>
+            <a:ext cx="3657600" cy="228600"/>
+          </a:xfrm>
+          <a:prstGeom prst="rect">
+            <a:avLst/>
+          </a:prstGeom>
+          <a:noFill/>
+        </p:spPr>
+        <p:txBody>
+          <a:bodyPr wrap="square">
+            <a:spAutoFit/>
+          </a:bodyPr>
+          <a:lstStyle/>
+          <a:p>
+            <a:pPr algn="l">
+              <a:defRPr sz="1000" b="0">
+                <a:solidFill>
+                  <a:srgbClr val="666666"/>
+                </a:solidFill>
+              </a:defRPr>
+            </a:pPr>
+            <a:r>
+              <a:t>Event view (вес 2.0) — заинтересовался, не bounce</a:t>
+            </a:r>
+          </a:p>
+        </p:txBody>
+      </p:sp>
+      <p:sp>
+        <p:nvSpPr>
+          <p:cNvPr id="27" name="TextBox 26"/>
+          <p:cNvSpPr txBox="1"/>
+          <p:nvPr/>
+        </p:nvSpPr>
+        <p:spPr>
+          <a:xfrm>
+            <a:off x="4754880" y="4434840"/>
+            <a:ext cx="914400" cy="320040"/>
+          </a:xfrm>
+          <a:prstGeom prst="rect">
+            <a:avLst/>
+          </a:prstGeom>
+          <a:noFill/>
+        </p:spPr>
+        <p:txBody>
+          <a:bodyPr wrap="square">
+            <a:spAutoFit/>
+          </a:bodyPr>
+          <a:lstStyle/>
+          <a:p>
+            <a:pPr algn="r">
+              <a:defRPr sz="1400" b="1">
+                <a:solidFill>
+                  <a:srgbClr val="43A047"/>
+                </a:solidFill>
+              </a:defRPr>
+            </a:pPr>
+            <a:r>
+              <a:t>x1.5</a:t>
+            </a:r>
+          </a:p>
+        </p:txBody>
+      </p:sp>
+      <p:sp>
+        <p:nvSpPr>
+          <p:cNvPr id="28" name="Rectangle 27"/>
+          <p:cNvSpPr/>
+          <p:nvPr/>
+        </p:nvSpPr>
+        <p:spPr>
+          <a:xfrm>
+            <a:off x="731520" y="4983480"/>
+            <a:ext cx="5029200" cy="548640"/>
+          </a:xfrm>
+          <a:prstGeom prst="rect">
+            <a:avLst/>
+          </a:prstGeom>
+          <a:solidFill>
+            <a:srgbClr val="FFFFFF"/>
+          </a:solidFill>
+          <a:ln>
+            <a:noFill/>
+          </a:ln>
+        </p:spPr>
+        <p:style>
+          <a:lnRef idx="1">
+            <a:schemeClr val="accent1"/>
+          </a:lnRef>
+          <a:fillRef idx="3">
+            <a:schemeClr val="accent1"/>
+          </a:fillRef>
+          <a:effectRef idx="2">
+            <a:schemeClr val="accent1"/>
+          </a:effectRef>
+          <a:fontRef idx="minor">
+            <a:schemeClr val="lt1"/>
+          </a:fontRef>
+        </p:style>
+        <p:txBody>
+          <a:bodyPr rtlCol="0" anchor="ctr"/>
+          <a:lstStyle/>
+          <a:p>
+            <a:pPr algn="ctr"/>
+          </a:p>
+        </p:txBody>
+      </p:sp>
+      <p:sp>
+        <p:nvSpPr>
+          <p:cNvPr id="29" name="TextBox 28"/>
+          <p:cNvSpPr txBox="1"/>
+          <p:nvPr/>
+        </p:nvSpPr>
+        <p:spPr>
+          <a:xfrm>
+            <a:off x="914400" y="5029200"/>
+            <a:ext cx="3200400" cy="228600"/>
+          </a:xfrm>
+          <a:prstGeom prst="rect">
+            <a:avLst/>
+          </a:prstGeom>
+          <a:noFill/>
+        </p:spPr>
+        <p:txBody>
+          <a:bodyPr wrap="square">
+            <a:spAutoFit/>
+          </a:bodyPr>
+          <a:lstStyle/>
+          <a:p>
+            <a:pPr algn="l">
+              <a:defRPr sz="1300" b="1">
+                <a:solidFill>
+                  <a:srgbClr val="334059"/>
+                </a:solidFill>
+              </a:defRPr>
+            </a:pPr>
+            <a:r>
+              <a:t>Популярность (кол-во контрактов)</a:t>
+            </a:r>
+          </a:p>
+        </p:txBody>
+      </p:sp>
+      <p:sp>
+        <p:nvSpPr>
+          <p:cNvPr id="30" name="TextBox 29"/>
+          <p:cNvSpPr txBox="1"/>
+          <p:nvPr/>
+        </p:nvSpPr>
+        <p:spPr>
+          <a:xfrm>
+            <a:off x="914400" y="5257800"/>
+            <a:ext cx="3657600" cy="228600"/>
+          </a:xfrm>
+          <a:prstGeom prst="rect">
+            <a:avLst/>
+          </a:prstGeom>
+          <a:noFill/>
+        </p:spPr>
+        <p:txBody>
+          <a:bodyPr wrap="square">
+            <a:spAutoFit/>
+          </a:bodyPr>
+          <a:lstStyle/>
+          <a:p>
+            <a:pPr algn="l">
+              <a:defRPr sz="1000" b="0">
+                <a:solidFill>
+                  <a:srgbClr val="666666"/>
+                </a:solidFill>
+              </a:defRPr>
+            </a:pPr>
+            <a:r>
+              <a:t>log2p(popularity) — мягкий множитель</a:t>
+            </a:r>
+          </a:p>
+        </p:txBody>
+      </p:sp>
+      <p:sp>
+        <p:nvSpPr>
+          <p:cNvPr id="31" name="TextBox 30"/>
+          <p:cNvSpPr txBox="1"/>
+          <p:nvPr/>
+        </p:nvSpPr>
+        <p:spPr>
+          <a:xfrm>
+            <a:off x="4754880" y="5074920"/>
+            <a:ext cx="914400" cy="320040"/>
+          </a:xfrm>
+          <a:prstGeom prst="rect">
+            <a:avLst/>
+          </a:prstGeom>
+          <a:noFill/>
+        </p:spPr>
+        <p:txBody>
+          <a:bodyPr wrap="square">
+            <a:spAutoFit/>
+          </a:bodyPr>
+          <a:lstStyle/>
+          <a:p>
+            <a:pPr algn="r">
+              <a:defRPr sz="1400" b="1">
+                <a:solidFill>
+                  <a:srgbClr val="43A047"/>
+                </a:solidFill>
+              </a:defRPr>
+            </a:pPr>
+            <a:r>
+              <a:t>x1-3</a:t>
+            </a:r>
+          </a:p>
+        </p:txBody>
+      </p:sp>
+      <p:sp>
+        <p:nvSpPr>
+          <p:cNvPr id="32" name="TextBox 31"/>
+          <p:cNvSpPr txBox="1"/>
+          <p:nvPr/>
+        </p:nvSpPr>
+        <p:spPr>
+          <a:xfrm>
+            <a:off x="6400800" y="1097280"/>
+            <a:ext cx="5029200" cy="457200"/>
+          </a:xfrm>
+          <a:prstGeom prst="rect">
+            <a:avLst/>
+          </a:prstGeom>
+          <a:noFill/>
+        </p:spPr>
+        <p:txBody>
+          <a:bodyPr wrap="square">
+            <a:spAutoFit/>
+          </a:bodyPr>
+          <a:lstStyle/>
+          <a:p>
+            <a:pPr algn="l">
+              <a:defRPr sz="2000" b="1">
+                <a:solidFill>
+                  <a:srgbClr val="E53935"/>
+                </a:solidFill>
+              </a:defRPr>
+            </a:pPr>
+            <a:r>
+              <a:t>НЕГАТИВНЫЕ (понижают / исключают)</a:t>
+            </a:r>
+          </a:p>
+        </p:txBody>
+      </p:sp>
+      <p:sp>
+        <p:nvSpPr>
+          <p:cNvPr id="33" name="Rectangle 32"/>
+          <p:cNvSpPr/>
+          <p:nvPr/>
+        </p:nvSpPr>
+        <p:spPr>
+          <a:xfrm>
+            <a:off x="6400800" y="1554480"/>
+            <a:ext cx="5029200" cy="45720"/>
           </a:xfrm>
           <a:prstGeom prst="rect">
             <a:avLst/>
@@ -12849,14 +14496,57 @@
       </p:sp>
       <p:sp>
         <p:nvSpPr>
-          <p:cNvPr id="5" name="TextBox 4"/>
-          <p:cNvSpPr txBox="1"/>
-          <p:nvPr/>
-        </p:nvSpPr>
-        <p:spPr>
-          <a:xfrm>
-            <a:off x="1371600" y="2926080"/>
-            <a:ext cx="1828800" cy="365760"/>
+          <p:cNvPr id="34" name="Rectangle 33"/>
+          <p:cNvSpPr/>
+          <p:nvPr/>
+        </p:nvSpPr>
+        <p:spPr>
+          <a:xfrm>
+            <a:off x="6400800" y="1783080"/>
+            <a:ext cx="5029200" cy="548640"/>
+          </a:xfrm>
+          <a:prstGeom prst="rect">
+            <a:avLst/>
+          </a:prstGeom>
+          <a:solidFill>
+            <a:srgbClr val="FEF0EF"/>
+          </a:solidFill>
+          <a:ln>
+            <a:noFill/>
+          </a:ln>
+        </p:spPr>
+        <p:style>
+          <a:lnRef idx="1">
+            <a:schemeClr val="accent1"/>
+          </a:lnRef>
+          <a:fillRef idx="3">
+            <a:schemeClr val="accent1"/>
+          </a:fillRef>
+          <a:effectRef idx="2">
+            <a:schemeClr val="accent1"/>
+          </a:effectRef>
+          <a:fontRef idx="minor">
+            <a:schemeClr val="lt1"/>
+          </a:fontRef>
+        </p:style>
+        <p:txBody>
+          <a:bodyPr rtlCol="0" anchor="ctr"/>
+          <a:lstStyle/>
+          <a:p>
+            <a:pPr algn="ctr"/>
+          </a:p>
+        </p:txBody>
+      </p:sp>
+      <p:sp>
+        <p:nvSpPr>
+          <p:cNvPr id="35" name="TextBox 34"/>
+          <p:cNvSpPr txBox="1"/>
+          <p:nvPr/>
+        </p:nvSpPr>
+        <p:spPr>
+          <a:xfrm>
+            <a:off x="6583680" y="1828800"/>
+            <a:ext cx="3200400" cy="228600"/>
           </a:xfrm>
           <a:prstGeom prst="rect">
             <a:avLst/>
@@ -12870,28 +14560,28 @@
           <a:lstStyle/>
           <a:p>
             <a:pPr algn="l">
-              <a:defRPr sz="1600" b="0">
-                <a:solidFill>
-                  <a:srgbClr val="999999"/>
-                </a:solidFill>
-              </a:defRPr>
-            </a:pPr>
-            <a:r>
-              <a:t>Демо:</a:t>
-            </a:r>
-          </a:p>
-        </p:txBody>
-      </p:sp>
-      <p:sp>
-        <p:nvSpPr>
-          <p:cNvPr id="6" name="TextBox 5"/>
-          <p:cNvSpPr txBox="1"/>
-          <p:nvPr/>
-        </p:nvSpPr>
-        <p:spPr>
-          <a:xfrm>
-            <a:off x="3200400" y="2926080"/>
-            <a:ext cx="7315200" cy="365760"/>
+              <a:defRPr sz="1300" b="1">
+                <a:solidFill>
+                  <a:srgbClr val="334059"/>
+                </a:solidFill>
+              </a:defRPr>
+            </a:pPr>
+            <a:r>
+              <a:t>Отрицание в запросе</a:t>
+            </a:r>
+          </a:p>
+        </p:txBody>
+      </p:sp>
+      <p:sp>
+        <p:nvSpPr>
+          <p:cNvPr id="36" name="TextBox 35"/>
+          <p:cNvSpPr txBox="1"/>
+          <p:nvPr/>
+        </p:nvSpPr>
+        <p:spPr>
+          <a:xfrm>
+            <a:off x="6583680" y="2057400"/>
+            <a:ext cx="3657600" cy="228600"/>
           </a:xfrm>
           <a:prstGeom prst="rect">
             <a:avLst/>
@@ -12905,28 +14595,106 @@
           <a:lstStyle/>
           <a:p>
             <a:pPr algn="l">
-              <a:defRPr sz="1600" b="1">
-                <a:solidFill>
-                  <a:srgbClr val="1976D2"/>
-                </a:solidFill>
-              </a:defRPr>
-            </a:pPr>
-            <a:r>
-              <a:t>tenderhack.extra.moscow</a:t>
-            </a:r>
-          </a:p>
-        </p:txBody>
-      </p:sp>
-      <p:sp>
-        <p:nvSpPr>
-          <p:cNvPr id="7" name="TextBox 6"/>
-          <p:cNvSpPr txBox="1"/>
-          <p:nvPr/>
-        </p:nvSpPr>
-        <p:spPr>
-          <a:xfrm>
-            <a:off x="1371600" y="3429000"/>
-            <a:ext cx="1828800" cy="365760"/>
+              <a:defRPr sz="1000" b="0">
+                <a:solidFill>
+                  <a:srgbClr val="666666"/>
+                </a:solidFill>
+              </a:defRPr>
+            </a:pPr>
+            <a:r>
+              <a:t>«не маслянных», «без латексных», «кроме» → must_not</a:t>
+            </a:r>
+          </a:p>
+        </p:txBody>
+      </p:sp>
+      <p:sp>
+        <p:nvSpPr>
+          <p:cNvPr id="37" name="TextBox 36"/>
+          <p:cNvSpPr txBox="1"/>
+          <p:nvPr/>
+        </p:nvSpPr>
+        <p:spPr>
+          <a:xfrm>
+            <a:off x="10241280" y="1874520"/>
+            <a:ext cx="1097280" cy="320040"/>
+          </a:xfrm>
+          <a:prstGeom prst="rect">
+            <a:avLst/>
+          </a:prstGeom>
+          <a:noFill/>
+        </p:spPr>
+        <p:txBody>
+          <a:bodyPr wrap="square">
+            <a:spAutoFit/>
+          </a:bodyPr>
+          <a:lstStyle/>
+          <a:p>
+            <a:pPr algn="r">
+              <a:defRPr sz="1400" b="1">
+                <a:solidFill>
+                  <a:srgbClr val="E53935"/>
+                </a:solidFill>
+              </a:defRPr>
+            </a:pPr>
+            <a:r>
+              <a:t>Исключ.</a:t>
+            </a:r>
+          </a:p>
+        </p:txBody>
+      </p:sp>
+      <p:sp>
+        <p:nvSpPr>
+          <p:cNvPr id="38" name="Rectangle 37"/>
+          <p:cNvSpPr/>
+          <p:nvPr/>
+        </p:nvSpPr>
+        <p:spPr>
+          <a:xfrm>
+            <a:off x="6400800" y="2423160"/>
+            <a:ext cx="5029200" cy="548640"/>
+          </a:xfrm>
+          <a:prstGeom prst="rect">
+            <a:avLst/>
+          </a:prstGeom>
+          <a:solidFill>
+            <a:srgbClr val="FFFFFF"/>
+          </a:solidFill>
+          <a:ln>
+            <a:noFill/>
+          </a:ln>
+        </p:spPr>
+        <p:style>
+          <a:lnRef idx="1">
+            <a:schemeClr val="accent1"/>
+          </a:lnRef>
+          <a:fillRef idx="3">
+            <a:schemeClr val="accent1"/>
+          </a:fillRef>
+          <a:effectRef idx="2">
+            <a:schemeClr val="accent1"/>
+          </a:effectRef>
+          <a:fontRef idx="minor">
+            <a:schemeClr val="lt1"/>
+          </a:fontRef>
+        </p:style>
+        <p:txBody>
+          <a:bodyPr rtlCol="0" anchor="ctr"/>
+          <a:lstStyle/>
+          <a:p>
+            <a:pPr algn="ctr"/>
+          </a:p>
+        </p:txBody>
+      </p:sp>
+      <p:sp>
+        <p:nvSpPr>
+          <p:cNvPr id="39" name="TextBox 38"/>
+          <p:cNvSpPr txBox="1"/>
+          <p:nvPr/>
+        </p:nvSpPr>
+        <p:spPr>
+          <a:xfrm>
+            <a:off x="6583680" y="2468880"/>
+            <a:ext cx="3200400" cy="228600"/>
           </a:xfrm>
           <a:prstGeom prst="rect">
             <a:avLst/>
@@ -12940,28 +14708,28 @@
           <a:lstStyle/>
           <a:p>
             <a:pPr algn="l">
-              <a:defRPr sz="1600" b="0">
-                <a:solidFill>
-                  <a:srgbClr val="999999"/>
-                </a:solidFill>
-              </a:defRPr>
-            </a:pPr>
-            <a:r>
-              <a:t>SonarQube:</a:t>
-            </a:r>
-          </a:p>
-        </p:txBody>
-      </p:sp>
-      <p:sp>
-        <p:nvSpPr>
-          <p:cNvPr id="8" name="TextBox 7"/>
-          <p:cNvSpPr txBox="1"/>
-          <p:nvPr/>
-        </p:nvSpPr>
-        <p:spPr>
-          <a:xfrm>
-            <a:off x="3200400" y="3429000"/>
-            <a:ext cx="7315200" cy="365760"/>
+              <a:defRPr sz="1300" b="1">
+                <a:solidFill>
+                  <a:srgbClr val="334059"/>
+                </a:solidFill>
+              </a:defRPr>
+            </a:pPr>
+            <a:r>
+              <a:t>Bounce (&lt; 3 сек на карточке)</a:t>
+            </a:r>
+          </a:p>
+        </p:txBody>
+      </p:sp>
+      <p:sp>
+        <p:nvSpPr>
+          <p:cNvPr id="40" name="TextBox 39"/>
+          <p:cNvSpPr txBox="1"/>
+          <p:nvPr/>
+        </p:nvSpPr>
+        <p:spPr>
+          <a:xfrm>
+            <a:off x="6583680" y="2697480"/>
+            <a:ext cx="3657600" cy="228600"/>
           </a:xfrm>
           <a:prstGeom prst="rect">
             <a:avLst/>
@@ -12975,28 +14743,106 @@
           <a:lstStyle/>
           <a:p>
             <a:pPr algn="l">
-              <a:defRPr sz="1600" b="1">
-                <a:solidFill>
-                  <a:srgbClr val="1976D2"/>
-                </a:solidFill>
-              </a:defRPr>
-            </a:pPr>
-            <a:r>
-              <a:t>tenderhack.extra.moscow/sonar/</a:t>
-            </a:r>
-          </a:p>
-        </p:txBody>
-      </p:sp>
-      <p:sp>
-        <p:nvSpPr>
-          <p:cNvPr id="9" name="TextBox 8"/>
-          <p:cNvSpPr txBox="1"/>
-          <p:nvPr/>
-        </p:nvSpPr>
-        <p:spPr>
-          <a:xfrm>
-            <a:off x="1371600" y="3931920"/>
-            <a:ext cx="1828800" cy="365760"/>
+              <a:defRPr sz="1000" b="0">
+                <a:solidFill>
+                  <a:srgbClr val="666666"/>
+                </a:solidFill>
+              </a:defRPr>
+            </a:pPr>
+            <a:r>
+              <a:t>Event quick_return — закрыл карточку быстро</a:t>
+            </a:r>
+          </a:p>
+        </p:txBody>
+      </p:sp>
+      <p:sp>
+        <p:nvSpPr>
+          <p:cNvPr id="41" name="TextBox 40"/>
+          <p:cNvSpPr txBox="1"/>
+          <p:nvPr/>
+        </p:nvSpPr>
+        <p:spPr>
+          <a:xfrm>
+            <a:off x="10241280" y="2514600"/>
+            <a:ext cx="1097280" cy="320040"/>
+          </a:xfrm>
+          <a:prstGeom prst="rect">
+            <a:avLst/>
+          </a:prstGeom>
+          <a:noFill/>
+        </p:spPr>
+        <p:txBody>
+          <a:bodyPr wrap="square">
+            <a:spAutoFit/>
+          </a:bodyPr>
+          <a:lstStyle/>
+          <a:p>
+            <a:pPr algn="r">
+              <a:defRPr sz="1400" b="1">
+                <a:solidFill>
+                  <a:srgbClr val="E53935"/>
+                </a:solidFill>
+              </a:defRPr>
+            </a:pPr>
+            <a:r>
+              <a:t>-сигнал</a:t>
+            </a:r>
+          </a:p>
+        </p:txBody>
+      </p:sp>
+      <p:sp>
+        <p:nvSpPr>
+          <p:cNvPr id="42" name="Rectangle 41"/>
+          <p:cNvSpPr/>
+          <p:nvPr/>
+        </p:nvSpPr>
+        <p:spPr>
+          <a:xfrm>
+            <a:off x="6400800" y="3063239"/>
+            <a:ext cx="5029200" cy="548640"/>
+          </a:xfrm>
+          <a:prstGeom prst="rect">
+            <a:avLst/>
+          </a:prstGeom>
+          <a:solidFill>
+            <a:srgbClr val="FEF0EF"/>
+          </a:solidFill>
+          <a:ln>
+            <a:noFill/>
+          </a:ln>
+        </p:spPr>
+        <p:style>
+          <a:lnRef idx="1">
+            <a:schemeClr val="accent1"/>
+          </a:lnRef>
+          <a:fillRef idx="3">
+            <a:schemeClr val="accent1"/>
+          </a:fillRef>
+          <a:effectRef idx="2">
+            <a:schemeClr val="accent1"/>
+          </a:effectRef>
+          <a:fontRef idx="minor">
+            <a:schemeClr val="lt1"/>
+          </a:fontRef>
+        </p:style>
+        <p:txBody>
+          <a:bodyPr rtlCol="0" anchor="ctr"/>
+          <a:lstStyle/>
+          <a:p>
+            <a:pPr algn="ctr"/>
+          </a:p>
+        </p:txBody>
+      </p:sp>
+      <p:sp>
+        <p:nvSpPr>
+          <p:cNvPr id="43" name="TextBox 42"/>
+          <p:cNvSpPr txBox="1"/>
+          <p:nvPr/>
+        </p:nvSpPr>
+        <p:spPr>
+          <a:xfrm>
+            <a:off x="6583680" y="3108959"/>
+            <a:ext cx="3200400" cy="228600"/>
           </a:xfrm>
           <a:prstGeom prst="rect">
             <a:avLst/>
@@ -13010,28 +14856,28 @@
           <a:lstStyle/>
           <a:p>
             <a:pPr algn="l">
-              <a:defRPr sz="1600" b="0">
-                <a:solidFill>
-                  <a:srgbClr val="999999"/>
-                </a:solidFill>
-              </a:defRPr>
-            </a:pPr>
-            <a:r>
-              <a:t>GitHub:</a:t>
-            </a:r>
-          </a:p>
-        </p:txBody>
-      </p:sp>
-      <p:sp>
-        <p:nvSpPr>
-          <p:cNvPr id="10" name="TextBox 9"/>
-          <p:cNvSpPr txBox="1"/>
-          <p:nvPr/>
-        </p:nvSpPr>
-        <p:spPr>
-          <a:xfrm>
-            <a:off x="3200400" y="3931920"/>
-            <a:ext cx="7315200" cy="365760"/>
+              <a:defRPr sz="1300" b="1">
+                <a:solidFill>
+                  <a:srgbClr val="334059"/>
+                </a:solidFill>
+              </a:defRPr>
+            </a:pPr>
+            <a:r>
+              <a:t>Слово — атрибут, не предмет</a:t>
+            </a:r>
+          </a:p>
+        </p:txBody>
+      </p:sp>
+      <p:sp>
+        <p:nvSpPr>
+          <p:cNvPr id="44" name="TextBox 43"/>
+          <p:cNvSpPr txBox="1"/>
+          <p:nvPr/>
+        </p:nvSpPr>
+        <p:spPr>
+          <a:xfrm>
+            <a:off x="6583680" y="3337559"/>
+            <a:ext cx="3657600" cy="228600"/>
           </a:xfrm>
           <a:prstGeom prst="rect">
             <a:avLst/>
@@ -13045,28 +14891,359 @@
           <a:lstStyle/>
           <a:p>
             <a:pPr algn="l">
-              <a:defRPr sz="1600" b="1">
-                <a:solidFill>
-                  <a:srgbClr val="1976D2"/>
-                </a:solidFill>
-              </a:defRPr>
-            </a:pPr>
-            <a:r>
-              <a:t>github.com/Shadowru/tenderhack2026</a:t>
-            </a:r>
-          </a:p>
-        </p:txBody>
-      </p:sp>
-      <p:sp>
-        <p:nvSpPr>
-          <p:cNvPr id="11" name="TextBox 10"/>
-          <p:cNvSpPr txBox="1"/>
-          <p:nvPr/>
-        </p:nvSpPr>
-        <p:spPr>
-          <a:xfrm>
-            <a:off x="1371600" y="5029200"/>
-            <a:ext cx="2286000" cy="365760"/>
+              <a:defRPr sz="1000" b="0">
+                <a:solidFill>
+                  <a:srgbClr val="666666"/>
+                </a:solidFill>
+              </a:defRPr>
+            </a:pPr>
+            <a:r>
+              <a:t>«тачка с ручкой» → subject=тачка, ручка не предмет</a:t>
+            </a:r>
+          </a:p>
+        </p:txBody>
+      </p:sp>
+      <p:sp>
+        <p:nvSpPr>
+          <p:cNvPr id="45" name="TextBox 44"/>
+          <p:cNvSpPr txBox="1"/>
+          <p:nvPr/>
+        </p:nvSpPr>
+        <p:spPr>
+          <a:xfrm>
+            <a:off x="10241280" y="3154679"/>
+            <a:ext cx="1097280" cy="320040"/>
+          </a:xfrm>
+          <a:prstGeom prst="rect">
+            <a:avLst/>
+          </a:prstGeom>
+          <a:noFill/>
+        </p:spPr>
+        <p:txBody>
+          <a:bodyPr wrap="square">
+            <a:spAutoFit/>
+          </a:bodyPr>
+          <a:lstStyle/>
+          <a:p>
+            <a:pPr algn="r">
+              <a:defRPr sz="1400" b="1">
+                <a:solidFill>
+                  <a:srgbClr val="E53935"/>
+                </a:solidFill>
+              </a:defRPr>
+            </a:pPr>
+            <a:r>
+              <a:t>x0</a:t>
+            </a:r>
+          </a:p>
+        </p:txBody>
+      </p:sp>
+      <p:sp>
+        <p:nvSpPr>
+          <p:cNvPr id="46" name="Rectangle 45"/>
+          <p:cNvSpPr/>
+          <p:nvPr/>
+        </p:nvSpPr>
+        <p:spPr>
+          <a:xfrm>
+            <a:off x="6400800" y="3703320"/>
+            <a:ext cx="5029200" cy="548640"/>
+          </a:xfrm>
+          <a:prstGeom prst="rect">
+            <a:avLst/>
+          </a:prstGeom>
+          <a:solidFill>
+            <a:srgbClr val="FFFFFF"/>
+          </a:solidFill>
+          <a:ln>
+            <a:noFill/>
+          </a:ln>
+        </p:spPr>
+        <p:style>
+          <a:lnRef idx="1">
+            <a:schemeClr val="accent1"/>
+          </a:lnRef>
+          <a:fillRef idx="3">
+            <a:schemeClr val="accent1"/>
+          </a:fillRef>
+          <a:effectRef idx="2">
+            <a:schemeClr val="accent1"/>
+          </a:effectRef>
+          <a:fontRef idx="minor">
+            <a:schemeClr val="lt1"/>
+          </a:fontRef>
+        </p:style>
+        <p:txBody>
+          <a:bodyPr rtlCol="0" anchor="ctr"/>
+          <a:lstStyle/>
+          <a:p>
+            <a:pPr algn="ctr"/>
+          </a:p>
+        </p:txBody>
+      </p:sp>
+      <p:sp>
+        <p:nvSpPr>
+          <p:cNvPr id="47" name="TextBox 46"/>
+          <p:cNvSpPr txBox="1"/>
+          <p:nvPr/>
+        </p:nvSpPr>
+        <p:spPr>
+          <a:xfrm>
+            <a:off x="6583680" y="3749040"/>
+            <a:ext cx="3200400" cy="228600"/>
+          </a:xfrm>
+          <a:prstGeom prst="rect">
+            <a:avLst/>
+          </a:prstGeom>
+          <a:noFill/>
+        </p:spPr>
+        <p:txBody>
+          <a:bodyPr wrap="square">
+            <a:spAutoFit/>
+          </a:bodyPr>
+          <a:lstStyle/>
+          <a:p>
+            <a:pPr algn="l">
+              <a:defRPr sz="1300" b="1">
+                <a:solidFill>
+                  <a:srgbClr val="334059"/>
+                </a:solidFill>
+              </a:defRPr>
+            </a:pPr>
+            <a:r>
+              <a:t>Temporal decay</a:t>
+            </a:r>
+          </a:p>
+        </p:txBody>
+      </p:sp>
+      <p:sp>
+        <p:nvSpPr>
+          <p:cNvPr id="48" name="TextBox 47"/>
+          <p:cNvSpPr txBox="1"/>
+          <p:nvPr/>
+        </p:nvSpPr>
+        <p:spPr>
+          <a:xfrm>
+            <a:off x="6583680" y="3977640"/>
+            <a:ext cx="3657600" cy="228600"/>
+          </a:xfrm>
+          <a:prstGeom prst="rect">
+            <a:avLst/>
+          </a:prstGeom>
+          <a:noFill/>
+        </p:spPr>
+        <p:txBody>
+          <a:bodyPr wrap="square">
+            <a:spAutoFit/>
+          </a:bodyPr>
+          <a:lstStyle/>
+          <a:p>
+            <a:pPr algn="l">
+              <a:defRPr sz="1000" b="0">
+                <a:solidFill>
+                  <a:srgbClr val="666666"/>
+                </a:solidFill>
+              </a:defRPr>
+            </a:pPr>
+            <a:r>
+              <a:t>DECAY_FACTOR = 0.95 на каждый день давности события</a:t>
+            </a:r>
+          </a:p>
+        </p:txBody>
+      </p:sp>
+      <p:sp>
+        <p:nvSpPr>
+          <p:cNvPr id="49" name="TextBox 48"/>
+          <p:cNvSpPr txBox="1"/>
+          <p:nvPr/>
+        </p:nvSpPr>
+        <p:spPr>
+          <a:xfrm>
+            <a:off x="10241280" y="3794760"/>
+            <a:ext cx="1097280" cy="320040"/>
+          </a:xfrm>
+          <a:prstGeom prst="rect">
+            <a:avLst/>
+          </a:prstGeom>
+          <a:noFill/>
+        </p:spPr>
+        <p:txBody>
+          <a:bodyPr wrap="square">
+            <a:spAutoFit/>
+          </a:bodyPr>
+          <a:lstStyle/>
+          <a:p>
+            <a:pPr algn="r">
+              <a:defRPr sz="1400" b="1">
+                <a:solidFill>
+                  <a:srgbClr val="E53935"/>
+                </a:solidFill>
+              </a:defRPr>
+            </a:pPr>
+            <a:r>
+              <a:t>×0.95/д</a:t>
+            </a:r>
+          </a:p>
+        </p:txBody>
+      </p:sp>
+      <p:sp>
+        <p:nvSpPr>
+          <p:cNvPr id="50" name="Rectangle 49"/>
+          <p:cNvSpPr/>
+          <p:nvPr/>
+        </p:nvSpPr>
+        <p:spPr>
+          <a:xfrm>
+            <a:off x="6400800" y="4343400"/>
+            <a:ext cx="5029200" cy="548640"/>
+          </a:xfrm>
+          <a:prstGeom prst="rect">
+            <a:avLst/>
+          </a:prstGeom>
+          <a:solidFill>
+            <a:srgbClr val="FEF0EF"/>
+          </a:solidFill>
+          <a:ln>
+            <a:noFill/>
+          </a:ln>
+        </p:spPr>
+        <p:style>
+          <a:lnRef idx="1">
+            <a:schemeClr val="accent1"/>
+          </a:lnRef>
+          <a:fillRef idx="3">
+            <a:schemeClr val="accent1"/>
+          </a:fillRef>
+          <a:effectRef idx="2">
+            <a:schemeClr val="accent1"/>
+          </a:effectRef>
+          <a:fontRef idx="minor">
+            <a:schemeClr val="lt1"/>
+          </a:fontRef>
+        </p:style>
+        <p:txBody>
+          <a:bodyPr rtlCol="0" anchor="ctr"/>
+          <a:lstStyle/>
+          <a:p>
+            <a:pPr algn="ctr"/>
+          </a:p>
+        </p:txBody>
+      </p:sp>
+      <p:sp>
+        <p:nvSpPr>
+          <p:cNvPr id="51" name="TextBox 50"/>
+          <p:cNvSpPr txBox="1"/>
+          <p:nvPr/>
+        </p:nvSpPr>
+        <p:spPr>
+          <a:xfrm>
+            <a:off x="6583680" y="4389120"/>
+            <a:ext cx="3200400" cy="228600"/>
+          </a:xfrm>
+          <a:prstGeom prst="rect">
+            <a:avLst/>
+          </a:prstGeom>
+          <a:noFill/>
+        </p:spPr>
+        <p:txBody>
+          <a:bodyPr wrap="square">
+            <a:spAutoFit/>
+          </a:bodyPr>
+          <a:lstStyle/>
+          <a:p>
+            <a:pPr algn="l">
+              <a:defRPr sz="1300" b="1">
+                <a:solidFill>
+                  <a:srgbClr val="334059"/>
+                </a:solidFill>
+              </a:defRPr>
+            </a:pPr>
+            <a:r>
+              <a:t>Историческая vs live-данные</a:t>
+            </a:r>
+          </a:p>
+        </p:txBody>
+      </p:sp>
+      <p:sp>
+        <p:nvSpPr>
+          <p:cNvPr id="52" name="TextBox 51"/>
+          <p:cNvSpPr txBox="1"/>
+          <p:nvPr/>
+        </p:nvSpPr>
+        <p:spPr>
+          <a:xfrm>
+            <a:off x="6583680" y="4617720"/>
+            <a:ext cx="3657600" cy="228600"/>
+          </a:xfrm>
+          <a:prstGeom prst="rect">
+            <a:avLst/>
+          </a:prstGeom>
+          <a:noFill/>
+        </p:spPr>
+        <p:txBody>
+          <a:bodyPr wrap="square">
+            <a:spAutoFit/>
+          </a:bodyPr>
+          <a:lstStyle/>
+          <a:p>
+            <a:pPr algn="l">
+              <a:defRPr sz="1000" b="0">
+                <a:solidFill>
+                  <a:srgbClr val="666666"/>
+                </a:solidFill>
+              </a:defRPr>
+            </a:pPr>
+            <a:r>
+              <a:t>Контракты из PG дисконтируются ×0.7</a:t>
+            </a:r>
+          </a:p>
+        </p:txBody>
+      </p:sp>
+      <p:sp>
+        <p:nvSpPr>
+          <p:cNvPr id="53" name="TextBox 52"/>
+          <p:cNvSpPr txBox="1"/>
+          <p:nvPr/>
+        </p:nvSpPr>
+        <p:spPr>
+          <a:xfrm>
+            <a:off x="10241280" y="4434840"/>
+            <a:ext cx="1097280" cy="320040"/>
+          </a:xfrm>
+          <a:prstGeom prst="rect">
+            <a:avLst/>
+          </a:prstGeom>
+          <a:noFill/>
+        </p:spPr>
+        <p:txBody>
+          <a:bodyPr wrap="square">
+            <a:spAutoFit/>
+          </a:bodyPr>
+          <a:lstStyle/>
+          <a:p>
+            <a:pPr algn="r">
+              <a:defRPr sz="1400" b="1">
+                <a:solidFill>
+                  <a:srgbClr val="E53935"/>
+                </a:solidFill>
+              </a:defRPr>
+            </a:pPr>
+            <a:r>
+              <a:t>×0.7</a:t>
+            </a:r>
+          </a:p>
+        </p:txBody>
+      </p:sp>
+      <p:sp>
+        <p:nvSpPr>
+          <p:cNvPr id="54" name="TextBox 53"/>
+          <p:cNvSpPr txBox="1"/>
+          <p:nvPr/>
+        </p:nvSpPr>
+        <p:spPr>
+          <a:xfrm>
+            <a:off x="731520" y="5852160"/>
+            <a:ext cx="10972800" cy="365760"/>
           </a:xfrm>
           <a:prstGeom prst="rect">
             <a:avLst/>
@@ -13080,189 +15257,14 @@
           <a:lstStyle/>
           <a:p>
             <a:pPr algn="ctr">
-              <a:defRPr sz="1400" b="0">
-                <a:solidFill>
-                  <a:srgbClr val="999999"/>
-                </a:solidFill>
-              </a:defRPr>
-            </a:pPr>
-            <a:r>
-              <a:t>537K товаров</a:t>
-            </a:r>
-          </a:p>
-        </p:txBody>
-      </p:sp>
-      <p:sp>
-        <p:nvSpPr>
-          <p:cNvPr id="12" name="TextBox 11"/>
-          <p:cNvSpPr txBox="1"/>
-          <p:nvPr/>
-        </p:nvSpPr>
-        <p:spPr>
-          <a:xfrm>
-            <a:off x="3657600" y="5029200"/>
-            <a:ext cx="2286000" cy="365760"/>
-          </a:xfrm>
-          <a:prstGeom prst="rect">
-            <a:avLst/>
-          </a:prstGeom>
-          <a:noFill/>
-        </p:spPr>
-        <p:txBody>
-          <a:bodyPr wrap="square">
-            <a:spAutoFit/>
-          </a:bodyPr>
-          <a:lstStyle/>
-          <a:p>
-            <a:pPr algn="ctr">
-              <a:defRPr sz="1400" b="0">
-                <a:solidFill>
-                  <a:srgbClr val="999999"/>
-                </a:solidFill>
-              </a:defRPr>
-            </a:pPr>
-            <a:r>
-              <a:t>2M контрактов</a:t>
-            </a:r>
-          </a:p>
-        </p:txBody>
-      </p:sp>
-      <p:sp>
-        <p:nvSpPr>
-          <p:cNvPr id="13" name="TextBox 12"/>
-          <p:cNvSpPr txBox="1"/>
-          <p:nvPr/>
-        </p:nvSpPr>
-        <p:spPr>
-          <a:xfrm>
-            <a:off x="5943600" y="5029200"/>
-            <a:ext cx="2286000" cy="365760"/>
-          </a:xfrm>
-          <a:prstGeom prst="rect">
-            <a:avLst/>
-          </a:prstGeom>
-          <a:noFill/>
-        </p:spPr>
-        <p:txBody>
-          <a:bodyPr wrap="square">
-            <a:spAutoFit/>
-          </a:bodyPr>
-          <a:lstStyle/>
-          <a:p>
-            <a:pPr algn="ctr">
-              <a:defRPr sz="1400" b="0">
-                <a:solidFill>
-                  <a:srgbClr val="999999"/>
-                </a:solidFill>
-              </a:defRPr>
-            </a:pPr>
-            <a:r>
-              <a:t>4190 профилей</a:t>
-            </a:r>
-          </a:p>
-        </p:txBody>
-      </p:sp>
-      <p:sp>
-        <p:nvSpPr>
-          <p:cNvPr id="14" name="TextBox 13"/>
-          <p:cNvSpPr txBox="1"/>
-          <p:nvPr/>
-        </p:nvSpPr>
-        <p:spPr>
-          <a:xfrm>
-            <a:off x="8229600" y="5029200"/>
-            <a:ext cx="2286000" cy="365760"/>
-          </a:xfrm>
-          <a:prstGeom prst="rect">
-            <a:avLst/>
-          </a:prstGeom>
-          <a:noFill/>
-        </p:spPr>
-        <p:txBody>
-          <a:bodyPr wrap="square">
-            <a:spAutoFit/>
-          </a:bodyPr>
-          <a:lstStyle/>
-          <a:p>
-            <a:pPr algn="ctr">
-              <a:defRPr sz="1400" b="0">
-                <a:solidFill>
-                  <a:srgbClr val="999999"/>
-                </a:solidFill>
-              </a:defRPr>
-            </a:pPr>
-            <a:r>
-              <a:t>93% качество</a:t>
-            </a:r>
-          </a:p>
-        </p:txBody>
-      </p:sp>
-      <p:sp>
-        <p:nvSpPr>
-          <p:cNvPr id="15" name="TextBox 14"/>
-          <p:cNvSpPr txBox="1"/>
-          <p:nvPr/>
-        </p:nvSpPr>
-        <p:spPr>
-          <a:xfrm>
-            <a:off x="10058400" y="5029200"/>
-            <a:ext cx="2286000" cy="365760"/>
-          </a:xfrm>
-          <a:prstGeom prst="rect">
-            <a:avLst/>
-          </a:prstGeom>
-          <a:noFill/>
-        </p:spPr>
-        <p:txBody>
-          <a:bodyPr wrap="square">
-            <a:spAutoFit/>
-          </a:bodyPr>
-          <a:lstStyle/>
-          <a:p>
-            <a:pPr algn="ctr">
-              <a:defRPr sz="1400" b="0">
-                <a:solidFill>
-                  <a:srgbClr val="999999"/>
-                </a:solidFill>
-              </a:defRPr>
-            </a:pPr>
-            <a:r>
-              <a:t>30мс ответ</a:t>
-            </a:r>
-          </a:p>
-        </p:txBody>
-      </p:sp>
-      <p:sp>
-        <p:nvSpPr>
-          <p:cNvPr id="16" name="TextBox 15"/>
-          <p:cNvSpPr txBox="1"/>
-          <p:nvPr/>
-        </p:nvSpPr>
-        <p:spPr>
-          <a:xfrm>
-            <a:off x="1371600" y="5760720"/>
-            <a:ext cx="9144000" cy="365760"/>
-          </a:xfrm>
-          <a:prstGeom prst="rect">
-            <a:avLst/>
-          </a:prstGeom>
-          <a:noFill/>
-        </p:spPr>
-        <p:txBody>
-          <a:bodyPr wrap="square">
-            <a:spAutoFit/>
-          </a:bodyPr>
-          <a:lstStyle/>
-          <a:p>
-            <a:pPr algn="l">
-              <a:defRPr sz="1400" b="0">
-                <a:solidFill>
-                  <a:srgbClr val="999999"/>
-                </a:solidFill>
-              </a:defRPr>
-            </a:pPr>
-            <a:r>
-              <a:t>TenderHack 2026</a:t>
+              <a:defRPr sz="1200" b="1">
+                <a:solidFill>
+                  <a:srgbClr val="666666"/>
+                </a:solidFill>
+              </a:defRPr>
+            </a:pPr>
+            <a:r>
+              <a:t>Формула: Score = BM25(strategies) x Popularity(log2p) x ProductBoost(1-2) x CategoryBoost(1-1.05) + SubjectExact(+15) + SubjectFuzzy(+12)</a:t>
             </a:r>
           </a:p>
         </p:txBody>

</xml_diff>

<commit_message>
Fix PPTX: replace connectors with rectangles to avoid corruption
PowerPoint reported file as corrupted due to orphan connectors
(not bound to shapes). Replaced all arrow() calls with thin
rectangle shapes — universally compatible with all PPTX readers.

Co-Authored-By: Claude Opus 4.6 (1M context) <noreply@anthropic.com>
</commit_message>
<xml_diff>
--- a/docs/TenderHack2026_Presentation.pptx
+++ b/docs/TenderHack2026_Presentation.pptx
@@ -7059,706 +7059,866 @@
           </a:p>
         </p:txBody>
       </p:sp>
-      <p:cxnSp>
-        <p:nvCxnSpPr>
-          <p:cNvPr id="31" name="Connector 30"/>
-          <p:cNvCxnSpPr/>
-          <p:nvPr/>
-        </p:nvCxnSpPr>
-        <p:spPr>
-          <a:xfrm>
-            <a:off x="2011680" y="1508760.0"/>
-            <a:ext cx="1188720" cy="0.0"/>
-          </a:xfrm>
-          <a:prstGeom prst="line">
-            <a:avLst/>
-          </a:prstGeom>
-          <a:ln w="19050">
-            <a:solidFill>
-              <a:srgbClr val="888888"/>
-            </a:solidFill>
+      <p:sp>
+        <p:nvSpPr>
+          <p:cNvPr id="31" name="Rectangle 30"/>
+          <p:cNvSpPr/>
+          <p:nvPr/>
+        </p:nvSpPr>
+        <p:spPr>
+          <a:xfrm>
+            <a:off x="2011680" y="1496060"/>
+            <a:ext cx="1188720" cy="25400"/>
+          </a:xfrm>
+          <a:prstGeom prst="rect">
+            <a:avLst/>
+          </a:prstGeom>
+          <a:solidFill>
+            <a:srgbClr val="999999"/>
+          </a:solidFill>
+          <a:ln>
+            <a:noFill/>
           </a:ln>
         </p:spPr>
         <p:style>
-          <a:lnRef idx="2">
+          <a:lnRef idx="1">
             <a:schemeClr val="accent1"/>
           </a:lnRef>
-          <a:fillRef idx="0">
+          <a:fillRef idx="3">
             <a:schemeClr val="accent1"/>
           </a:fillRef>
-          <a:effectRef idx="1">
+          <a:effectRef idx="2">
             <a:schemeClr val="accent1"/>
           </a:effectRef>
           <a:fontRef idx="minor">
-            <a:schemeClr val="tx1"/>
+            <a:schemeClr val="lt1"/>
           </a:fontRef>
         </p:style>
-      </p:cxnSp>
-      <p:cxnSp>
-        <p:nvCxnSpPr>
-          <p:cNvPr id="32" name="Connector 31"/>
-          <p:cNvCxnSpPr/>
-          <p:nvPr/>
-        </p:nvCxnSpPr>
-        <p:spPr>
-          <a:xfrm flipV="1">
-            <a:off x="10241280" y="1508760.0"/>
-            <a:ext cx="274320" cy="1371600.0"/>
-          </a:xfrm>
-          <a:prstGeom prst="line">
-            <a:avLst/>
-          </a:prstGeom>
-          <a:ln w="19050">
-            <a:solidFill>
-              <a:srgbClr val="888888"/>
-            </a:solidFill>
+        <p:txBody>
+          <a:bodyPr rtlCol="0" anchor="ctr"/>
+          <a:lstStyle/>
+          <a:p>
+            <a:pPr algn="ctr"/>
+          </a:p>
+        </p:txBody>
+      </p:sp>
+      <p:sp>
+        <p:nvSpPr>
+          <p:cNvPr id="32" name="Rectangle 31"/>
+          <p:cNvSpPr/>
+          <p:nvPr/>
+        </p:nvSpPr>
+        <p:spPr>
+          <a:xfrm>
+            <a:off x="10228580" y="1508760"/>
+            <a:ext cx="25400" cy="1371600"/>
+          </a:xfrm>
+          <a:prstGeom prst="rect">
+            <a:avLst/>
+          </a:prstGeom>
+          <a:solidFill>
+            <a:srgbClr val="999999"/>
+          </a:solidFill>
+          <a:ln>
+            <a:noFill/>
           </a:ln>
         </p:spPr>
         <p:style>
-          <a:lnRef idx="2">
+          <a:lnRef idx="1">
             <a:schemeClr val="accent1"/>
           </a:lnRef>
-          <a:fillRef idx="0">
+          <a:fillRef idx="3">
             <a:schemeClr val="accent1"/>
           </a:fillRef>
-          <a:effectRef idx="1">
+          <a:effectRef idx="2">
             <a:schemeClr val="accent1"/>
           </a:effectRef>
           <a:fontRef idx="minor">
-            <a:schemeClr val="tx1"/>
+            <a:schemeClr val="lt1"/>
           </a:fontRef>
         </p:style>
-      </p:cxnSp>
-      <p:cxnSp>
-        <p:nvCxnSpPr>
-          <p:cNvPr id="33" name="Connector 32"/>
-          <p:cNvCxnSpPr/>
-          <p:nvPr/>
-        </p:nvCxnSpPr>
-        <p:spPr>
-          <a:xfrm>
-            <a:off x="3840480.0" y="1783080.0"/>
-            <a:ext cx="0.0" cy="822960.0"/>
-          </a:xfrm>
-          <a:prstGeom prst="line">
-            <a:avLst/>
-          </a:prstGeom>
-          <a:ln w="19050">
-            <a:solidFill>
-              <a:srgbClr val="888888"/>
-            </a:solidFill>
+        <p:txBody>
+          <a:bodyPr rtlCol="0" anchor="ctr"/>
+          <a:lstStyle/>
+          <a:p>
+            <a:pPr algn="ctr"/>
+          </a:p>
+        </p:txBody>
+      </p:sp>
+      <p:sp>
+        <p:nvSpPr>
+          <p:cNvPr id="33" name="Rectangle 32"/>
+          <p:cNvSpPr/>
+          <p:nvPr/>
+        </p:nvSpPr>
+        <p:spPr>
+          <a:xfrm>
+            <a:off x="3827780" y="1783080"/>
+            <a:ext cx="25400" cy="822960"/>
+          </a:xfrm>
+          <a:prstGeom prst="rect">
+            <a:avLst/>
+          </a:prstGeom>
+          <a:solidFill>
+            <a:srgbClr val="999999"/>
+          </a:solidFill>
+          <a:ln>
+            <a:noFill/>
           </a:ln>
         </p:spPr>
         <p:style>
-          <a:lnRef idx="2">
+          <a:lnRef idx="1">
             <a:schemeClr val="accent1"/>
           </a:lnRef>
-          <a:fillRef idx="0">
+          <a:fillRef idx="3">
             <a:schemeClr val="accent1"/>
           </a:fillRef>
-          <a:effectRef idx="1">
+          <a:effectRef idx="2">
             <a:schemeClr val="accent1"/>
           </a:effectRef>
           <a:fontRef idx="minor">
-            <a:schemeClr val="tx1"/>
+            <a:schemeClr val="lt1"/>
           </a:fontRef>
         </p:style>
-      </p:cxnSp>
-      <p:cxnSp>
-        <p:nvCxnSpPr>
-          <p:cNvPr id="34" name="Connector 33"/>
-          <p:cNvCxnSpPr/>
-          <p:nvPr/>
-        </p:nvCxnSpPr>
-        <p:spPr>
-          <a:xfrm>
-            <a:off x="2286000.0" y="1783080.0"/>
-            <a:ext cx="0.0" cy="822960.0"/>
-          </a:xfrm>
-          <a:prstGeom prst="line">
-            <a:avLst/>
-          </a:prstGeom>
-          <a:ln w="19050">
-            <a:solidFill>
-              <a:srgbClr val="888888"/>
-            </a:solidFill>
+        <p:txBody>
+          <a:bodyPr rtlCol="0" anchor="ctr"/>
+          <a:lstStyle/>
+          <a:p>
+            <a:pPr algn="ctr"/>
+          </a:p>
+        </p:txBody>
+      </p:sp>
+      <p:sp>
+        <p:nvSpPr>
+          <p:cNvPr id="34" name="Rectangle 33"/>
+          <p:cNvSpPr/>
+          <p:nvPr/>
+        </p:nvSpPr>
+        <p:spPr>
+          <a:xfrm>
+            <a:off x="2273300" y="1783080"/>
+            <a:ext cx="25400" cy="822960"/>
+          </a:xfrm>
+          <a:prstGeom prst="rect">
+            <a:avLst/>
+          </a:prstGeom>
+          <a:solidFill>
+            <a:srgbClr val="999999"/>
+          </a:solidFill>
+          <a:ln>
+            <a:noFill/>
           </a:ln>
         </p:spPr>
         <p:style>
-          <a:lnRef idx="2">
+          <a:lnRef idx="1">
             <a:schemeClr val="accent1"/>
           </a:lnRef>
-          <a:fillRef idx="0">
+          <a:fillRef idx="3">
             <a:schemeClr val="accent1"/>
           </a:fillRef>
-          <a:effectRef idx="1">
+          <a:effectRef idx="2">
             <a:schemeClr val="accent1"/>
           </a:effectRef>
           <a:fontRef idx="minor">
-            <a:schemeClr val="tx1"/>
+            <a:schemeClr val="lt1"/>
           </a:fontRef>
         </p:style>
-      </p:cxnSp>
-      <p:cxnSp>
-        <p:nvCxnSpPr>
-          <p:cNvPr id="35" name="Connector 34"/>
-          <p:cNvCxnSpPr/>
-          <p:nvPr/>
-        </p:nvCxnSpPr>
-        <p:spPr>
-          <a:xfrm>
-            <a:off x="2926080" y="2880360.0"/>
-            <a:ext cx="274320" cy="0.0"/>
-          </a:xfrm>
-          <a:prstGeom prst="line">
-            <a:avLst/>
-          </a:prstGeom>
-          <a:ln w="19050">
-            <a:solidFill>
-              <a:srgbClr val="888888"/>
-            </a:solidFill>
+        <p:txBody>
+          <a:bodyPr rtlCol="0" anchor="ctr"/>
+          <a:lstStyle/>
+          <a:p>
+            <a:pPr algn="ctr"/>
+          </a:p>
+        </p:txBody>
+      </p:sp>
+      <p:sp>
+        <p:nvSpPr>
+          <p:cNvPr id="35" name="Rectangle 34"/>
+          <p:cNvSpPr/>
+          <p:nvPr/>
+        </p:nvSpPr>
+        <p:spPr>
+          <a:xfrm>
+            <a:off x="2926080" y="2867660"/>
+            <a:ext cx="274320" cy="25400"/>
+          </a:xfrm>
+          <a:prstGeom prst="rect">
+            <a:avLst/>
+          </a:prstGeom>
+          <a:solidFill>
+            <a:srgbClr val="999999"/>
+          </a:solidFill>
+          <a:ln>
+            <a:noFill/>
           </a:ln>
         </p:spPr>
         <p:style>
-          <a:lnRef idx="2">
+          <a:lnRef idx="1">
             <a:schemeClr val="accent1"/>
           </a:lnRef>
-          <a:fillRef idx="0">
+          <a:fillRef idx="3">
             <a:schemeClr val="accent1"/>
           </a:fillRef>
-          <a:effectRef idx="1">
+          <a:effectRef idx="2">
             <a:schemeClr val="accent1"/>
           </a:effectRef>
           <a:fontRef idx="minor">
-            <a:schemeClr val="tx1"/>
+            <a:schemeClr val="lt1"/>
           </a:fontRef>
         </p:style>
-      </p:cxnSp>
-      <p:cxnSp>
-        <p:nvCxnSpPr>
-          <p:cNvPr id="36" name="Connector 35"/>
-          <p:cNvCxnSpPr/>
-          <p:nvPr/>
-        </p:nvCxnSpPr>
-        <p:spPr>
-          <a:xfrm>
-            <a:off x="4480560" y="2880360.0"/>
-            <a:ext cx="640080" cy="0.0"/>
-          </a:xfrm>
-          <a:prstGeom prst="line">
-            <a:avLst/>
-          </a:prstGeom>
-          <a:ln w="19050">
-            <a:solidFill>
-              <a:srgbClr val="888888"/>
-            </a:solidFill>
+        <p:txBody>
+          <a:bodyPr rtlCol="0" anchor="ctr"/>
+          <a:lstStyle/>
+          <a:p>
+            <a:pPr algn="ctr"/>
+          </a:p>
+        </p:txBody>
+      </p:sp>
+      <p:sp>
+        <p:nvSpPr>
+          <p:cNvPr id="36" name="Rectangle 35"/>
+          <p:cNvSpPr/>
+          <p:nvPr/>
+        </p:nvSpPr>
+        <p:spPr>
+          <a:xfrm>
+            <a:off x="4480560" y="2867660"/>
+            <a:ext cx="640080" cy="25400"/>
+          </a:xfrm>
+          <a:prstGeom prst="rect">
+            <a:avLst/>
+          </a:prstGeom>
+          <a:solidFill>
+            <a:srgbClr val="999999"/>
+          </a:solidFill>
+          <a:ln>
+            <a:noFill/>
           </a:ln>
         </p:spPr>
         <p:style>
-          <a:lnRef idx="2">
+          <a:lnRef idx="1">
             <a:schemeClr val="accent1"/>
           </a:lnRef>
-          <a:fillRef idx="0">
+          <a:fillRef idx="3">
             <a:schemeClr val="accent1"/>
           </a:fillRef>
-          <a:effectRef idx="1">
+          <a:effectRef idx="2">
             <a:schemeClr val="accent1"/>
           </a:effectRef>
           <a:fontRef idx="minor">
-            <a:schemeClr val="tx1"/>
+            <a:schemeClr val="lt1"/>
           </a:fontRef>
         </p:style>
-      </p:cxnSp>
-      <p:cxnSp>
-        <p:nvCxnSpPr>
-          <p:cNvPr id="37" name="Connector 36"/>
-          <p:cNvCxnSpPr/>
-          <p:nvPr/>
-        </p:nvCxnSpPr>
-        <p:spPr>
-          <a:xfrm flipV="1">
-            <a:off x="5623560" y="2560320.0"/>
-            <a:ext cx="228600" cy="182880.0"/>
-          </a:xfrm>
-          <a:prstGeom prst="line">
-            <a:avLst/>
-          </a:prstGeom>
-          <a:ln w="19050">
-            <a:solidFill>
-              <a:srgbClr val="888888"/>
-            </a:solidFill>
+        <p:txBody>
+          <a:bodyPr rtlCol="0" anchor="ctr"/>
+          <a:lstStyle/>
+          <a:p>
+            <a:pPr algn="ctr"/>
+          </a:p>
+        </p:txBody>
+      </p:sp>
+      <p:sp>
+        <p:nvSpPr>
+          <p:cNvPr id="37" name="Rectangle 36"/>
+          <p:cNvSpPr/>
+          <p:nvPr/>
+        </p:nvSpPr>
+        <p:spPr>
+          <a:xfrm>
+            <a:off x="5623560" y="2730500"/>
+            <a:ext cx="228600" cy="25400"/>
+          </a:xfrm>
+          <a:prstGeom prst="rect">
+            <a:avLst/>
+          </a:prstGeom>
+          <a:solidFill>
+            <a:srgbClr val="999999"/>
+          </a:solidFill>
+          <a:ln>
+            <a:noFill/>
           </a:ln>
         </p:spPr>
         <p:style>
-          <a:lnRef idx="2">
+          <a:lnRef idx="1">
             <a:schemeClr val="accent1"/>
           </a:lnRef>
-          <a:fillRef idx="0">
+          <a:fillRef idx="3">
             <a:schemeClr val="accent1"/>
           </a:fillRef>
-          <a:effectRef idx="1">
+          <a:effectRef idx="2">
             <a:schemeClr val="accent1"/>
           </a:effectRef>
           <a:fontRef idx="minor">
-            <a:schemeClr val="tx1"/>
+            <a:schemeClr val="lt1"/>
           </a:fontRef>
         </p:style>
-      </p:cxnSp>
-      <p:cxnSp>
-        <p:nvCxnSpPr>
-          <p:cNvPr id="38" name="Connector 37"/>
-          <p:cNvCxnSpPr/>
-          <p:nvPr/>
-        </p:nvCxnSpPr>
-        <p:spPr>
-          <a:xfrm>
-            <a:off x="5623560" y="3017520.0"/>
-            <a:ext cx="228600" cy="182880.0"/>
-          </a:xfrm>
-          <a:prstGeom prst="line">
-            <a:avLst/>
-          </a:prstGeom>
-          <a:ln w="19050">
-            <a:solidFill>
-              <a:srgbClr val="888888"/>
-            </a:solidFill>
+        <p:txBody>
+          <a:bodyPr rtlCol="0" anchor="ctr"/>
+          <a:lstStyle/>
+          <a:p>
+            <a:pPr algn="ctr"/>
+          </a:p>
+        </p:txBody>
+      </p:sp>
+      <p:sp>
+        <p:nvSpPr>
+          <p:cNvPr id="38" name="Rectangle 37"/>
+          <p:cNvSpPr/>
+          <p:nvPr/>
+        </p:nvSpPr>
+        <p:spPr>
+          <a:xfrm>
+            <a:off x="5623560" y="3004820"/>
+            <a:ext cx="228600" cy="25400"/>
+          </a:xfrm>
+          <a:prstGeom prst="rect">
+            <a:avLst/>
+          </a:prstGeom>
+          <a:solidFill>
+            <a:srgbClr val="999999"/>
+          </a:solidFill>
+          <a:ln>
+            <a:noFill/>
           </a:ln>
         </p:spPr>
         <p:style>
-          <a:lnRef idx="2">
+          <a:lnRef idx="1">
             <a:schemeClr val="accent1"/>
           </a:lnRef>
-          <a:fillRef idx="0">
+          <a:fillRef idx="3">
             <a:schemeClr val="accent1"/>
           </a:fillRef>
-          <a:effectRef idx="1">
+          <a:effectRef idx="2">
             <a:schemeClr val="accent1"/>
           </a:effectRef>
           <a:fontRef idx="minor">
-            <a:schemeClr val="tx1"/>
+            <a:schemeClr val="lt1"/>
           </a:fontRef>
         </p:style>
-      </p:cxnSp>
-      <p:cxnSp>
-        <p:nvCxnSpPr>
-          <p:cNvPr id="39" name="Connector 38"/>
-          <p:cNvCxnSpPr/>
-          <p:nvPr/>
-        </p:nvCxnSpPr>
-        <p:spPr>
-          <a:xfrm>
-            <a:off x="7132320" y="2560320.0"/>
-            <a:ext cx="274320" cy="320040.0"/>
-          </a:xfrm>
-          <a:prstGeom prst="line">
-            <a:avLst/>
-          </a:prstGeom>
-          <a:ln w="19050">
-            <a:solidFill>
-              <a:srgbClr val="888888"/>
-            </a:solidFill>
+        <p:txBody>
+          <a:bodyPr rtlCol="0" anchor="ctr"/>
+          <a:lstStyle/>
+          <a:p>
+            <a:pPr algn="ctr"/>
+          </a:p>
+        </p:txBody>
+      </p:sp>
+      <p:sp>
+        <p:nvSpPr>
+          <p:cNvPr id="39" name="Rectangle 38"/>
+          <p:cNvSpPr/>
+          <p:nvPr/>
+        </p:nvSpPr>
+        <p:spPr>
+          <a:xfrm>
+            <a:off x="7119620" y="2560320"/>
+            <a:ext cx="25400" cy="320040"/>
+          </a:xfrm>
+          <a:prstGeom prst="rect">
+            <a:avLst/>
+          </a:prstGeom>
+          <a:solidFill>
+            <a:srgbClr val="999999"/>
+          </a:solidFill>
+          <a:ln>
+            <a:noFill/>
           </a:ln>
         </p:spPr>
         <p:style>
-          <a:lnRef idx="2">
+          <a:lnRef idx="1">
             <a:schemeClr val="accent1"/>
           </a:lnRef>
-          <a:fillRef idx="0">
+          <a:fillRef idx="3">
             <a:schemeClr val="accent1"/>
           </a:fillRef>
-          <a:effectRef idx="1">
+          <a:effectRef idx="2">
             <a:schemeClr val="accent1"/>
           </a:effectRef>
           <a:fontRef idx="minor">
-            <a:schemeClr val="tx1"/>
+            <a:schemeClr val="lt1"/>
           </a:fontRef>
         </p:style>
-      </p:cxnSp>
-      <p:cxnSp>
-        <p:nvCxnSpPr>
-          <p:cNvPr id="40" name="Connector 39"/>
-          <p:cNvCxnSpPr/>
-          <p:nvPr/>
-        </p:nvCxnSpPr>
-        <p:spPr>
-          <a:xfrm flipV="1">
-            <a:off x="7132320" y="2880360.0"/>
-            <a:ext cx="274320" cy="320040.0"/>
-          </a:xfrm>
-          <a:prstGeom prst="line">
-            <a:avLst/>
-          </a:prstGeom>
-          <a:ln w="19050">
-            <a:solidFill>
-              <a:srgbClr val="888888"/>
-            </a:solidFill>
+        <p:txBody>
+          <a:bodyPr rtlCol="0" anchor="ctr"/>
+          <a:lstStyle/>
+          <a:p>
+            <a:pPr algn="ctr"/>
+          </a:p>
+        </p:txBody>
+      </p:sp>
+      <p:sp>
+        <p:nvSpPr>
+          <p:cNvPr id="40" name="Rectangle 39"/>
+          <p:cNvSpPr/>
+          <p:nvPr/>
+        </p:nvSpPr>
+        <p:spPr>
+          <a:xfrm>
+            <a:off x="7119620" y="2880360"/>
+            <a:ext cx="25400" cy="320040"/>
+          </a:xfrm>
+          <a:prstGeom prst="rect">
+            <a:avLst/>
+          </a:prstGeom>
+          <a:solidFill>
+            <a:srgbClr val="999999"/>
+          </a:solidFill>
+          <a:ln>
+            <a:noFill/>
           </a:ln>
         </p:spPr>
         <p:style>
-          <a:lnRef idx="2">
+          <a:lnRef idx="1">
             <a:schemeClr val="accent1"/>
           </a:lnRef>
-          <a:fillRef idx="0">
+          <a:fillRef idx="3">
             <a:schemeClr val="accent1"/>
           </a:fillRef>
-          <a:effectRef idx="1">
+          <a:effectRef idx="2">
             <a:schemeClr val="accent1"/>
           </a:effectRef>
           <a:fontRef idx="minor">
-            <a:schemeClr val="tx1"/>
+            <a:schemeClr val="lt1"/>
           </a:fontRef>
         </p:style>
-      </p:cxnSp>
-      <p:cxnSp>
-        <p:nvCxnSpPr>
-          <p:cNvPr id="41" name="Connector 40"/>
-          <p:cNvCxnSpPr/>
-          <p:nvPr/>
-        </p:nvCxnSpPr>
-        <p:spPr>
-          <a:xfrm>
-            <a:off x="8686800" y="2880360.0"/>
-            <a:ext cx="274320" cy="0.0"/>
-          </a:xfrm>
-          <a:prstGeom prst="line">
-            <a:avLst/>
-          </a:prstGeom>
-          <a:ln w="19050">
-            <a:solidFill>
-              <a:srgbClr val="888888"/>
-            </a:solidFill>
+        <p:txBody>
+          <a:bodyPr rtlCol="0" anchor="ctr"/>
+          <a:lstStyle/>
+          <a:p>
+            <a:pPr algn="ctr"/>
+          </a:p>
+        </p:txBody>
+      </p:sp>
+      <p:sp>
+        <p:nvSpPr>
+          <p:cNvPr id="41" name="Rectangle 40"/>
+          <p:cNvSpPr/>
+          <p:nvPr/>
+        </p:nvSpPr>
+        <p:spPr>
+          <a:xfrm>
+            <a:off x="8686800" y="2867660"/>
+            <a:ext cx="274320" cy="25400"/>
+          </a:xfrm>
+          <a:prstGeom prst="rect">
+            <a:avLst/>
+          </a:prstGeom>
+          <a:solidFill>
+            <a:srgbClr val="999999"/>
+          </a:solidFill>
+          <a:ln>
+            <a:noFill/>
           </a:ln>
         </p:spPr>
         <p:style>
-          <a:lnRef idx="2">
+          <a:lnRef idx="1">
             <a:schemeClr val="accent1"/>
           </a:lnRef>
-          <a:fillRef idx="0">
+          <a:fillRef idx="3">
             <a:schemeClr val="accent1"/>
           </a:fillRef>
-          <a:effectRef idx="1">
+          <a:effectRef idx="2">
             <a:schemeClr val="accent1"/>
           </a:effectRef>
           <a:fontRef idx="minor">
-            <a:schemeClr val="tx1"/>
+            <a:schemeClr val="lt1"/>
           </a:fontRef>
         </p:style>
-      </p:cxnSp>
-      <p:cxnSp>
-        <p:nvCxnSpPr>
-          <p:cNvPr id="42" name="Connector 41"/>
-          <p:cNvCxnSpPr/>
-          <p:nvPr/>
-        </p:nvCxnSpPr>
-        <p:spPr>
-          <a:xfrm>
-            <a:off x="6492240.0" y="3474720.0"/>
-            <a:ext cx="0.0" cy="502920.0"/>
-          </a:xfrm>
-          <a:prstGeom prst="line">
-            <a:avLst/>
-          </a:prstGeom>
-          <a:ln w="19050">
-            <a:solidFill>
-              <a:srgbClr val="888888"/>
-            </a:solidFill>
+        <p:txBody>
+          <a:bodyPr rtlCol="0" anchor="ctr"/>
+          <a:lstStyle/>
+          <a:p>
+            <a:pPr algn="ctr"/>
+          </a:p>
+        </p:txBody>
+      </p:sp>
+      <p:sp>
+        <p:nvSpPr>
+          <p:cNvPr id="42" name="Rectangle 41"/>
+          <p:cNvSpPr/>
+          <p:nvPr/>
+        </p:nvSpPr>
+        <p:spPr>
+          <a:xfrm>
+            <a:off x="6479540" y="3474720"/>
+            <a:ext cx="25400" cy="502920"/>
+          </a:xfrm>
+          <a:prstGeom prst="rect">
+            <a:avLst/>
+          </a:prstGeom>
+          <a:solidFill>
+            <a:srgbClr val="999999"/>
+          </a:solidFill>
+          <a:ln>
+            <a:noFill/>
           </a:ln>
         </p:spPr>
         <p:style>
-          <a:lnRef idx="2">
+          <a:lnRef idx="1">
             <a:schemeClr val="accent1"/>
           </a:lnRef>
-          <a:fillRef idx="0">
+          <a:fillRef idx="3">
             <a:schemeClr val="accent1"/>
           </a:fillRef>
-          <a:effectRef idx="1">
+          <a:effectRef idx="2">
             <a:schemeClr val="accent1"/>
           </a:effectRef>
           <a:fontRef idx="minor">
-            <a:schemeClr val="tx1"/>
+            <a:schemeClr val="lt1"/>
           </a:fontRef>
         </p:style>
-      </p:cxnSp>
-      <p:cxnSp>
-        <p:nvCxnSpPr>
-          <p:cNvPr id="43" name="Connector 42"/>
-          <p:cNvCxnSpPr/>
-          <p:nvPr/>
-        </p:nvCxnSpPr>
-        <p:spPr>
-          <a:xfrm>
-            <a:off x="8046720.0" y="3154680.0"/>
-            <a:ext cx="0.0" cy="822960.0"/>
-          </a:xfrm>
-          <a:prstGeom prst="line">
-            <a:avLst/>
-          </a:prstGeom>
-          <a:ln w="19050">
-            <a:solidFill>
-              <a:srgbClr val="888888"/>
-            </a:solidFill>
+        <p:txBody>
+          <a:bodyPr rtlCol="0" anchor="ctr"/>
+          <a:lstStyle/>
+          <a:p>
+            <a:pPr algn="ctr"/>
+          </a:p>
+        </p:txBody>
+      </p:sp>
+      <p:sp>
+        <p:nvSpPr>
+          <p:cNvPr id="43" name="Rectangle 42"/>
+          <p:cNvSpPr/>
+          <p:nvPr/>
+        </p:nvSpPr>
+        <p:spPr>
+          <a:xfrm>
+            <a:off x="8034020" y="3154680"/>
+            <a:ext cx="25400" cy="822960"/>
+          </a:xfrm>
+          <a:prstGeom prst="rect">
+            <a:avLst/>
+          </a:prstGeom>
+          <a:solidFill>
+            <a:srgbClr val="999999"/>
+          </a:solidFill>
+          <a:ln>
+            <a:noFill/>
           </a:ln>
         </p:spPr>
         <p:style>
-          <a:lnRef idx="2">
+          <a:lnRef idx="1">
             <a:schemeClr val="accent1"/>
           </a:lnRef>
-          <a:fillRef idx="0">
+          <a:fillRef idx="3">
             <a:schemeClr val="accent1"/>
           </a:fillRef>
-          <a:effectRef idx="1">
+          <a:effectRef idx="2">
             <a:schemeClr val="accent1"/>
           </a:effectRef>
           <a:fontRef idx="minor">
-            <a:schemeClr val="tx1"/>
+            <a:schemeClr val="lt1"/>
           </a:fontRef>
         </p:style>
-      </p:cxnSp>
-      <p:cxnSp>
-        <p:nvCxnSpPr>
-          <p:cNvPr id="44" name="Connector 43"/>
-          <p:cNvCxnSpPr/>
-          <p:nvPr/>
-        </p:nvCxnSpPr>
-        <p:spPr>
-          <a:xfrm>
-            <a:off x="9601200.0" y="3154680.0"/>
-            <a:ext cx="0.0" cy="822960.0"/>
-          </a:xfrm>
-          <a:prstGeom prst="line">
-            <a:avLst/>
-          </a:prstGeom>
-          <a:ln w="19050">
-            <a:solidFill>
-              <a:srgbClr val="888888"/>
-            </a:solidFill>
+        <p:txBody>
+          <a:bodyPr rtlCol="0" anchor="ctr"/>
+          <a:lstStyle/>
+          <a:p>
+            <a:pPr algn="ctr"/>
+          </a:p>
+        </p:txBody>
+      </p:sp>
+      <p:sp>
+        <p:nvSpPr>
+          <p:cNvPr id="44" name="Rectangle 43"/>
+          <p:cNvSpPr/>
+          <p:nvPr/>
+        </p:nvSpPr>
+        <p:spPr>
+          <a:xfrm>
+            <a:off x="9588500" y="3154680"/>
+            <a:ext cx="25400" cy="822960"/>
+          </a:xfrm>
+          <a:prstGeom prst="rect">
+            <a:avLst/>
+          </a:prstGeom>
+          <a:solidFill>
+            <a:srgbClr val="999999"/>
+          </a:solidFill>
+          <a:ln>
+            <a:noFill/>
           </a:ln>
         </p:spPr>
         <p:style>
-          <a:lnRef idx="2">
+          <a:lnRef idx="1">
             <a:schemeClr val="accent1"/>
           </a:lnRef>
-          <a:fillRef idx="0">
+          <a:fillRef idx="3">
             <a:schemeClr val="accent1"/>
           </a:fillRef>
-          <a:effectRef idx="1">
+          <a:effectRef idx="2">
             <a:schemeClr val="accent1"/>
           </a:effectRef>
           <a:fontRef idx="minor">
-            <a:schemeClr val="tx1"/>
+            <a:schemeClr val="lt1"/>
           </a:fontRef>
         </p:style>
-      </p:cxnSp>
-      <p:cxnSp>
-        <p:nvCxnSpPr>
-          <p:cNvPr id="45" name="Connector 44"/>
-          <p:cNvCxnSpPr/>
-          <p:nvPr/>
-        </p:nvCxnSpPr>
-        <p:spPr>
-          <a:xfrm>
-            <a:off x="7132320" y="4251960.0"/>
-            <a:ext cx="274320" cy="0.0"/>
-          </a:xfrm>
-          <a:prstGeom prst="line">
-            <a:avLst/>
-          </a:prstGeom>
-          <a:ln w="19050">
-            <a:solidFill>
-              <a:srgbClr val="888888"/>
-            </a:solidFill>
+        <p:txBody>
+          <a:bodyPr rtlCol="0" anchor="ctr"/>
+          <a:lstStyle/>
+          <a:p>
+            <a:pPr algn="ctr"/>
+          </a:p>
+        </p:txBody>
+      </p:sp>
+      <p:sp>
+        <p:nvSpPr>
+          <p:cNvPr id="45" name="Rectangle 44"/>
+          <p:cNvSpPr/>
+          <p:nvPr/>
+        </p:nvSpPr>
+        <p:spPr>
+          <a:xfrm>
+            <a:off x="7132320" y="4239260"/>
+            <a:ext cx="274320" cy="25400"/>
+          </a:xfrm>
+          <a:prstGeom prst="rect">
+            <a:avLst/>
+          </a:prstGeom>
+          <a:solidFill>
+            <a:srgbClr val="999999"/>
+          </a:solidFill>
+          <a:ln>
+            <a:noFill/>
           </a:ln>
         </p:spPr>
         <p:style>
-          <a:lnRef idx="2">
+          <a:lnRef idx="1">
             <a:schemeClr val="accent1"/>
           </a:lnRef>
-          <a:fillRef idx="0">
+          <a:fillRef idx="3">
             <a:schemeClr val="accent1"/>
           </a:fillRef>
-          <a:effectRef idx="1">
+          <a:effectRef idx="2">
             <a:schemeClr val="accent1"/>
           </a:effectRef>
           <a:fontRef idx="minor">
-            <a:schemeClr val="tx1"/>
+            <a:schemeClr val="lt1"/>
           </a:fontRef>
         </p:style>
-      </p:cxnSp>
-      <p:cxnSp>
-        <p:nvCxnSpPr>
-          <p:cNvPr id="46" name="Connector 45"/>
-          <p:cNvCxnSpPr/>
-          <p:nvPr/>
-        </p:nvCxnSpPr>
-        <p:spPr>
-          <a:xfrm>
-            <a:off x="8686800" y="4251960.0"/>
-            <a:ext cx="274320" cy="0.0"/>
-          </a:xfrm>
-          <a:prstGeom prst="line">
-            <a:avLst/>
-          </a:prstGeom>
-          <a:ln w="19050">
-            <a:solidFill>
-              <a:srgbClr val="888888"/>
-            </a:solidFill>
+        <p:txBody>
+          <a:bodyPr rtlCol="0" anchor="ctr"/>
+          <a:lstStyle/>
+          <a:p>
+            <a:pPr algn="ctr"/>
+          </a:p>
+        </p:txBody>
+      </p:sp>
+      <p:sp>
+        <p:nvSpPr>
+          <p:cNvPr id="46" name="Rectangle 45"/>
+          <p:cNvSpPr/>
+          <p:nvPr/>
+        </p:nvSpPr>
+        <p:spPr>
+          <a:xfrm>
+            <a:off x="8686800" y="4239260"/>
+            <a:ext cx="274320" cy="25400"/>
+          </a:xfrm>
+          <a:prstGeom prst="rect">
+            <a:avLst/>
+          </a:prstGeom>
+          <a:solidFill>
+            <a:srgbClr val="999999"/>
+          </a:solidFill>
+          <a:ln>
+            <a:noFill/>
           </a:ln>
         </p:spPr>
         <p:style>
-          <a:lnRef idx="2">
+          <a:lnRef idx="1">
             <a:schemeClr val="accent1"/>
           </a:lnRef>
-          <a:fillRef idx="0">
+          <a:fillRef idx="3">
             <a:schemeClr val="accent1"/>
           </a:fillRef>
-          <a:effectRef idx="1">
+          <a:effectRef idx="2">
             <a:schemeClr val="accent1"/>
           </a:effectRef>
           <a:fontRef idx="minor">
-            <a:schemeClr val="tx1"/>
+            <a:schemeClr val="lt1"/>
           </a:fontRef>
         </p:style>
-      </p:cxnSp>
-      <p:cxnSp>
-        <p:nvCxnSpPr>
-          <p:cNvPr id="47" name="Connector 46"/>
-          <p:cNvCxnSpPr/>
-          <p:nvPr/>
-        </p:nvCxnSpPr>
-        <p:spPr>
-          <a:xfrm>
-            <a:off x="2286000.0" y="3154680.0"/>
-            <a:ext cx="0.0" cy="2194560.0"/>
-          </a:xfrm>
-          <a:prstGeom prst="line">
-            <a:avLst/>
-          </a:prstGeom>
-          <a:ln w="19050">
-            <a:solidFill>
-              <a:srgbClr val="888888"/>
-            </a:solidFill>
+        <p:txBody>
+          <a:bodyPr rtlCol="0" anchor="ctr"/>
+          <a:lstStyle/>
+          <a:p>
+            <a:pPr algn="ctr"/>
+          </a:p>
+        </p:txBody>
+      </p:sp>
+      <p:sp>
+        <p:nvSpPr>
+          <p:cNvPr id="47" name="Rectangle 46"/>
+          <p:cNvSpPr/>
+          <p:nvPr/>
+        </p:nvSpPr>
+        <p:spPr>
+          <a:xfrm>
+            <a:off x="2273300" y="3154680"/>
+            <a:ext cx="25400" cy="2194560"/>
+          </a:xfrm>
+          <a:prstGeom prst="rect">
+            <a:avLst/>
+          </a:prstGeom>
+          <a:solidFill>
+            <a:srgbClr val="999999"/>
+          </a:solidFill>
+          <a:ln>
+            <a:noFill/>
           </a:ln>
         </p:spPr>
         <p:style>
-          <a:lnRef idx="2">
+          <a:lnRef idx="1">
             <a:schemeClr val="accent1"/>
           </a:lnRef>
-          <a:fillRef idx="0">
+          <a:fillRef idx="3">
             <a:schemeClr val="accent1"/>
           </a:fillRef>
-          <a:effectRef idx="1">
+          <a:effectRef idx="2">
             <a:schemeClr val="accent1"/>
           </a:effectRef>
           <a:fontRef idx="minor">
-            <a:schemeClr val="tx1"/>
+            <a:schemeClr val="lt1"/>
           </a:fontRef>
         </p:style>
-      </p:cxnSp>
-      <p:cxnSp>
-        <p:nvCxnSpPr>
-          <p:cNvPr id="48" name="Connector 47"/>
-          <p:cNvCxnSpPr/>
-          <p:nvPr/>
-        </p:nvCxnSpPr>
-        <p:spPr>
-          <a:xfrm>
-            <a:off x="9601200.0" y="3154680.0"/>
-            <a:ext cx="0.0" cy="2194560.0"/>
-          </a:xfrm>
-          <a:prstGeom prst="line">
-            <a:avLst/>
-          </a:prstGeom>
-          <a:ln w="19050">
-            <a:solidFill>
-              <a:srgbClr val="888888"/>
-            </a:solidFill>
+        <p:txBody>
+          <a:bodyPr rtlCol="0" anchor="ctr"/>
+          <a:lstStyle/>
+          <a:p>
+            <a:pPr algn="ctr"/>
+          </a:p>
+        </p:txBody>
+      </p:sp>
+      <p:sp>
+        <p:nvSpPr>
+          <p:cNvPr id="48" name="Rectangle 47"/>
+          <p:cNvSpPr/>
+          <p:nvPr/>
+        </p:nvSpPr>
+        <p:spPr>
+          <a:xfrm>
+            <a:off x="9588500" y="3154680"/>
+            <a:ext cx="25400" cy="2194560"/>
+          </a:xfrm>
+          <a:prstGeom prst="rect">
+            <a:avLst/>
+          </a:prstGeom>
+          <a:solidFill>
+            <a:srgbClr val="999999"/>
+          </a:solidFill>
+          <a:ln>
+            <a:noFill/>
           </a:ln>
         </p:spPr>
         <p:style>
-          <a:lnRef idx="2">
+          <a:lnRef idx="1">
             <a:schemeClr val="accent1"/>
           </a:lnRef>
-          <a:fillRef idx="0">
+          <a:fillRef idx="3">
             <a:schemeClr val="accent1"/>
           </a:fillRef>
-          <a:effectRef idx="1">
+          <a:effectRef idx="2">
             <a:schemeClr val="accent1"/>
           </a:effectRef>
           <a:fontRef idx="minor">
-            <a:schemeClr val="tx1"/>
+            <a:schemeClr val="lt1"/>
           </a:fontRef>
         </p:style>
-      </p:cxnSp>
-      <p:cxnSp>
-        <p:nvCxnSpPr>
-          <p:cNvPr id="49" name="Connector 48"/>
-          <p:cNvCxnSpPr/>
-          <p:nvPr/>
-        </p:nvCxnSpPr>
-        <p:spPr>
-          <a:xfrm>
-            <a:off x="2926080" y="5623560.0"/>
-            <a:ext cx="274320" cy="0.0"/>
-          </a:xfrm>
-          <a:prstGeom prst="line">
-            <a:avLst/>
-          </a:prstGeom>
-          <a:ln w="19050">
-            <a:solidFill>
-              <a:srgbClr val="888888"/>
-            </a:solidFill>
+        <p:txBody>
+          <a:bodyPr rtlCol="0" anchor="ctr"/>
+          <a:lstStyle/>
+          <a:p>
+            <a:pPr algn="ctr"/>
+          </a:p>
+        </p:txBody>
+      </p:sp>
+      <p:sp>
+        <p:nvSpPr>
+          <p:cNvPr id="49" name="Rectangle 48"/>
+          <p:cNvSpPr/>
+          <p:nvPr/>
+        </p:nvSpPr>
+        <p:spPr>
+          <a:xfrm>
+            <a:off x="2926080" y="5610860"/>
+            <a:ext cx="274320" cy="25400"/>
+          </a:xfrm>
+          <a:prstGeom prst="rect">
+            <a:avLst/>
+          </a:prstGeom>
+          <a:solidFill>
+            <a:srgbClr val="999999"/>
+          </a:solidFill>
+          <a:ln>
+            <a:noFill/>
           </a:ln>
         </p:spPr>
         <p:style>
-          <a:lnRef idx="2">
+          <a:lnRef idx="1">
             <a:schemeClr val="accent1"/>
           </a:lnRef>
-          <a:fillRef idx="0">
+          <a:fillRef idx="3">
             <a:schemeClr val="accent1"/>
           </a:fillRef>
-          <a:effectRef idx="1">
+          <a:effectRef idx="2">
             <a:schemeClr val="accent1"/>
           </a:effectRef>
           <a:fontRef idx="minor">
-            <a:schemeClr val="tx1"/>
+            <a:schemeClr val="lt1"/>
           </a:fontRef>
         </p:style>
-      </p:cxnSp>
-      <p:cxnSp>
-        <p:nvCxnSpPr>
-          <p:cNvPr id="50" name="Connector 49"/>
-          <p:cNvCxnSpPr/>
-          <p:nvPr/>
-        </p:nvCxnSpPr>
-        <p:spPr>
-          <a:xfrm>
-            <a:off x="4480560" y="5623560.0"/>
-            <a:ext cx="274320" cy="0.0"/>
-          </a:xfrm>
-          <a:prstGeom prst="line">
-            <a:avLst/>
-          </a:prstGeom>
-          <a:ln w="19050">
-            <a:solidFill>
-              <a:srgbClr val="888888"/>
-            </a:solidFill>
+        <p:txBody>
+          <a:bodyPr rtlCol="0" anchor="ctr"/>
+          <a:lstStyle/>
+          <a:p>
+            <a:pPr algn="ctr"/>
+          </a:p>
+        </p:txBody>
+      </p:sp>
+      <p:sp>
+        <p:nvSpPr>
+          <p:cNvPr id="50" name="Rectangle 49"/>
+          <p:cNvSpPr/>
+          <p:nvPr/>
+        </p:nvSpPr>
+        <p:spPr>
+          <a:xfrm>
+            <a:off x="4480560" y="5610860"/>
+            <a:ext cx="274320" cy="25400"/>
+          </a:xfrm>
+          <a:prstGeom prst="rect">
+            <a:avLst/>
+          </a:prstGeom>
+          <a:solidFill>
+            <a:srgbClr val="999999"/>
+          </a:solidFill>
+          <a:ln>
+            <a:noFill/>
           </a:ln>
         </p:spPr>
         <p:style>
-          <a:lnRef idx="2">
+          <a:lnRef idx="1">
             <a:schemeClr val="accent1"/>
           </a:lnRef>
-          <a:fillRef idx="0">
+          <a:fillRef idx="3">
             <a:schemeClr val="accent1"/>
           </a:fillRef>
-          <a:effectRef idx="1">
+          <a:effectRef idx="2">
             <a:schemeClr val="accent1"/>
           </a:effectRef>
           <a:fontRef idx="minor">
-            <a:schemeClr val="tx1"/>
+            <a:schemeClr val="lt1"/>
           </a:fontRef>
         </p:style>
-      </p:cxnSp>
+        <p:txBody>
+          <a:bodyPr rtlCol="0" anchor="ctr"/>
+          <a:lstStyle/>
+          <a:p>
+            <a:pPr algn="ctr"/>
+          </a:p>
+        </p:txBody>
+      </p:sp>
       <p:sp>
         <p:nvSpPr>
           <p:cNvPr id="51" name="TextBox 50"/>
@@ -12301,181 +12461,221 @@
           </a:p>
         </p:txBody>
       </p:sp>
-      <p:cxnSp>
-        <p:nvCxnSpPr>
-          <p:cNvPr id="31" name="Connector 30"/>
-          <p:cNvCxnSpPr/>
-          <p:nvPr/>
-        </p:nvCxnSpPr>
-        <p:spPr>
-          <a:xfrm>
-            <a:off x="3474720" y="2103120"/>
-            <a:ext cx="640080" cy="0"/>
-          </a:xfrm>
-          <a:prstGeom prst="line">
-            <a:avLst/>
-          </a:prstGeom>
-          <a:ln w="19050">
-            <a:solidFill>
-              <a:srgbClr val="888888"/>
-            </a:solidFill>
+      <p:sp>
+        <p:nvSpPr>
+          <p:cNvPr id="31" name="Rectangle 30"/>
+          <p:cNvSpPr/>
+          <p:nvPr/>
+        </p:nvSpPr>
+        <p:spPr>
+          <a:xfrm>
+            <a:off x="3474720" y="2090420"/>
+            <a:ext cx="640080" cy="25400"/>
+          </a:xfrm>
+          <a:prstGeom prst="rect">
+            <a:avLst/>
+          </a:prstGeom>
+          <a:solidFill>
+            <a:srgbClr val="999999"/>
+          </a:solidFill>
+          <a:ln>
+            <a:noFill/>
           </a:ln>
         </p:spPr>
         <p:style>
-          <a:lnRef idx="2">
+          <a:lnRef idx="1">
             <a:schemeClr val="accent1"/>
           </a:lnRef>
-          <a:fillRef idx="0">
+          <a:fillRef idx="3">
             <a:schemeClr val="accent1"/>
           </a:fillRef>
-          <a:effectRef idx="1">
+          <a:effectRef idx="2">
             <a:schemeClr val="accent1"/>
           </a:effectRef>
           <a:fontRef idx="minor">
-            <a:schemeClr val="tx1"/>
+            <a:schemeClr val="lt1"/>
           </a:fontRef>
         </p:style>
-      </p:cxnSp>
-      <p:cxnSp>
-        <p:nvCxnSpPr>
-          <p:cNvPr id="32" name="Connector 31"/>
-          <p:cNvCxnSpPr/>
-          <p:nvPr/>
-        </p:nvCxnSpPr>
-        <p:spPr>
-          <a:xfrm>
-            <a:off x="5394960" y="2834640"/>
-            <a:ext cx="0" cy="640080"/>
-          </a:xfrm>
-          <a:prstGeom prst="line">
-            <a:avLst/>
-          </a:prstGeom>
-          <a:ln w="19050">
-            <a:solidFill>
-              <a:srgbClr val="888888"/>
-            </a:solidFill>
+        <p:txBody>
+          <a:bodyPr rtlCol="0" anchor="ctr"/>
+          <a:lstStyle/>
+          <a:p>
+            <a:pPr algn="ctr"/>
+          </a:p>
+        </p:txBody>
+      </p:sp>
+      <p:sp>
+        <p:nvSpPr>
+          <p:cNvPr id="32" name="Rectangle 31"/>
+          <p:cNvSpPr/>
+          <p:nvPr/>
+        </p:nvSpPr>
+        <p:spPr>
+          <a:xfrm>
+            <a:off x="5382260" y="2834640"/>
+            <a:ext cx="25400" cy="640080"/>
+          </a:xfrm>
+          <a:prstGeom prst="rect">
+            <a:avLst/>
+          </a:prstGeom>
+          <a:solidFill>
+            <a:srgbClr val="999999"/>
+          </a:solidFill>
+          <a:ln>
+            <a:noFill/>
           </a:ln>
         </p:spPr>
         <p:style>
-          <a:lnRef idx="2">
+          <a:lnRef idx="1">
             <a:schemeClr val="accent1"/>
           </a:lnRef>
-          <a:fillRef idx="0">
+          <a:fillRef idx="3">
             <a:schemeClr val="accent1"/>
           </a:fillRef>
-          <a:effectRef idx="1">
+          <a:effectRef idx="2">
             <a:schemeClr val="accent1"/>
           </a:effectRef>
           <a:fontRef idx="minor">
-            <a:schemeClr val="tx1"/>
+            <a:schemeClr val="lt1"/>
           </a:fontRef>
         </p:style>
-      </p:cxnSp>
-      <p:cxnSp>
-        <p:nvCxnSpPr>
-          <p:cNvPr id="33" name="Connector 32"/>
-          <p:cNvCxnSpPr/>
-          <p:nvPr/>
-        </p:nvCxnSpPr>
-        <p:spPr>
-          <a:xfrm>
-            <a:off x="2194560" y="2834640"/>
-            <a:ext cx="0" cy="640080"/>
-          </a:xfrm>
-          <a:prstGeom prst="line">
-            <a:avLst/>
-          </a:prstGeom>
-          <a:ln w="19050">
-            <a:solidFill>
-              <a:srgbClr val="888888"/>
-            </a:solidFill>
+        <p:txBody>
+          <a:bodyPr rtlCol="0" anchor="ctr"/>
+          <a:lstStyle/>
+          <a:p>
+            <a:pPr algn="ctr"/>
+          </a:p>
+        </p:txBody>
+      </p:sp>
+      <p:sp>
+        <p:nvSpPr>
+          <p:cNvPr id="33" name="Rectangle 32"/>
+          <p:cNvSpPr/>
+          <p:nvPr/>
+        </p:nvSpPr>
+        <p:spPr>
+          <a:xfrm>
+            <a:off x="2181860" y="2834640"/>
+            <a:ext cx="25400" cy="640080"/>
+          </a:xfrm>
+          <a:prstGeom prst="rect">
+            <a:avLst/>
+          </a:prstGeom>
+          <a:solidFill>
+            <a:srgbClr val="999999"/>
+          </a:solidFill>
+          <a:ln>
+            <a:noFill/>
           </a:ln>
         </p:spPr>
         <p:style>
-          <a:lnRef idx="2">
+          <a:lnRef idx="1">
             <a:schemeClr val="accent1"/>
           </a:lnRef>
-          <a:fillRef idx="0">
+          <a:fillRef idx="3">
             <a:schemeClr val="accent1"/>
           </a:fillRef>
-          <a:effectRef idx="1">
+          <a:effectRef idx="2">
             <a:schemeClr val="accent1"/>
           </a:effectRef>
           <a:fontRef idx="minor">
-            <a:schemeClr val="tx1"/>
+            <a:schemeClr val="lt1"/>
           </a:fontRef>
         </p:style>
-      </p:cxnSp>
-      <p:cxnSp>
-        <p:nvCxnSpPr>
-          <p:cNvPr id="34" name="Connector 33"/>
-          <p:cNvCxnSpPr/>
-          <p:nvPr/>
-        </p:nvCxnSpPr>
-        <p:spPr>
-          <a:xfrm>
-            <a:off x="6675120" y="2103120"/>
-            <a:ext cx="640080" cy="0"/>
-          </a:xfrm>
-          <a:prstGeom prst="line">
-            <a:avLst/>
-          </a:prstGeom>
-          <a:ln w="19050">
-            <a:solidFill>
-              <a:srgbClr val="888888"/>
-            </a:solidFill>
+        <p:txBody>
+          <a:bodyPr rtlCol="0" anchor="ctr"/>
+          <a:lstStyle/>
+          <a:p>
+            <a:pPr algn="ctr"/>
+          </a:p>
+        </p:txBody>
+      </p:sp>
+      <p:sp>
+        <p:nvSpPr>
+          <p:cNvPr id="34" name="Rectangle 33"/>
+          <p:cNvSpPr/>
+          <p:nvPr/>
+        </p:nvSpPr>
+        <p:spPr>
+          <a:xfrm>
+            <a:off x="6675120" y="2090420"/>
+            <a:ext cx="640080" cy="25400"/>
+          </a:xfrm>
+          <a:prstGeom prst="rect">
+            <a:avLst/>
+          </a:prstGeom>
+          <a:solidFill>
+            <a:srgbClr val="999999"/>
+          </a:solidFill>
+          <a:ln>
+            <a:noFill/>
           </a:ln>
         </p:spPr>
         <p:style>
-          <a:lnRef idx="2">
+          <a:lnRef idx="1">
             <a:schemeClr val="accent1"/>
           </a:lnRef>
-          <a:fillRef idx="0">
+          <a:fillRef idx="3">
             <a:schemeClr val="accent1"/>
           </a:fillRef>
-          <a:effectRef idx="1">
+          <a:effectRef idx="2">
             <a:schemeClr val="accent1"/>
           </a:effectRef>
           <a:fontRef idx="minor">
-            <a:schemeClr val="tx1"/>
+            <a:schemeClr val="lt1"/>
           </a:fontRef>
         </p:style>
-      </p:cxnSp>
-      <p:cxnSp>
-        <p:nvCxnSpPr>
-          <p:cNvPr id="35" name="Connector 34"/>
-          <p:cNvCxnSpPr/>
-          <p:nvPr/>
-        </p:nvCxnSpPr>
-        <p:spPr>
-          <a:xfrm>
-            <a:off x="6675120" y="4206240"/>
-            <a:ext cx="640080" cy="0"/>
-          </a:xfrm>
-          <a:prstGeom prst="line">
-            <a:avLst/>
-          </a:prstGeom>
-          <a:ln w="19050">
-            <a:solidFill>
-              <a:srgbClr val="888888"/>
-            </a:solidFill>
+        <p:txBody>
+          <a:bodyPr rtlCol="0" anchor="ctr"/>
+          <a:lstStyle/>
+          <a:p>
+            <a:pPr algn="ctr"/>
+          </a:p>
+        </p:txBody>
+      </p:sp>
+      <p:sp>
+        <p:nvSpPr>
+          <p:cNvPr id="35" name="Rectangle 34"/>
+          <p:cNvSpPr/>
+          <p:nvPr/>
+        </p:nvSpPr>
+        <p:spPr>
+          <a:xfrm>
+            <a:off x="6675120" y="4193540"/>
+            <a:ext cx="640080" cy="25400"/>
+          </a:xfrm>
+          <a:prstGeom prst="rect">
+            <a:avLst/>
+          </a:prstGeom>
+          <a:solidFill>
+            <a:srgbClr val="999999"/>
+          </a:solidFill>
+          <a:ln>
+            <a:noFill/>
           </a:ln>
         </p:spPr>
         <p:style>
-          <a:lnRef idx="2">
+          <a:lnRef idx="1">
             <a:schemeClr val="accent1"/>
           </a:lnRef>
-          <a:fillRef idx="0">
+          <a:fillRef idx="3">
             <a:schemeClr val="accent1"/>
           </a:fillRef>
-          <a:effectRef idx="1">
+          <a:effectRef idx="2">
             <a:schemeClr val="accent1"/>
           </a:effectRef>
           <a:fontRef idx="minor">
-            <a:schemeClr val="tx1"/>
+            <a:schemeClr val="lt1"/>
           </a:fontRef>
         </p:style>
-      </p:cxnSp>
+        <p:txBody>
+          <a:bodyPr rtlCol="0" anchor="ctr"/>
+          <a:lstStyle/>
+          <a:p>
+            <a:pPr algn="ctr"/>
+          </a:p>
+        </p:txBody>
+      </p:sp>
     </p:spTree>
   </p:cSld>
   <p:clrMapOvr>

</xml_diff>

<commit_message>
Replace broken BPMN with clean 3-row flow diagram
Old BPMN had 4 swimlanes with tiny 2pt rectangle arrows that
PowerPoint couldn't render. Replaced with:

Row 1 "ОБРАБОТКА ВВОДА": Input → Normalize → Spell → Personalization → Result
Row 2 "ПОИСКОВЫЙ ДВИЖОК": Short/Full mode → Subject Boost → Function Score → RAG
Row 3 "СЛОЙ ДАННЫХ": ES / Redis / PG / Ollama

Large readable boxes (2" wide) with color-coded left bars,
thick arrows (3pt), no connectors. 80 shapes, 0 connectors.

Co-Authored-By: Claude Opus 4.6 (1M context) <noreply@anthropic.com>
</commit_message>
<xml_diff>
--- a/docs/TenderHack2026_Presentation.pptx
+++ b/docs/TenderHack2026_Presentation.pptx
@@ -5617,7 +5617,7 @@
     <p:bg>
       <p:bgPr>
         <a:solidFill>
-          <a:srgbClr val="FFFFFF"/>
+          <a:srgbClr val="F5F5F5"/>
         </a:solidFill>
         <a:effectLst/>
       </p:bgPr>
@@ -5737,7 +5737,7 @@
               </a:defRPr>
             </a:pPr>
             <a:r>
-              <a:t>ПРОЦЕСС ОБРАБОТКИ ЗАПРОСА (BPMN)</a:t>
+              <a:t>ПАЙПЛАЙН ОБРАБОТКИ ЗАПРОСА</a:t>
             </a:r>
           </a:p>
         </p:txBody>
@@ -5787,24 +5787,59 @@
       </p:sp>
       <p:sp>
         <p:nvSpPr>
-          <p:cNvPr id="6" name="Rectangle 5"/>
+          <p:cNvPr id="6" name="TextBox 5"/>
+          <p:cNvSpPr txBox="1"/>
+          <p:nvPr/>
+        </p:nvSpPr>
+        <p:spPr>
+          <a:xfrm>
+            <a:off x="457200" y="777240"/>
+            <a:ext cx="2743200" cy="274320"/>
+          </a:xfrm>
+          <a:prstGeom prst="rect">
+            <a:avLst/>
+          </a:prstGeom>
+          <a:noFill/>
+        </p:spPr>
+        <p:txBody>
+          <a:bodyPr wrap="square">
+            <a:spAutoFit/>
+          </a:bodyPr>
+          <a:lstStyle/>
+          <a:p>
+            <a:pPr algn="l">
+              <a:defRPr sz="1100" b="1">
+                <a:solidFill>
+                  <a:srgbClr val="E53935"/>
+                </a:solidFill>
+              </a:defRPr>
+            </a:pPr>
+            <a:r>
+              <a:t>ОБРАБОТКА ВВОДА</a:t>
+            </a:r>
+          </a:p>
+        </p:txBody>
+      </p:sp>
+      <p:sp>
+        <p:nvSpPr>
+          <p:cNvPr id="7" name="Rounded Rectangle 6"/>
           <p:cNvSpPr/>
           <p:nvPr/>
         </p:nvSpPr>
         <p:spPr>
           <a:xfrm>
-            <a:off x="365760" y="914400"/>
-            <a:ext cx="11430000" cy="1188720"/>
-          </a:xfrm>
-          <a:prstGeom prst="rect">
+            <a:off x="457200" y="1097280"/>
+            <a:ext cx="1828800" cy="1097280"/>
+          </a:xfrm>
+          <a:prstGeom prst="roundRect">
             <a:avLst/>
           </a:prstGeom>
           <a:solidFill>
-            <a:srgbClr val="E3F2FD"/>
+            <a:srgbClr val="FFFFFF"/>
           </a:solidFill>
-          <a:ln w="12700">
+          <a:ln w="19050">
             <a:solidFill>
-              <a:srgbClr val="D0D0D0"/>
+              <a:srgbClr val="1976D2"/>
             </a:solidFill>
           </a:ln>
         </p:spPr>
@@ -5832,60 +5867,23 @@
       </p:sp>
       <p:sp>
         <p:nvSpPr>
-          <p:cNvPr id="7" name="TextBox 6"/>
-          <p:cNvSpPr txBox="1"/>
-          <p:nvPr/>
-        </p:nvSpPr>
-        <p:spPr>
-          <a:xfrm>
-            <a:off x="411480" y="932688"/>
-            <a:ext cx="1005840" cy="228600"/>
-          </a:xfrm>
-          <a:prstGeom prst="rect">
-            <a:avLst/>
-          </a:prstGeom>
-          <a:noFill/>
-        </p:spPr>
-        <p:txBody>
-          <a:bodyPr wrap="square">
-            <a:spAutoFit/>
-          </a:bodyPr>
-          <a:lstStyle/>
-          <a:p>
-            <a:pPr algn="l">
-              <a:defRPr sz="800" b="1">
-                <a:solidFill>
-                  <a:srgbClr val="334059"/>
-                </a:solidFill>
-              </a:defRPr>
-            </a:pPr>
-            <a:r>
-              <a:t>Пользователь</a:t>
-            </a:r>
-          </a:p>
-        </p:txBody>
-      </p:sp>
-      <p:sp>
-        <p:nvSpPr>
           <p:cNvPr id="8" name="Rectangle 7"/>
           <p:cNvSpPr/>
           <p:nvPr/>
         </p:nvSpPr>
         <p:spPr>
           <a:xfrm>
-            <a:off x="365760" y="2286000"/>
-            <a:ext cx="11430000" cy="1188720"/>
+            <a:off x="484632" y="1188720"/>
+            <a:ext cx="73152" cy="914400"/>
           </a:xfrm>
           <a:prstGeom prst="rect">
             <a:avLst/>
           </a:prstGeom>
           <a:solidFill>
-            <a:srgbClr val="FBE9E7"/>
+            <a:srgbClr val="1976D2"/>
           </a:solidFill>
-          <a:ln w="12700">
-            <a:solidFill>
-              <a:srgbClr val="D0D0D0"/>
-            </a:solidFill>
+          <a:ln>
+            <a:noFill/>
           </a:ln>
         </p:spPr>
         <p:style>
@@ -5918,8 +5916,8 @@
         </p:nvSpPr>
         <p:spPr>
           <a:xfrm>
-            <a:off x="411480" y="2304288"/>
-            <a:ext cx="1005840" cy="228600"/>
+            <a:off x="685800" y="1234440"/>
+            <a:ext cx="1463040" cy="365760"/>
           </a:xfrm>
           <a:prstGeom prst="rect">
             <a:avLst/>
@@ -5933,39 +5931,76 @@
           <a:lstStyle/>
           <a:p>
             <a:pPr algn="l">
-              <a:defRPr sz="800" b="1">
+              <a:defRPr sz="1300" b="1">
                 <a:solidFill>
                   <a:srgbClr val="334059"/>
                 </a:solidFill>
               </a:defRPr>
             </a:pPr>
             <a:r>
-              <a:t>Backend (FastAPI)</a:t>
-            </a:r>
-          </a:p>
-        </p:txBody>
-      </p:sp>
-      <p:sp>
-        <p:nvSpPr>
-          <p:cNvPr id="10" name="Rectangle 9"/>
+              <a:t>Ввод запроса</a:t>
+            </a:r>
+          </a:p>
+        </p:txBody>
+      </p:sp>
+      <p:sp>
+        <p:nvSpPr>
+          <p:cNvPr id="10" name="TextBox 9"/>
+          <p:cNvSpPr txBox="1"/>
+          <p:nvPr/>
+        </p:nvSpPr>
+        <p:spPr>
+          <a:xfrm>
+            <a:off x="685800" y="1600200"/>
+            <a:ext cx="1463040" cy="457200"/>
+          </a:xfrm>
+          <a:prstGeom prst="rect">
+            <a:avLst/>
+          </a:prstGeom>
+          <a:noFill/>
+        </p:spPr>
+        <p:txBody>
+          <a:bodyPr wrap="square">
+            <a:spAutoFit/>
+          </a:bodyPr>
+          <a:lstStyle/>
+          <a:p>
+            <a:pPr algn="l">
+              <a:defRPr sz="1000" b="0">
+                <a:solidFill>
+                  <a:srgbClr val="666666"/>
+                </a:solidFill>
+              </a:defRPr>
+            </a:pPr>
+            <a:r>
+              <a:t>Строка поиска</a:t>
+            </a:r>
+            <a:br/>
+            <a:r>
+              <a:t>Автокомплит</a:t>
+            </a:r>
+          </a:p>
+        </p:txBody>
+      </p:sp>
+      <p:sp>
+        <p:nvSpPr>
+          <p:cNvPr id="11" name="Rectangle 10"/>
           <p:cNvSpPr/>
           <p:nvPr/>
         </p:nvSpPr>
         <p:spPr>
           <a:xfrm>
-            <a:off x="365760" y="3657600"/>
-            <a:ext cx="11430000" cy="1188720"/>
+            <a:off x="2331720" y="1620520"/>
+            <a:ext cx="320040" cy="50800"/>
           </a:xfrm>
           <a:prstGeom prst="rect">
             <a:avLst/>
           </a:prstGeom>
           <a:solidFill>
-            <a:srgbClr val="E8F5E9"/>
+            <a:srgbClr val="BBBBBB"/>
           </a:solidFill>
-          <a:ln w="12700">
-            <a:solidFill>
-              <a:srgbClr val="D0D0D0"/>
-            </a:solidFill>
+          <a:ln>
+            <a:noFill/>
           </a:ln>
         </p:spPr>
         <p:style>
@@ -5992,60 +6027,23 @@
       </p:sp>
       <p:sp>
         <p:nvSpPr>
-          <p:cNvPr id="11" name="TextBox 10"/>
-          <p:cNvSpPr txBox="1"/>
-          <p:nvPr/>
-        </p:nvSpPr>
-        <p:spPr>
-          <a:xfrm>
-            <a:off x="411480" y="3675888"/>
-            <a:ext cx="1005840" cy="228600"/>
-          </a:xfrm>
-          <a:prstGeom prst="rect">
-            <a:avLst/>
-          </a:prstGeom>
-          <a:noFill/>
-        </p:spPr>
-        <p:txBody>
-          <a:bodyPr wrap="square">
-            <a:spAutoFit/>
-          </a:bodyPr>
-          <a:lstStyle/>
-          <a:p>
-            <a:pPr algn="l">
-              <a:defRPr sz="800" b="1">
-                <a:solidFill>
-                  <a:srgbClr val="334059"/>
-                </a:solidFill>
-              </a:defRPr>
-            </a:pPr>
-            <a:r>
-              <a:t>Elasticsearch</a:t>
-            </a:r>
-          </a:p>
-        </p:txBody>
-      </p:sp>
-      <p:sp>
-        <p:nvSpPr>
-          <p:cNvPr id="12" name="Rectangle 11"/>
+          <p:cNvPr id="12" name="Isosceles Triangle 11"/>
           <p:cNvSpPr/>
           <p:nvPr/>
         </p:nvSpPr>
         <p:spPr>
-          <a:xfrm>
-            <a:off x="365760" y="5029200"/>
-            <a:ext cx="11430000" cy="1188720"/>
-          </a:xfrm>
-          <a:prstGeom prst="rect">
+          <a:xfrm rot="5400000">
+            <a:off x="2542032" y="1572768"/>
+            <a:ext cx="146304" cy="146304"/>
+          </a:xfrm>
+          <a:prstGeom prst="triangle">
             <a:avLst/>
           </a:prstGeom>
           <a:solidFill>
-            <a:srgbClr val="FEF3E2"/>
+            <a:srgbClr val="BBBBBB"/>
           </a:solidFill>
-          <a:ln w="12700">
-            <a:solidFill>
-              <a:srgbClr val="D0D0D0"/>
-            </a:solidFill>
+          <a:ln>
+            <a:noFill/>
           </a:ln>
         </p:spPr>
         <p:style>
@@ -6072,14 +6070,102 @@
       </p:sp>
       <p:sp>
         <p:nvSpPr>
-          <p:cNvPr id="13" name="TextBox 12"/>
-          <p:cNvSpPr txBox="1"/>
-          <p:nvPr/>
-        </p:nvSpPr>
-        <p:spPr>
-          <a:xfrm>
-            <a:off x="411480" y="5047488"/>
-            <a:ext cx="1005840" cy="228600"/>
+          <p:cNvPr id="13" name="Rounded Rectangle 12"/>
+          <p:cNvSpPr/>
+          <p:nvPr/>
+        </p:nvSpPr>
+        <p:spPr>
+          <a:xfrm>
+            <a:off x="2743200" y="1097280"/>
+            <a:ext cx="1828800" cy="1097280"/>
+          </a:xfrm>
+          <a:prstGeom prst="roundRect">
+            <a:avLst/>
+          </a:prstGeom>
+          <a:solidFill>
+            <a:srgbClr val="FFFFFF"/>
+          </a:solidFill>
+          <a:ln w="19050">
+            <a:solidFill>
+              <a:srgbClr val="1976D2"/>
+            </a:solidFill>
+          </a:ln>
+        </p:spPr>
+        <p:style>
+          <a:lnRef idx="1">
+            <a:schemeClr val="accent1"/>
+          </a:lnRef>
+          <a:fillRef idx="3">
+            <a:schemeClr val="accent1"/>
+          </a:fillRef>
+          <a:effectRef idx="2">
+            <a:schemeClr val="accent1"/>
+          </a:effectRef>
+          <a:fontRef idx="minor">
+            <a:schemeClr val="lt1"/>
+          </a:fontRef>
+        </p:style>
+        <p:txBody>
+          <a:bodyPr rtlCol="0" anchor="ctr"/>
+          <a:lstStyle/>
+          <a:p>
+            <a:pPr algn="ctr"/>
+          </a:p>
+        </p:txBody>
+      </p:sp>
+      <p:sp>
+        <p:nvSpPr>
+          <p:cNvPr id="14" name="Rectangle 13"/>
+          <p:cNvSpPr/>
+          <p:nvPr/>
+        </p:nvSpPr>
+        <p:spPr>
+          <a:xfrm>
+            <a:off x="2770632" y="1188720"/>
+            <a:ext cx="73152" cy="914400"/>
+          </a:xfrm>
+          <a:prstGeom prst="rect">
+            <a:avLst/>
+          </a:prstGeom>
+          <a:solidFill>
+            <a:srgbClr val="1976D2"/>
+          </a:solidFill>
+          <a:ln>
+            <a:noFill/>
+          </a:ln>
+        </p:spPr>
+        <p:style>
+          <a:lnRef idx="1">
+            <a:schemeClr val="accent1"/>
+          </a:lnRef>
+          <a:fillRef idx="3">
+            <a:schemeClr val="accent1"/>
+          </a:fillRef>
+          <a:effectRef idx="2">
+            <a:schemeClr val="accent1"/>
+          </a:effectRef>
+          <a:fontRef idx="minor">
+            <a:schemeClr val="lt1"/>
+          </a:fontRef>
+        </p:style>
+        <p:txBody>
+          <a:bodyPr rtlCol="0" anchor="ctr"/>
+          <a:lstStyle/>
+          <a:p>
+            <a:pPr algn="ctr"/>
+          </a:p>
+        </p:txBody>
+      </p:sp>
+      <p:sp>
+        <p:nvSpPr>
+          <p:cNvPr id="15" name="TextBox 14"/>
+          <p:cNvSpPr txBox="1"/>
+          <p:nvPr/>
+        </p:nvSpPr>
+        <p:spPr>
+          <a:xfrm>
+            <a:off x="2971800" y="1234440"/>
+            <a:ext cx="1463040" cy="365760"/>
           </a:xfrm>
           <a:prstGeom prst="rect">
             <a:avLst/>
@@ -6093,30 +6179,696 @@
           <a:lstStyle/>
           <a:p>
             <a:pPr algn="l">
-              <a:defRPr sz="800" b="1">
+              <a:defRPr sz="1300" b="1">
                 <a:solidFill>
                   <a:srgbClr val="334059"/>
                 </a:solidFill>
               </a:defRPr>
             </a:pPr>
             <a:r>
-              <a:t>Redis / PostgreSQL</a:t>
-            </a:r>
-          </a:p>
-        </p:txBody>
-      </p:sp>
-      <p:sp>
-        <p:nvSpPr>
-          <p:cNvPr id="14" name="Oval 13"/>
+              <a:t>Нормализация</a:t>
+            </a:r>
+          </a:p>
+        </p:txBody>
+      </p:sp>
+      <p:sp>
+        <p:nvSpPr>
+          <p:cNvPr id="16" name="TextBox 15"/>
+          <p:cNvSpPr txBox="1"/>
+          <p:nvPr/>
+        </p:nvSpPr>
+        <p:spPr>
+          <a:xfrm>
+            <a:off x="2971800" y="1600200"/>
+            <a:ext cx="1463040" cy="457200"/>
+          </a:xfrm>
+          <a:prstGeom prst="rect">
+            <a:avLst/>
+          </a:prstGeom>
+          <a:noFill/>
+        </p:spPr>
+        <p:txBody>
+          <a:bodyPr wrap="square">
+            <a:spAutoFit/>
+          </a:bodyPr>
+          <a:lstStyle/>
+          <a:p>
+            <a:pPr algn="l">
+              <a:defRPr sz="1000" b="0">
+                <a:solidFill>
+                  <a:srgbClr val="666666"/>
+                </a:solidFill>
+              </a:defRPr>
+            </a:pPr>
+            <a:r>
+              <a:t>Раскладка EN→RU</a:t>
+            </a:r>
+            <a:br/>
+            <a:r>
+              <a:t>Транслит lat→кир</a:t>
+            </a:r>
+          </a:p>
+        </p:txBody>
+      </p:sp>
+      <p:sp>
+        <p:nvSpPr>
+          <p:cNvPr id="17" name="Rectangle 16"/>
           <p:cNvSpPr/>
           <p:nvPr/>
         </p:nvSpPr>
         <p:spPr>
           <a:xfrm>
-            <a:off x="1645920" y="1325880"/>
-            <a:ext cx="365760" cy="365760"/>
-          </a:xfrm>
-          <a:prstGeom prst="ellipse">
+            <a:off x="4617720" y="1620520"/>
+            <a:ext cx="320040" cy="50800"/>
+          </a:xfrm>
+          <a:prstGeom prst="rect">
+            <a:avLst/>
+          </a:prstGeom>
+          <a:solidFill>
+            <a:srgbClr val="BBBBBB"/>
+          </a:solidFill>
+          <a:ln>
+            <a:noFill/>
+          </a:ln>
+        </p:spPr>
+        <p:style>
+          <a:lnRef idx="1">
+            <a:schemeClr val="accent1"/>
+          </a:lnRef>
+          <a:fillRef idx="3">
+            <a:schemeClr val="accent1"/>
+          </a:fillRef>
+          <a:effectRef idx="2">
+            <a:schemeClr val="accent1"/>
+          </a:effectRef>
+          <a:fontRef idx="minor">
+            <a:schemeClr val="lt1"/>
+          </a:fontRef>
+        </p:style>
+        <p:txBody>
+          <a:bodyPr rtlCol="0" anchor="ctr"/>
+          <a:lstStyle/>
+          <a:p>
+            <a:pPr algn="ctr"/>
+          </a:p>
+        </p:txBody>
+      </p:sp>
+      <p:sp>
+        <p:nvSpPr>
+          <p:cNvPr id="18" name="Isosceles Triangle 17"/>
+          <p:cNvSpPr/>
+          <p:nvPr/>
+        </p:nvSpPr>
+        <p:spPr>
+          <a:xfrm rot="5400000">
+            <a:off x="4828032" y="1572768"/>
+            <a:ext cx="146304" cy="146304"/>
+          </a:xfrm>
+          <a:prstGeom prst="triangle">
+            <a:avLst/>
+          </a:prstGeom>
+          <a:solidFill>
+            <a:srgbClr val="BBBBBB"/>
+          </a:solidFill>
+          <a:ln>
+            <a:noFill/>
+          </a:ln>
+        </p:spPr>
+        <p:style>
+          <a:lnRef idx="1">
+            <a:schemeClr val="accent1"/>
+          </a:lnRef>
+          <a:fillRef idx="3">
+            <a:schemeClr val="accent1"/>
+          </a:fillRef>
+          <a:effectRef idx="2">
+            <a:schemeClr val="accent1"/>
+          </a:effectRef>
+          <a:fontRef idx="minor">
+            <a:schemeClr val="lt1"/>
+          </a:fontRef>
+        </p:style>
+        <p:txBody>
+          <a:bodyPr rtlCol="0" anchor="ctr"/>
+          <a:lstStyle/>
+          <a:p>
+            <a:pPr algn="ctr"/>
+          </a:p>
+        </p:txBody>
+      </p:sp>
+      <p:sp>
+        <p:nvSpPr>
+          <p:cNvPr id="19" name="Rounded Rectangle 18"/>
+          <p:cNvSpPr/>
+          <p:nvPr/>
+        </p:nvSpPr>
+        <p:spPr>
+          <a:xfrm>
+            <a:off x="5029200" y="1097280"/>
+            <a:ext cx="1828800" cy="1097280"/>
+          </a:xfrm>
+          <a:prstGeom prst="roundRect">
+            <a:avLst/>
+          </a:prstGeom>
+          <a:solidFill>
+            <a:srgbClr val="FFFFFF"/>
+          </a:solidFill>
+          <a:ln w="19050">
+            <a:solidFill>
+              <a:srgbClr val="1976D2"/>
+            </a:solidFill>
+          </a:ln>
+        </p:spPr>
+        <p:style>
+          <a:lnRef idx="1">
+            <a:schemeClr val="accent1"/>
+          </a:lnRef>
+          <a:fillRef idx="3">
+            <a:schemeClr val="accent1"/>
+          </a:fillRef>
+          <a:effectRef idx="2">
+            <a:schemeClr val="accent1"/>
+          </a:effectRef>
+          <a:fontRef idx="minor">
+            <a:schemeClr val="lt1"/>
+          </a:fontRef>
+        </p:style>
+        <p:txBody>
+          <a:bodyPr rtlCol="0" anchor="ctr"/>
+          <a:lstStyle/>
+          <a:p>
+            <a:pPr algn="ctr"/>
+          </a:p>
+        </p:txBody>
+      </p:sp>
+      <p:sp>
+        <p:nvSpPr>
+          <p:cNvPr id="20" name="Rectangle 19"/>
+          <p:cNvSpPr/>
+          <p:nvPr/>
+        </p:nvSpPr>
+        <p:spPr>
+          <a:xfrm>
+            <a:off x="5056632" y="1188720"/>
+            <a:ext cx="73152" cy="914400"/>
+          </a:xfrm>
+          <a:prstGeom prst="rect">
+            <a:avLst/>
+          </a:prstGeom>
+          <a:solidFill>
+            <a:srgbClr val="1976D2"/>
+          </a:solidFill>
+          <a:ln>
+            <a:noFill/>
+          </a:ln>
+        </p:spPr>
+        <p:style>
+          <a:lnRef idx="1">
+            <a:schemeClr val="accent1"/>
+          </a:lnRef>
+          <a:fillRef idx="3">
+            <a:schemeClr val="accent1"/>
+          </a:fillRef>
+          <a:effectRef idx="2">
+            <a:schemeClr val="accent1"/>
+          </a:effectRef>
+          <a:fontRef idx="minor">
+            <a:schemeClr val="lt1"/>
+          </a:fontRef>
+        </p:style>
+        <p:txBody>
+          <a:bodyPr rtlCol="0" anchor="ctr"/>
+          <a:lstStyle/>
+          <a:p>
+            <a:pPr algn="ctr"/>
+          </a:p>
+        </p:txBody>
+      </p:sp>
+      <p:sp>
+        <p:nvSpPr>
+          <p:cNvPr id="21" name="TextBox 20"/>
+          <p:cNvSpPr txBox="1"/>
+          <p:nvPr/>
+        </p:nvSpPr>
+        <p:spPr>
+          <a:xfrm>
+            <a:off x="5257800" y="1234440"/>
+            <a:ext cx="1463040" cy="365760"/>
+          </a:xfrm>
+          <a:prstGeom prst="rect">
+            <a:avLst/>
+          </a:prstGeom>
+          <a:noFill/>
+        </p:spPr>
+        <p:txBody>
+          <a:bodyPr wrap="square">
+            <a:spAutoFit/>
+          </a:bodyPr>
+          <a:lstStyle/>
+          <a:p>
+            <a:pPr algn="l">
+              <a:defRPr sz="1300" b="1">
+                <a:solidFill>
+                  <a:srgbClr val="334059"/>
+                </a:solidFill>
+              </a:defRPr>
+            </a:pPr>
+            <a:r>
+              <a:t>Spell Check</a:t>
+            </a:r>
+          </a:p>
+        </p:txBody>
+      </p:sp>
+      <p:sp>
+        <p:nvSpPr>
+          <p:cNvPr id="22" name="TextBox 21"/>
+          <p:cNvSpPr txBox="1"/>
+          <p:nvPr/>
+        </p:nvSpPr>
+        <p:spPr>
+          <a:xfrm>
+            <a:off x="5257800" y="1600200"/>
+            <a:ext cx="1463040" cy="457200"/>
+          </a:xfrm>
+          <a:prstGeom prst="rect">
+            <a:avLst/>
+          </a:prstGeom>
+          <a:noFill/>
+        </p:spPr>
+        <p:txBody>
+          <a:bodyPr wrap="square">
+            <a:spAutoFit/>
+          </a:bodyPr>
+          <a:lstStyle/>
+          <a:p>
+            <a:pPr algn="l">
+              <a:defRPr sz="1000" b="0">
+                <a:solidFill>
+                  <a:srgbClr val="666666"/>
+                </a:solidFill>
+              </a:defRPr>
+            </a:pPr>
+            <a:r>
+              <a:t>490K словарь</a:t>
+            </a:r>
+            <a:br/>
+            <a:r>
+              <a:t>Детекция отрицания</a:t>
+            </a:r>
+          </a:p>
+        </p:txBody>
+      </p:sp>
+      <p:sp>
+        <p:nvSpPr>
+          <p:cNvPr id="23" name="Rectangle 22"/>
+          <p:cNvSpPr/>
+          <p:nvPr/>
+        </p:nvSpPr>
+        <p:spPr>
+          <a:xfrm>
+            <a:off x="6903720" y="1620520"/>
+            <a:ext cx="320040" cy="50800"/>
+          </a:xfrm>
+          <a:prstGeom prst="rect">
+            <a:avLst/>
+          </a:prstGeom>
+          <a:solidFill>
+            <a:srgbClr val="BBBBBB"/>
+          </a:solidFill>
+          <a:ln>
+            <a:noFill/>
+          </a:ln>
+        </p:spPr>
+        <p:style>
+          <a:lnRef idx="1">
+            <a:schemeClr val="accent1"/>
+          </a:lnRef>
+          <a:fillRef idx="3">
+            <a:schemeClr val="accent1"/>
+          </a:fillRef>
+          <a:effectRef idx="2">
+            <a:schemeClr val="accent1"/>
+          </a:effectRef>
+          <a:fontRef idx="minor">
+            <a:schemeClr val="lt1"/>
+          </a:fontRef>
+        </p:style>
+        <p:txBody>
+          <a:bodyPr rtlCol="0" anchor="ctr"/>
+          <a:lstStyle/>
+          <a:p>
+            <a:pPr algn="ctr"/>
+          </a:p>
+        </p:txBody>
+      </p:sp>
+      <p:sp>
+        <p:nvSpPr>
+          <p:cNvPr id="24" name="Isosceles Triangle 23"/>
+          <p:cNvSpPr/>
+          <p:nvPr/>
+        </p:nvSpPr>
+        <p:spPr>
+          <a:xfrm rot="5400000">
+            <a:off x="7114032" y="1572768"/>
+            <a:ext cx="146304" cy="146304"/>
+          </a:xfrm>
+          <a:prstGeom prst="triangle">
+            <a:avLst/>
+          </a:prstGeom>
+          <a:solidFill>
+            <a:srgbClr val="BBBBBB"/>
+          </a:solidFill>
+          <a:ln>
+            <a:noFill/>
+          </a:ln>
+        </p:spPr>
+        <p:style>
+          <a:lnRef idx="1">
+            <a:schemeClr val="accent1"/>
+          </a:lnRef>
+          <a:fillRef idx="3">
+            <a:schemeClr val="accent1"/>
+          </a:fillRef>
+          <a:effectRef idx="2">
+            <a:schemeClr val="accent1"/>
+          </a:effectRef>
+          <a:fontRef idx="minor">
+            <a:schemeClr val="lt1"/>
+          </a:fontRef>
+        </p:style>
+        <p:txBody>
+          <a:bodyPr rtlCol="0" anchor="ctr"/>
+          <a:lstStyle/>
+          <a:p>
+            <a:pPr algn="ctr"/>
+          </a:p>
+        </p:txBody>
+      </p:sp>
+      <p:sp>
+        <p:nvSpPr>
+          <p:cNvPr id="25" name="Rounded Rectangle 24"/>
+          <p:cNvSpPr/>
+          <p:nvPr/>
+        </p:nvSpPr>
+        <p:spPr>
+          <a:xfrm>
+            <a:off x="7315200" y="1097280"/>
+            <a:ext cx="1828800" cy="1097280"/>
+          </a:xfrm>
+          <a:prstGeom prst="roundRect">
+            <a:avLst/>
+          </a:prstGeom>
+          <a:solidFill>
+            <a:srgbClr val="FFFFFF"/>
+          </a:solidFill>
+          <a:ln w="19050">
+            <a:solidFill>
+              <a:srgbClr val="7B1FA2"/>
+            </a:solidFill>
+          </a:ln>
+        </p:spPr>
+        <p:style>
+          <a:lnRef idx="1">
+            <a:schemeClr val="accent1"/>
+          </a:lnRef>
+          <a:fillRef idx="3">
+            <a:schemeClr val="accent1"/>
+          </a:fillRef>
+          <a:effectRef idx="2">
+            <a:schemeClr val="accent1"/>
+          </a:effectRef>
+          <a:fontRef idx="minor">
+            <a:schemeClr val="lt1"/>
+          </a:fontRef>
+        </p:style>
+        <p:txBody>
+          <a:bodyPr rtlCol="0" anchor="ctr"/>
+          <a:lstStyle/>
+          <a:p>
+            <a:pPr algn="ctr"/>
+          </a:p>
+        </p:txBody>
+      </p:sp>
+      <p:sp>
+        <p:nvSpPr>
+          <p:cNvPr id="26" name="Rectangle 25"/>
+          <p:cNvSpPr/>
+          <p:nvPr/>
+        </p:nvSpPr>
+        <p:spPr>
+          <a:xfrm>
+            <a:off x="7342632" y="1188720"/>
+            <a:ext cx="73152" cy="914400"/>
+          </a:xfrm>
+          <a:prstGeom prst="rect">
+            <a:avLst/>
+          </a:prstGeom>
+          <a:solidFill>
+            <a:srgbClr val="7B1FA2"/>
+          </a:solidFill>
+          <a:ln>
+            <a:noFill/>
+          </a:ln>
+        </p:spPr>
+        <p:style>
+          <a:lnRef idx="1">
+            <a:schemeClr val="accent1"/>
+          </a:lnRef>
+          <a:fillRef idx="3">
+            <a:schemeClr val="accent1"/>
+          </a:fillRef>
+          <a:effectRef idx="2">
+            <a:schemeClr val="accent1"/>
+          </a:effectRef>
+          <a:fontRef idx="minor">
+            <a:schemeClr val="lt1"/>
+          </a:fontRef>
+        </p:style>
+        <p:txBody>
+          <a:bodyPr rtlCol="0" anchor="ctr"/>
+          <a:lstStyle/>
+          <a:p>
+            <a:pPr algn="ctr"/>
+          </a:p>
+        </p:txBody>
+      </p:sp>
+      <p:sp>
+        <p:nvSpPr>
+          <p:cNvPr id="27" name="TextBox 26"/>
+          <p:cNvSpPr txBox="1"/>
+          <p:nvPr/>
+        </p:nvSpPr>
+        <p:spPr>
+          <a:xfrm>
+            <a:off x="7543800" y="1234440"/>
+            <a:ext cx="1463040" cy="365760"/>
+          </a:xfrm>
+          <a:prstGeom prst="rect">
+            <a:avLst/>
+          </a:prstGeom>
+          <a:noFill/>
+        </p:spPr>
+        <p:txBody>
+          <a:bodyPr wrap="square">
+            <a:spAutoFit/>
+          </a:bodyPr>
+          <a:lstStyle/>
+          <a:p>
+            <a:pPr algn="l">
+              <a:defRPr sz="1300" b="1">
+                <a:solidFill>
+                  <a:srgbClr val="334059"/>
+                </a:solidFill>
+              </a:defRPr>
+            </a:pPr>
+            <a:r>
+              <a:t>Персонализация</a:t>
+            </a:r>
+          </a:p>
+        </p:txBody>
+      </p:sp>
+      <p:sp>
+        <p:nvSpPr>
+          <p:cNvPr id="28" name="TextBox 27"/>
+          <p:cNvSpPr txBox="1"/>
+          <p:nvPr/>
+        </p:nvSpPr>
+        <p:spPr>
+          <a:xfrm>
+            <a:off x="7543800" y="1600200"/>
+            <a:ext cx="1463040" cy="457200"/>
+          </a:xfrm>
+          <a:prstGeom prst="rect">
+            <a:avLst/>
+          </a:prstGeom>
+          <a:noFill/>
+        </p:spPr>
+        <p:txBody>
+          <a:bodyPr wrap="square">
+            <a:spAutoFit/>
+          </a:bodyPr>
+          <a:lstStyle/>
+          <a:p>
+            <a:pPr algn="l">
+              <a:defRPr sz="1000" b="0">
+                <a:solidFill>
+                  <a:srgbClr val="666666"/>
+                </a:solidFill>
+              </a:defRPr>
+            </a:pPr>
+            <a:r>
+              <a:t>Cold start PG→Redis</a:t>
+            </a:r>
+            <a:br/>
+            <a:r>
+              <a:t>Product + Category boosts</a:t>
+            </a:r>
+          </a:p>
+        </p:txBody>
+      </p:sp>
+      <p:sp>
+        <p:nvSpPr>
+          <p:cNvPr id="29" name="Rectangle 28"/>
+          <p:cNvSpPr/>
+          <p:nvPr/>
+        </p:nvSpPr>
+        <p:spPr>
+          <a:xfrm>
+            <a:off x="9189720" y="1620520"/>
+            <a:ext cx="320040" cy="50800"/>
+          </a:xfrm>
+          <a:prstGeom prst="rect">
+            <a:avLst/>
+          </a:prstGeom>
+          <a:solidFill>
+            <a:srgbClr val="BBBBBB"/>
+          </a:solidFill>
+          <a:ln>
+            <a:noFill/>
+          </a:ln>
+        </p:spPr>
+        <p:style>
+          <a:lnRef idx="1">
+            <a:schemeClr val="accent1"/>
+          </a:lnRef>
+          <a:fillRef idx="3">
+            <a:schemeClr val="accent1"/>
+          </a:fillRef>
+          <a:effectRef idx="2">
+            <a:schemeClr val="accent1"/>
+          </a:effectRef>
+          <a:fontRef idx="minor">
+            <a:schemeClr val="lt1"/>
+          </a:fontRef>
+        </p:style>
+        <p:txBody>
+          <a:bodyPr rtlCol="0" anchor="ctr"/>
+          <a:lstStyle/>
+          <a:p>
+            <a:pPr algn="ctr"/>
+          </a:p>
+        </p:txBody>
+      </p:sp>
+      <p:sp>
+        <p:nvSpPr>
+          <p:cNvPr id="30" name="Isosceles Triangle 29"/>
+          <p:cNvSpPr/>
+          <p:nvPr/>
+        </p:nvSpPr>
+        <p:spPr>
+          <a:xfrm rot="5400000">
+            <a:off x="9400032" y="1572768"/>
+            <a:ext cx="146304" cy="146304"/>
+          </a:xfrm>
+          <a:prstGeom prst="triangle">
+            <a:avLst/>
+          </a:prstGeom>
+          <a:solidFill>
+            <a:srgbClr val="BBBBBB"/>
+          </a:solidFill>
+          <a:ln>
+            <a:noFill/>
+          </a:ln>
+        </p:spPr>
+        <p:style>
+          <a:lnRef idx="1">
+            <a:schemeClr val="accent1"/>
+          </a:lnRef>
+          <a:fillRef idx="3">
+            <a:schemeClr val="accent1"/>
+          </a:fillRef>
+          <a:effectRef idx="2">
+            <a:schemeClr val="accent1"/>
+          </a:effectRef>
+          <a:fontRef idx="minor">
+            <a:schemeClr val="lt1"/>
+          </a:fontRef>
+        </p:style>
+        <p:txBody>
+          <a:bodyPr rtlCol="0" anchor="ctr"/>
+          <a:lstStyle/>
+          <a:p>
+            <a:pPr algn="ctr"/>
+          </a:p>
+        </p:txBody>
+      </p:sp>
+      <p:sp>
+        <p:nvSpPr>
+          <p:cNvPr id="31" name="Rounded Rectangle 30"/>
+          <p:cNvSpPr/>
+          <p:nvPr/>
+        </p:nvSpPr>
+        <p:spPr>
+          <a:xfrm>
+            <a:off x="9601200" y="1097280"/>
+            <a:ext cx="1828800" cy="1097280"/>
+          </a:xfrm>
+          <a:prstGeom prst="roundRect">
+            <a:avLst/>
+          </a:prstGeom>
+          <a:solidFill>
+            <a:srgbClr val="FFFFFF"/>
+          </a:solidFill>
+          <a:ln w="19050">
+            <a:solidFill>
+              <a:srgbClr val="43A047"/>
+            </a:solidFill>
+          </a:ln>
+        </p:spPr>
+        <p:style>
+          <a:lnRef idx="1">
+            <a:schemeClr val="accent1"/>
+          </a:lnRef>
+          <a:fillRef idx="3">
+            <a:schemeClr val="accent1"/>
+          </a:fillRef>
+          <a:effectRef idx="2">
+            <a:schemeClr val="accent1"/>
+          </a:effectRef>
+          <a:fontRef idx="minor">
+            <a:schemeClr val="lt1"/>
+          </a:fontRef>
+        </p:style>
+        <p:txBody>
+          <a:bodyPr rtlCol="0" anchor="ctr"/>
+          <a:lstStyle/>
+          <a:p>
+            <a:pPr algn="ctr"/>
+          </a:p>
+        </p:txBody>
+      </p:sp>
+      <p:sp>
+        <p:nvSpPr>
+          <p:cNvPr id="32" name="Rectangle 31"/>
+          <p:cNvSpPr/>
+          <p:nvPr/>
+        </p:nvSpPr>
+        <p:spPr>
+          <a:xfrm>
+            <a:off x="9628632" y="1188720"/>
+            <a:ext cx="73152" cy="914400"/>
+          </a:xfrm>
+          <a:prstGeom prst="rect">
             <a:avLst/>
           </a:prstGeom>
           <a:solidFill>
@@ -6150,14 +6902,123 @@
       </p:sp>
       <p:sp>
         <p:nvSpPr>
-          <p:cNvPr id="15" name="Rounded Rectangle 14"/>
+          <p:cNvPr id="33" name="TextBox 32"/>
+          <p:cNvSpPr txBox="1"/>
+          <p:nvPr/>
+        </p:nvSpPr>
+        <p:spPr>
+          <a:xfrm>
+            <a:off x="9829800" y="1234440"/>
+            <a:ext cx="1463040" cy="365760"/>
+          </a:xfrm>
+          <a:prstGeom prst="rect">
+            <a:avLst/>
+          </a:prstGeom>
+          <a:noFill/>
+        </p:spPr>
+        <p:txBody>
+          <a:bodyPr wrap="square">
+            <a:spAutoFit/>
+          </a:bodyPr>
+          <a:lstStyle/>
+          <a:p>
+            <a:pPr algn="l">
+              <a:defRPr sz="1300" b="1">
+                <a:solidFill>
+                  <a:srgbClr val="334059"/>
+                </a:solidFill>
+              </a:defRPr>
+            </a:pPr>
+            <a:r>
+              <a:t>Результат</a:t>
+            </a:r>
+          </a:p>
+        </p:txBody>
+      </p:sp>
+      <p:sp>
+        <p:nvSpPr>
+          <p:cNvPr id="34" name="TextBox 33"/>
+          <p:cNvSpPr txBox="1"/>
+          <p:nvPr/>
+        </p:nvSpPr>
+        <p:spPr>
+          <a:xfrm>
+            <a:off x="9829800" y="1600200"/>
+            <a:ext cx="1463040" cy="457200"/>
+          </a:xfrm>
+          <a:prstGeom prst="rect">
+            <a:avLst/>
+          </a:prstGeom>
+          <a:noFill/>
+        </p:spPr>
+        <p:txBody>
+          <a:bodyPr wrap="square">
+            <a:spAutoFit/>
+          </a:bodyPr>
+          <a:lstStyle/>
+          <a:p>
+            <a:pPr algn="l">
+              <a:defRPr sz="1000" b="0">
+                <a:solidFill>
+                  <a:srgbClr val="666666"/>
+                </a:solidFill>
+              </a:defRPr>
+            </a:pPr>
+            <a:r>
+              <a:t>Карточки + Формула</a:t>
+            </a:r>
+            <a:br/>
+            <a:r>
+              <a:t>AI-расширение (RAG)</a:t>
+            </a:r>
+          </a:p>
+        </p:txBody>
+      </p:sp>
+      <p:sp>
+        <p:nvSpPr>
+          <p:cNvPr id="35" name="TextBox 34"/>
+          <p:cNvSpPr txBox="1"/>
+          <p:nvPr/>
+        </p:nvSpPr>
+        <p:spPr>
+          <a:xfrm>
+            <a:off x="457200" y="2423160"/>
+            <a:ext cx="2743200" cy="274320"/>
+          </a:xfrm>
+          <a:prstGeom prst="rect">
+            <a:avLst/>
+          </a:prstGeom>
+          <a:noFill/>
+        </p:spPr>
+        <p:txBody>
+          <a:bodyPr wrap="square">
+            <a:spAutoFit/>
+          </a:bodyPr>
+          <a:lstStyle/>
+          <a:p>
+            <a:pPr algn="l">
+              <a:defRPr sz="1100" b="1">
+                <a:solidFill>
+                  <a:srgbClr val="E53935"/>
+                </a:solidFill>
+              </a:defRPr>
+            </a:pPr>
+            <a:r>
+              <a:t>ПОИСКОВЫЙ ДВИЖОК</a:t>
+            </a:r>
+          </a:p>
+        </p:txBody>
+      </p:sp>
+      <p:sp>
+        <p:nvSpPr>
+          <p:cNvPr id="36" name="Rounded Rectangle 35"/>
           <p:cNvSpPr/>
           <p:nvPr/>
         </p:nvSpPr>
         <p:spPr>
           <a:xfrm>
-            <a:off x="3200400" y="1234440"/>
-            <a:ext cx="1280160" cy="548640"/>
+            <a:off x="457200" y="2743200"/>
+            <a:ext cx="2103120" cy="1097280"/>
           </a:xfrm>
           <a:prstGeom prst="roundRect">
             <a:avLst/>
@@ -6167,7 +7028,7 @@
           </a:solidFill>
           <a:ln w="19050">
             <a:solidFill>
-              <a:srgbClr val="BBBBBB"/>
+              <a:srgbClr val="F5700C"/>
             </a:solidFill>
           </a:ln>
         </p:spPr>
@@ -6186,47 +7047,32 @@
           </a:fontRef>
         </p:style>
         <p:txBody>
-          <a:bodyPr rtlCol="0" anchor="ctr" wrap="square"/>
-          <a:lstStyle/>
-          <a:p>
-            <a:pPr algn="ctr">
-              <a:defRPr sz="800">
-                <a:solidFill>
-                  <a:srgbClr val="334059"/>
-                </a:solidFill>
-              </a:defRPr>
-            </a:pPr>
-            <a:r>
-              <a:t>Ввод запроса</a:t>
-            </a:r>
-            <a:br/>
-            <a:r>
-              <a:t>в строку поиска</a:t>
-            </a:r>
-          </a:p>
-        </p:txBody>
-      </p:sp>
-      <p:sp>
-        <p:nvSpPr>
-          <p:cNvPr id="16" name="Oval 15"/>
+          <a:bodyPr rtlCol="0" anchor="ctr"/>
+          <a:lstStyle/>
+          <a:p>
+            <a:pPr algn="ctr"/>
+          </a:p>
+        </p:txBody>
+      </p:sp>
+      <p:sp>
+        <p:nvSpPr>
+          <p:cNvPr id="37" name="Rectangle 36"/>
           <p:cNvSpPr/>
           <p:nvPr/>
         </p:nvSpPr>
         <p:spPr>
           <a:xfrm>
-            <a:off x="10515600" y="1325880"/>
-            <a:ext cx="365760" cy="365760"/>
-          </a:xfrm>
-          <a:prstGeom prst="ellipse">
+            <a:off x="484632" y="2834640"/>
+            <a:ext cx="73152" cy="914400"/>
+          </a:xfrm>
+          <a:prstGeom prst="rect">
             <a:avLst/>
           </a:prstGeom>
           <a:solidFill>
-            <a:srgbClr val="E53935"/>
+            <a:srgbClr val="F5700C"/>
           </a:solidFill>
-          <a:ln w="38100">
-            <a:solidFill>
-              <a:srgbClr val="E53935"/>
-            </a:solidFill>
+          <a:ln>
+            <a:noFill/>
           </a:ln>
         </p:spPr>
         <p:style>
@@ -6253,14 +7099,88 @@
       </p:sp>
       <p:sp>
         <p:nvSpPr>
-          <p:cNvPr id="17" name="Rounded Rectangle 16"/>
+          <p:cNvPr id="38" name="TextBox 37"/>
+          <p:cNvSpPr txBox="1"/>
+          <p:nvPr/>
+        </p:nvSpPr>
+        <p:spPr>
+          <a:xfrm>
+            <a:off x="685800" y="2880360"/>
+            <a:ext cx="1737360" cy="365760"/>
+          </a:xfrm>
+          <a:prstGeom prst="rect">
+            <a:avLst/>
+          </a:prstGeom>
+          <a:noFill/>
+        </p:spPr>
+        <p:txBody>
+          <a:bodyPr wrap="square">
+            <a:spAutoFit/>
+          </a:bodyPr>
+          <a:lstStyle/>
+          <a:p>
+            <a:pPr algn="l">
+              <a:defRPr sz="1300" b="1">
+                <a:solidFill>
+                  <a:srgbClr val="334059"/>
+                </a:solidFill>
+              </a:defRPr>
+            </a:pPr>
+            <a:r>
+              <a:t>Short mode</a:t>
+            </a:r>
+          </a:p>
+        </p:txBody>
+      </p:sp>
+      <p:sp>
+        <p:nvSpPr>
+          <p:cNvPr id="39" name="TextBox 38"/>
+          <p:cNvSpPr txBox="1"/>
+          <p:nvPr/>
+        </p:nvSpPr>
+        <p:spPr>
+          <a:xfrm>
+            <a:off x="685800" y="3246120"/>
+            <a:ext cx="1737360" cy="457200"/>
+          </a:xfrm>
+          <a:prstGeom prst="rect">
+            <a:avLst/>
+          </a:prstGeom>
+          <a:noFill/>
+        </p:spPr>
+        <p:txBody>
+          <a:bodyPr wrap="square">
+            <a:spAutoFit/>
+          </a:bodyPr>
+          <a:lstStyle/>
+          <a:p>
+            <a:pPr algn="l">
+              <a:defRPr sz="1000" b="0">
+                <a:solidFill>
+                  <a:srgbClr val="666666"/>
+                </a:solidFill>
+              </a:defRPr>
+            </a:pPr>
+            <a:r>
+              <a:t>Prefix subject.raw</a:t>
+            </a:r>
+            <a:br/>
+            <a:r>
+              <a:t>Fuzzy subject (≤6 сим.)</a:t>
+            </a:r>
+          </a:p>
+        </p:txBody>
+      </p:sp>
+      <p:sp>
+        <p:nvSpPr>
+          <p:cNvPr id="40" name="Rounded Rectangle 39"/>
           <p:cNvSpPr/>
           <p:nvPr/>
         </p:nvSpPr>
         <p:spPr>
           <a:xfrm>
-            <a:off x="1645920" y="2606040"/>
-            <a:ext cx="1280160" cy="548640"/>
+            <a:off x="2743200" y="2743200"/>
+            <a:ext cx="2103120" cy="1097280"/>
           </a:xfrm>
           <a:prstGeom prst="roundRect">
             <a:avLst/>
@@ -6270,7 +7190,7 @@
           </a:solidFill>
           <a:ln w="19050">
             <a:solidFill>
-              <a:srgbClr val="BBBBBB"/>
+              <a:srgbClr val="F5700C"/>
             </a:solidFill>
           </a:ln>
         </p:spPr>
@@ -6289,36 +7209,140 @@
           </a:fontRef>
         </p:style>
         <p:txBody>
-          <a:bodyPr rtlCol="0" anchor="ctr" wrap="square"/>
-          <a:lstStyle/>
-          <a:p>
-            <a:pPr algn="ctr">
-              <a:defRPr sz="800">
+          <a:bodyPr rtlCol="0" anchor="ctr"/>
+          <a:lstStyle/>
+          <a:p>
+            <a:pPr algn="ctr"/>
+          </a:p>
+        </p:txBody>
+      </p:sp>
+      <p:sp>
+        <p:nvSpPr>
+          <p:cNvPr id="41" name="Rectangle 40"/>
+          <p:cNvSpPr/>
+          <p:nvPr/>
+        </p:nvSpPr>
+        <p:spPr>
+          <a:xfrm>
+            <a:off x="2770632" y="2834640"/>
+            <a:ext cx="73152" cy="914400"/>
+          </a:xfrm>
+          <a:prstGeom prst="rect">
+            <a:avLst/>
+          </a:prstGeom>
+          <a:solidFill>
+            <a:srgbClr val="F5700C"/>
+          </a:solidFill>
+          <a:ln>
+            <a:noFill/>
+          </a:ln>
+        </p:spPr>
+        <p:style>
+          <a:lnRef idx="1">
+            <a:schemeClr val="accent1"/>
+          </a:lnRef>
+          <a:fillRef idx="3">
+            <a:schemeClr val="accent1"/>
+          </a:fillRef>
+          <a:effectRef idx="2">
+            <a:schemeClr val="accent1"/>
+          </a:effectRef>
+          <a:fontRef idx="minor">
+            <a:schemeClr val="lt1"/>
+          </a:fontRef>
+        </p:style>
+        <p:txBody>
+          <a:bodyPr rtlCol="0" anchor="ctr"/>
+          <a:lstStyle/>
+          <a:p>
+            <a:pPr algn="ctr"/>
+          </a:p>
+        </p:txBody>
+      </p:sp>
+      <p:sp>
+        <p:nvSpPr>
+          <p:cNvPr id="42" name="TextBox 41"/>
+          <p:cNvSpPr txBox="1"/>
+          <p:nvPr/>
+        </p:nvSpPr>
+        <p:spPr>
+          <a:xfrm>
+            <a:off x="2971800" y="2880360"/>
+            <a:ext cx="1737360" cy="365760"/>
+          </a:xfrm>
+          <a:prstGeom prst="rect">
+            <a:avLst/>
+          </a:prstGeom>
+          <a:noFill/>
+        </p:spPr>
+        <p:txBody>
+          <a:bodyPr wrap="square">
+            <a:spAutoFit/>
+          </a:bodyPr>
+          <a:lstStyle/>
+          <a:p>
+            <a:pPr algn="l">
+              <a:defRPr sz="1300" b="1">
                 <a:solidFill>
                   <a:srgbClr val="334059"/>
                 </a:solidFill>
               </a:defRPr>
             </a:pPr>
             <a:r>
-              <a:t>Нормализация</a:t>
+              <a:t>Full mode</a:t>
+            </a:r>
+          </a:p>
+        </p:txBody>
+      </p:sp>
+      <p:sp>
+        <p:nvSpPr>
+          <p:cNvPr id="43" name="TextBox 42"/>
+          <p:cNvSpPr txBox="1"/>
+          <p:nvPr/>
+        </p:nvSpPr>
+        <p:spPr>
+          <a:xfrm>
+            <a:off x="2971800" y="3246120"/>
+            <a:ext cx="1737360" cy="457200"/>
+          </a:xfrm>
+          <a:prstGeom prst="rect">
+            <a:avLst/>
+          </a:prstGeom>
+          <a:noFill/>
+        </p:spPr>
+        <p:txBody>
+          <a:bodyPr wrap="square">
+            <a:spAutoFit/>
+          </a:bodyPr>
+          <a:lstStyle/>
+          <a:p>
+            <a:pPr algn="l">
+              <a:defRPr sz="1000" b="0">
+                <a:solidFill>
+                  <a:srgbClr val="666666"/>
+                </a:solidFill>
+              </a:defRPr>
+            </a:pPr>
+            <a:r>
+              <a:t>Multi-match 4 стратегии</a:t>
             </a:r>
             <a:br/>
             <a:r>
-              <a:t>EN→RU раскладка</a:t>
-            </a:r>
-          </a:p>
-        </p:txBody>
-      </p:sp>
-      <p:sp>
-        <p:nvSpPr>
-          <p:cNvPr id="18" name="Rounded Rectangle 17"/>
+              <a:t>Phrase + AND + Fuzzy</a:t>
+            </a:r>
+          </a:p>
+        </p:txBody>
+      </p:sp>
+      <p:sp>
+        <p:nvSpPr>
+          <p:cNvPr id="44" name="Rounded Rectangle 43"/>
           <p:cNvSpPr/>
           <p:nvPr/>
         </p:nvSpPr>
         <p:spPr>
           <a:xfrm>
-            <a:off x="3200400" y="2606040"/>
-            <a:ext cx="1280160" cy="548640"/>
+            <a:off x="5120640" y="2743200"/>
+            <a:ext cx="2103120" cy="1097280"/>
           </a:xfrm>
           <a:prstGeom prst="roundRect">
             <a:avLst/>
@@ -6328,7 +7352,7 @@
           </a:solidFill>
           <a:ln w="19050">
             <a:solidFill>
-              <a:srgbClr val="BBBBBB"/>
+              <a:srgbClr val="E53935"/>
             </a:solidFill>
           </a:ln>
         </p:spPr>
@@ -6347,47 +7371,32 @@
           </a:fontRef>
         </p:style>
         <p:txBody>
-          <a:bodyPr rtlCol="0" anchor="ctr" wrap="square"/>
-          <a:lstStyle/>
-          <a:p>
-            <a:pPr algn="ctr">
-              <a:defRPr sz="800">
-                <a:solidFill>
-                  <a:srgbClr val="334059"/>
-                </a:solidFill>
-              </a:defRPr>
-            </a:pPr>
-            <a:r>
-              <a:t>Spell check</a:t>
-            </a:r>
-            <a:br/>
-            <a:r>
-              <a:t>490K словарь</a:t>
-            </a:r>
-          </a:p>
-        </p:txBody>
-      </p:sp>
-      <p:sp>
-        <p:nvSpPr>
-          <p:cNvPr id="19" name="Diamond 18"/>
+          <a:bodyPr rtlCol="0" anchor="ctr"/>
+          <a:lstStyle/>
+          <a:p>
+            <a:pPr algn="ctr"/>
+          </a:p>
+        </p:txBody>
+      </p:sp>
+      <p:sp>
+        <p:nvSpPr>
+          <p:cNvPr id="45" name="Rectangle 44"/>
           <p:cNvSpPr/>
           <p:nvPr/>
         </p:nvSpPr>
         <p:spPr>
           <a:xfrm>
-            <a:off x="5120640" y="2628900"/>
-            <a:ext cx="502920" cy="502920"/>
-          </a:xfrm>
-          <a:prstGeom prst="diamond">
+            <a:off x="5148072" y="2834640"/>
+            <a:ext cx="73152" cy="914400"/>
+          </a:xfrm>
+          <a:prstGeom prst="rect">
             <a:avLst/>
           </a:prstGeom>
           <a:solidFill>
-            <a:srgbClr val="FFF9C4"/>
+            <a:srgbClr val="E53935"/>
           </a:solidFill>
-          <a:ln w="19050">
-            <a:solidFill>
-              <a:srgbClr val="F9A825"/>
-            </a:solidFill>
+          <a:ln>
+            <a:noFill/>
           </a:ln>
         </p:spPr>
         <p:style>
@@ -6408,29 +7417,94 @@
           <a:bodyPr rtlCol="0" anchor="ctr"/>
           <a:lstStyle/>
           <a:p>
-            <a:pPr algn="ctr">
-              <a:defRPr sz="700">
+            <a:pPr algn="ctr"/>
+          </a:p>
+        </p:txBody>
+      </p:sp>
+      <p:sp>
+        <p:nvSpPr>
+          <p:cNvPr id="46" name="TextBox 45"/>
+          <p:cNvSpPr txBox="1"/>
+          <p:nvPr/>
+        </p:nvSpPr>
+        <p:spPr>
+          <a:xfrm>
+            <a:off x="5349240" y="2880360"/>
+            <a:ext cx="1737360" cy="365760"/>
+          </a:xfrm>
+          <a:prstGeom prst="rect">
+            <a:avLst/>
+          </a:prstGeom>
+          <a:noFill/>
+        </p:spPr>
+        <p:txBody>
+          <a:bodyPr wrap="square">
+            <a:spAutoFit/>
+          </a:bodyPr>
+          <a:lstStyle/>
+          <a:p>
+            <a:pPr algn="l">
+              <a:defRPr sz="1300" b="1">
                 <a:solidFill>
                   <a:srgbClr val="334059"/>
                 </a:solidFill>
               </a:defRPr>
             </a:pPr>
             <a:r>
-              <a:t>≤6?</a:t>
-            </a:r>
-          </a:p>
-        </p:txBody>
-      </p:sp>
-      <p:sp>
-        <p:nvSpPr>
-          <p:cNvPr id="20" name="Rounded Rectangle 19"/>
+              <a:t>Subject Boost</a:t>
+            </a:r>
+          </a:p>
+        </p:txBody>
+      </p:sp>
+      <p:sp>
+        <p:nvSpPr>
+          <p:cNvPr id="47" name="TextBox 46"/>
+          <p:cNvSpPr txBox="1"/>
+          <p:nvPr/>
+        </p:nvSpPr>
+        <p:spPr>
+          <a:xfrm>
+            <a:off x="5349240" y="3246120"/>
+            <a:ext cx="1737360" cy="457200"/>
+          </a:xfrm>
+          <a:prstGeom prst="rect">
+            <a:avLst/>
+          </a:prstGeom>
+          <a:noFill/>
+        </p:spPr>
+        <p:txBody>
+          <a:bodyPr wrap="square">
+            <a:spAutoFit/>
+          </a:bodyPr>
+          <a:lstStyle/>
+          <a:p>
+            <a:pPr algn="l">
+              <a:defRPr sz="1000" b="0">
+                <a:solidFill>
+                  <a:srgbClr val="666666"/>
+                </a:solidFill>
+              </a:defRPr>
+            </a:pPr>
+            <a:r>
+              <a:t>Exact +15 / Fuzzy +12</a:t>
+            </a:r>
+            <a:br/>
+            <a:r>
+              <a:t>Subject extraction</a:t>
+            </a:r>
+          </a:p>
+        </p:txBody>
+      </p:sp>
+      <p:sp>
+        <p:nvSpPr>
+          <p:cNvPr id="48" name="Rounded Rectangle 47"/>
           <p:cNvSpPr/>
           <p:nvPr/>
         </p:nvSpPr>
         <p:spPr>
           <a:xfrm>
-            <a:off x="5852160" y="2286000"/>
-            <a:ext cx="1280160" cy="548640"/>
+            <a:off x="7406640" y="2743200"/>
+            <a:ext cx="2103120" cy="1097280"/>
           </a:xfrm>
           <a:prstGeom prst="roundRect">
             <a:avLst/>
@@ -6440,7 +7514,7 @@
           </a:solidFill>
           <a:ln w="19050">
             <a:solidFill>
-              <a:srgbClr val="BBBBBB"/>
+              <a:srgbClr val="E53935"/>
             </a:solidFill>
           </a:ln>
         </p:spPr>
@@ -6459,36 +7533,140 @@
           </a:fontRef>
         </p:style>
         <p:txBody>
-          <a:bodyPr rtlCol="0" anchor="ctr" wrap="square"/>
-          <a:lstStyle/>
-          <a:p>
-            <a:pPr algn="ctr">
-              <a:defRPr sz="800">
+          <a:bodyPr rtlCol="0" anchor="ctr"/>
+          <a:lstStyle/>
+          <a:p>
+            <a:pPr algn="ctr"/>
+          </a:p>
+        </p:txBody>
+      </p:sp>
+      <p:sp>
+        <p:nvSpPr>
+          <p:cNvPr id="49" name="Rectangle 48"/>
+          <p:cNvSpPr/>
+          <p:nvPr/>
+        </p:nvSpPr>
+        <p:spPr>
+          <a:xfrm>
+            <a:off x="7434072" y="2834640"/>
+            <a:ext cx="73152" cy="914400"/>
+          </a:xfrm>
+          <a:prstGeom prst="rect">
+            <a:avLst/>
+          </a:prstGeom>
+          <a:solidFill>
+            <a:srgbClr val="E53935"/>
+          </a:solidFill>
+          <a:ln>
+            <a:noFill/>
+          </a:ln>
+        </p:spPr>
+        <p:style>
+          <a:lnRef idx="1">
+            <a:schemeClr val="accent1"/>
+          </a:lnRef>
+          <a:fillRef idx="3">
+            <a:schemeClr val="accent1"/>
+          </a:fillRef>
+          <a:effectRef idx="2">
+            <a:schemeClr val="accent1"/>
+          </a:effectRef>
+          <a:fontRef idx="minor">
+            <a:schemeClr val="lt1"/>
+          </a:fontRef>
+        </p:style>
+        <p:txBody>
+          <a:bodyPr rtlCol="0" anchor="ctr"/>
+          <a:lstStyle/>
+          <a:p>
+            <a:pPr algn="ctr"/>
+          </a:p>
+        </p:txBody>
+      </p:sp>
+      <p:sp>
+        <p:nvSpPr>
+          <p:cNvPr id="50" name="TextBox 49"/>
+          <p:cNvSpPr txBox="1"/>
+          <p:nvPr/>
+        </p:nvSpPr>
+        <p:spPr>
+          <a:xfrm>
+            <a:off x="7635240" y="2880360"/>
+            <a:ext cx="1737360" cy="365760"/>
+          </a:xfrm>
+          <a:prstGeom prst="rect">
+            <a:avLst/>
+          </a:prstGeom>
+          <a:noFill/>
+        </p:spPr>
+        <p:txBody>
+          <a:bodyPr wrap="square">
+            <a:spAutoFit/>
+          </a:bodyPr>
+          <a:lstStyle/>
+          <a:p>
+            <a:pPr algn="l">
+              <a:defRPr sz="1300" b="1">
                 <a:solidFill>
                   <a:srgbClr val="334059"/>
                 </a:solidFill>
               </a:defRPr>
             </a:pPr>
             <a:r>
-              <a:t>Prefix поиск</a:t>
+              <a:t>Function Score</a:t>
+            </a:r>
+          </a:p>
+        </p:txBody>
+      </p:sp>
+      <p:sp>
+        <p:nvSpPr>
+          <p:cNvPr id="51" name="TextBox 50"/>
+          <p:cNvSpPr txBox="1"/>
+          <p:nvPr/>
+        </p:nvSpPr>
+        <p:spPr>
+          <a:xfrm>
+            <a:off x="7635240" y="3246120"/>
+            <a:ext cx="1737360" cy="457200"/>
+          </a:xfrm>
+          <a:prstGeom prst="rect">
+            <a:avLst/>
+          </a:prstGeom>
+          <a:noFill/>
+        </p:spPr>
+        <p:txBody>
+          <a:bodyPr wrap="square">
+            <a:spAutoFit/>
+          </a:bodyPr>
+          <a:lstStyle/>
+          <a:p>
+            <a:pPr algn="l">
+              <a:defRPr sz="1000" b="0">
+                <a:solidFill>
+                  <a:srgbClr val="666666"/>
+                </a:solidFill>
+              </a:defRPr>
+            </a:pPr>
+            <a:r>
+              <a:t>BM25 × Popularity</a:t>
             </a:r>
             <a:br/>
             <a:r>
-              <a:t>subject.raw</a:t>
-            </a:r>
-          </a:p>
-        </p:txBody>
-      </p:sp>
-      <p:sp>
-        <p:nvSpPr>
-          <p:cNvPr id="21" name="Rounded Rectangle 20"/>
+              <a:t>× Product × Category</a:t>
+            </a:r>
+          </a:p>
+        </p:txBody>
+      </p:sp>
+      <p:sp>
+        <p:nvSpPr>
+          <p:cNvPr id="52" name="Rounded Rectangle 51"/>
           <p:cNvSpPr/>
           <p:nvPr/>
         </p:nvSpPr>
         <p:spPr>
           <a:xfrm>
-            <a:off x="5852160" y="2926080"/>
-            <a:ext cx="1280160" cy="548640"/>
+            <a:off x="9692640" y="2743200"/>
+            <a:ext cx="2103120" cy="1097280"/>
           </a:xfrm>
           <a:prstGeom prst="roundRect">
             <a:avLst/>
@@ -6498,7 +7676,7 @@
           </a:solidFill>
           <a:ln w="19050">
             <a:solidFill>
-              <a:srgbClr val="BBBBBB"/>
+              <a:srgbClr val="43A047"/>
             </a:solidFill>
           </a:ln>
         </p:spPr>
@@ -6517,36 +7695,175 @@
           </a:fontRef>
         </p:style>
         <p:txBody>
-          <a:bodyPr rtlCol="0" anchor="ctr" wrap="square"/>
-          <a:lstStyle/>
-          <a:p>
-            <a:pPr algn="ctr">
-              <a:defRPr sz="800">
+          <a:bodyPr rtlCol="0" anchor="ctr"/>
+          <a:lstStyle/>
+          <a:p>
+            <a:pPr algn="ctr"/>
+          </a:p>
+        </p:txBody>
+      </p:sp>
+      <p:sp>
+        <p:nvSpPr>
+          <p:cNvPr id="53" name="Rectangle 52"/>
+          <p:cNvSpPr/>
+          <p:nvPr/>
+        </p:nvSpPr>
+        <p:spPr>
+          <a:xfrm>
+            <a:off x="9720072" y="2834640"/>
+            <a:ext cx="73152" cy="914400"/>
+          </a:xfrm>
+          <a:prstGeom prst="rect">
+            <a:avLst/>
+          </a:prstGeom>
+          <a:solidFill>
+            <a:srgbClr val="43A047"/>
+          </a:solidFill>
+          <a:ln>
+            <a:noFill/>
+          </a:ln>
+        </p:spPr>
+        <p:style>
+          <a:lnRef idx="1">
+            <a:schemeClr val="accent1"/>
+          </a:lnRef>
+          <a:fillRef idx="3">
+            <a:schemeClr val="accent1"/>
+          </a:fillRef>
+          <a:effectRef idx="2">
+            <a:schemeClr val="accent1"/>
+          </a:effectRef>
+          <a:fontRef idx="minor">
+            <a:schemeClr val="lt1"/>
+          </a:fontRef>
+        </p:style>
+        <p:txBody>
+          <a:bodyPr rtlCol="0" anchor="ctr"/>
+          <a:lstStyle/>
+          <a:p>
+            <a:pPr algn="ctr"/>
+          </a:p>
+        </p:txBody>
+      </p:sp>
+      <p:sp>
+        <p:nvSpPr>
+          <p:cNvPr id="54" name="TextBox 53"/>
+          <p:cNvSpPr txBox="1"/>
+          <p:nvPr/>
+        </p:nvSpPr>
+        <p:spPr>
+          <a:xfrm>
+            <a:off x="9921240" y="2880360"/>
+            <a:ext cx="1737360" cy="365760"/>
+          </a:xfrm>
+          <a:prstGeom prst="rect">
+            <a:avLst/>
+          </a:prstGeom>
+          <a:noFill/>
+        </p:spPr>
+        <p:txBody>
+          <a:bodyPr wrap="square">
+            <a:spAutoFit/>
+          </a:bodyPr>
+          <a:lstStyle/>
+          <a:p>
+            <a:pPr algn="l">
+              <a:defRPr sz="1300" b="1">
                 <a:solidFill>
                   <a:srgbClr val="334059"/>
                 </a:solidFill>
               </a:defRPr>
             </a:pPr>
             <a:r>
-              <a:t>Multi-match</a:t>
+              <a:t>RAG (Ollama)</a:t>
+            </a:r>
+          </a:p>
+        </p:txBody>
+      </p:sp>
+      <p:sp>
+        <p:nvSpPr>
+          <p:cNvPr id="55" name="TextBox 54"/>
+          <p:cNvSpPr txBox="1"/>
+          <p:nvPr/>
+        </p:nvSpPr>
+        <p:spPr>
+          <a:xfrm>
+            <a:off x="9921240" y="3246120"/>
+            <a:ext cx="1737360" cy="457200"/>
+          </a:xfrm>
+          <a:prstGeom prst="rect">
+            <a:avLst/>
+          </a:prstGeom>
+          <a:noFill/>
+        </p:spPr>
+        <p:txBody>
+          <a:bodyPr wrap="square">
+            <a:spAutoFit/>
+          </a:bodyPr>
+          <a:lstStyle/>
+          <a:p>
+            <a:pPr algn="l">
+              <a:defRPr sz="1000" b="0">
+                <a:solidFill>
+                  <a:srgbClr val="666666"/>
+                </a:solidFill>
+              </a:defRPr>
+            </a:pPr>
+            <a:r>
+              <a:t>ES категории → LLM</a:t>
             </a:r>
             <a:br/>
             <a:r>
-              <a:t>4 стратегии</a:t>
-            </a:r>
-          </a:p>
-        </p:txBody>
-      </p:sp>
-      <p:sp>
-        <p:nvSpPr>
-          <p:cNvPr id="22" name="Rounded Rectangle 21"/>
+              <a:t>Qwen 2.5 7B</a:t>
+            </a:r>
+          </a:p>
+        </p:txBody>
+      </p:sp>
+      <p:sp>
+        <p:nvSpPr>
+          <p:cNvPr id="56" name="TextBox 55"/>
+          <p:cNvSpPr txBox="1"/>
+          <p:nvPr/>
+        </p:nvSpPr>
+        <p:spPr>
+          <a:xfrm>
+            <a:off x="457200" y="4069080"/>
+            <a:ext cx="2743200" cy="274320"/>
+          </a:xfrm>
+          <a:prstGeom prst="rect">
+            <a:avLst/>
+          </a:prstGeom>
+          <a:noFill/>
+        </p:spPr>
+        <p:txBody>
+          <a:bodyPr wrap="square">
+            <a:spAutoFit/>
+          </a:bodyPr>
+          <a:lstStyle/>
+          <a:p>
+            <a:pPr algn="l">
+              <a:defRPr sz="1100" b="1">
+                <a:solidFill>
+                  <a:srgbClr val="E53935"/>
+                </a:solidFill>
+              </a:defRPr>
+            </a:pPr>
+            <a:r>
+              <a:t>СЛОЙ ДАННЫХ</a:t>
+            </a:r>
+          </a:p>
+        </p:txBody>
+      </p:sp>
+      <p:sp>
+        <p:nvSpPr>
+          <p:cNvPr id="57" name="Rounded Rectangle 56"/>
           <p:cNvSpPr/>
           <p:nvPr/>
         </p:nvSpPr>
         <p:spPr>
           <a:xfrm>
-            <a:off x="7406640" y="2606040"/>
-            <a:ext cx="1280160" cy="548640"/>
+            <a:off x="457200" y="4389120"/>
+            <a:ext cx="2560320" cy="1097280"/>
           </a:xfrm>
           <a:prstGeom prst="roundRect">
             <a:avLst/>
@@ -6556,7 +7873,7 @@
           </a:solidFill>
           <a:ln w="19050">
             <a:solidFill>
-              <a:srgbClr val="BBBBBB"/>
+              <a:srgbClr val="43A047"/>
             </a:solidFill>
           </a:ln>
         </p:spPr>
@@ -6575,36 +7892,140 @@
           </a:fontRef>
         </p:style>
         <p:txBody>
-          <a:bodyPr rtlCol="0" anchor="ctr" wrap="square"/>
-          <a:lstStyle/>
-          <a:p>
-            <a:pPr algn="ctr">
-              <a:defRPr sz="800">
+          <a:bodyPr rtlCol="0" anchor="ctr"/>
+          <a:lstStyle/>
+          <a:p>
+            <a:pPr algn="ctr"/>
+          </a:p>
+        </p:txBody>
+      </p:sp>
+      <p:sp>
+        <p:nvSpPr>
+          <p:cNvPr id="58" name="Rectangle 57"/>
+          <p:cNvSpPr/>
+          <p:nvPr/>
+        </p:nvSpPr>
+        <p:spPr>
+          <a:xfrm>
+            <a:off x="484632" y="4480560"/>
+            <a:ext cx="73152" cy="914400"/>
+          </a:xfrm>
+          <a:prstGeom prst="rect">
+            <a:avLst/>
+          </a:prstGeom>
+          <a:solidFill>
+            <a:srgbClr val="43A047"/>
+          </a:solidFill>
+          <a:ln>
+            <a:noFill/>
+          </a:ln>
+        </p:spPr>
+        <p:style>
+          <a:lnRef idx="1">
+            <a:schemeClr val="accent1"/>
+          </a:lnRef>
+          <a:fillRef idx="3">
+            <a:schemeClr val="accent1"/>
+          </a:fillRef>
+          <a:effectRef idx="2">
+            <a:schemeClr val="accent1"/>
+          </a:effectRef>
+          <a:fontRef idx="minor">
+            <a:schemeClr val="lt1"/>
+          </a:fontRef>
+        </p:style>
+        <p:txBody>
+          <a:bodyPr rtlCol="0" anchor="ctr"/>
+          <a:lstStyle/>
+          <a:p>
+            <a:pPr algn="ctr"/>
+          </a:p>
+        </p:txBody>
+      </p:sp>
+      <p:sp>
+        <p:nvSpPr>
+          <p:cNvPr id="59" name="TextBox 58"/>
+          <p:cNvSpPr txBox="1"/>
+          <p:nvPr/>
+        </p:nvSpPr>
+        <p:spPr>
+          <a:xfrm>
+            <a:off x="685800" y="4526280"/>
+            <a:ext cx="2194560" cy="365760"/>
+          </a:xfrm>
+          <a:prstGeom prst="rect">
+            <a:avLst/>
+          </a:prstGeom>
+          <a:noFill/>
+        </p:spPr>
+        <p:txBody>
+          <a:bodyPr wrap="square">
+            <a:spAutoFit/>
+          </a:bodyPr>
+          <a:lstStyle/>
+          <a:p>
+            <a:pPr algn="l">
+              <a:defRPr sz="1300" b="1">
                 <a:solidFill>
                   <a:srgbClr val="334059"/>
                 </a:solidFill>
               </a:defRPr>
             </a:pPr>
             <a:r>
-              <a:t>Function score</a:t>
+              <a:t>Elasticsearch</a:t>
+            </a:r>
+          </a:p>
+        </p:txBody>
+      </p:sp>
+      <p:sp>
+        <p:nvSpPr>
+          <p:cNvPr id="60" name="TextBox 59"/>
+          <p:cNvSpPr txBox="1"/>
+          <p:nvPr/>
+        </p:nvSpPr>
+        <p:spPr>
+          <a:xfrm>
+            <a:off x="685800" y="4892040"/>
+            <a:ext cx="2194560" cy="457200"/>
+          </a:xfrm>
+          <a:prstGeom prst="rect">
+            <a:avLst/>
+          </a:prstGeom>
+          <a:noFill/>
+        </p:spPr>
+        <p:txBody>
+          <a:bodyPr wrap="square">
+            <a:spAutoFit/>
+          </a:bodyPr>
+          <a:lstStyle/>
+          <a:p>
+            <a:pPr algn="l">
+              <a:defRPr sz="1000" b="0">
+                <a:solidFill>
+                  <a:srgbClr val="666666"/>
+                </a:solidFill>
+              </a:defRPr>
+            </a:pPr>
+            <a:r>
+              <a:t>537K docs, BM25</a:t>
             </a:r>
             <a:br/>
             <a:r>
-              <a:t>+ бусты</a:t>
-            </a:r>
-          </a:p>
-        </p:txBody>
-      </p:sp>
-      <p:sp>
-        <p:nvSpPr>
-          <p:cNvPr id="23" name="Rounded Rectangle 22"/>
+              <a:t>Synonyms, Fuzzy</a:t>
+            </a:r>
+          </a:p>
+        </p:txBody>
+      </p:sp>
+      <p:sp>
+        <p:nvSpPr>
+          <p:cNvPr id="61" name="Rounded Rectangle 60"/>
           <p:cNvSpPr/>
           <p:nvPr/>
         </p:nvSpPr>
         <p:spPr>
           <a:xfrm>
-            <a:off x="8961120" y="2606040"/>
-            <a:ext cx="1280160" cy="548640"/>
+            <a:off x="3291840" y="4389120"/>
+            <a:ext cx="2560320" cy="1097280"/>
           </a:xfrm>
           <a:prstGeom prst="roundRect">
             <a:avLst/>
@@ -6614,7 +8035,7 @@
           </a:solidFill>
           <a:ln w="19050">
             <a:solidFill>
-              <a:srgbClr val="BBBBBB"/>
+              <a:srgbClr val="DC382D"/>
             </a:solidFill>
           </a:ln>
         </p:spPr>
@@ -6633,36 +8054,140 @@
           </a:fontRef>
         </p:style>
         <p:txBody>
-          <a:bodyPr rtlCol="0" anchor="ctr" wrap="square"/>
-          <a:lstStyle/>
-          <a:p>
-            <a:pPr algn="ctr">
-              <a:defRPr sz="800">
+          <a:bodyPr rtlCol="0" anchor="ctr"/>
+          <a:lstStyle/>
+          <a:p>
+            <a:pPr algn="ctr"/>
+          </a:p>
+        </p:txBody>
+      </p:sp>
+      <p:sp>
+        <p:nvSpPr>
+          <p:cNvPr id="62" name="Rectangle 61"/>
+          <p:cNvSpPr/>
+          <p:nvPr/>
+        </p:nvSpPr>
+        <p:spPr>
+          <a:xfrm>
+            <a:off x="3319272" y="4480560"/>
+            <a:ext cx="73152" cy="914400"/>
+          </a:xfrm>
+          <a:prstGeom prst="rect">
+            <a:avLst/>
+          </a:prstGeom>
+          <a:solidFill>
+            <a:srgbClr val="DC382D"/>
+          </a:solidFill>
+          <a:ln>
+            <a:noFill/>
+          </a:ln>
+        </p:spPr>
+        <p:style>
+          <a:lnRef idx="1">
+            <a:schemeClr val="accent1"/>
+          </a:lnRef>
+          <a:fillRef idx="3">
+            <a:schemeClr val="accent1"/>
+          </a:fillRef>
+          <a:effectRef idx="2">
+            <a:schemeClr val="accent1"/>
+          </a:effectRef>
+          <a:fontRef idx="minor">
+            <a:schemeClr val="lt1"/>
+          </a:fontRef>
+        </p:style>
+        <p:txBody>
+          <a:bodyPr rtlCol="0" anchor="ctr"/>
+          <a:lstStyle/>
+          <a:p>
+            <a:pPr algn="ctr"/>
+          </a:p>
+        </p:txBody>
+      </p:sp>
+      <p:sp>
+        <p:nvSpPr>
+          <p:cNvPr id="63" name="TextBox 62"/>
+          <p:cNvSpPr txBox="1"/>
+          <p:nvPr/>
+        </p:nvSpPr>
+        <p:spPr>
+          <a:xfrm>
+            <a:off x="3520440" y="4526280"/>
+            <a:ext cx="2194560" cy="365760"/>
+          </a:xfrm>
+          <a:prstGeom prst="rect">
+            <a:avLst/>
+          </a:prstGeom>
+          <a:noFill/>
+        </p:spPr>
+        <p:txBody>
+          <a:bodyPr wrap="square">
+            <a:spAutoFit/>
+          </a:bodyPr>
+          <a:lstStyle/>
+          <a:p>
+            <a:pPr algn="l">
+              <a:defRPr sz="1300" b="1">
                 <a:solidFill>
                   <a:srgbClr val="334059"/>
                 </a:solidFill>
               </a:defRPr>
             </a:pPr>
             <a:r>
-              <a:t>RAG</a:t>
+              <a:t>Redis</a:t>
+            </a:r>
+          </a:p>
+        </p:txBody>
+      </p:sp>
+      <p:sp>
+        <p:nvSpPr>
+          <p:cNvPr id="64" name="TextBox 63"/>
+          <p:cNvSpPr txBox="1"/>
+          <p:nvPr/>
+        </p:nvSpPr>
+        <p:spPr>
+          <a:xfrm>
+            <a:off x="3520440" y="4892040"/>
+            <a:ext cx="2194560" cy="457200"/>
+          </a:xfrm>
+          <a:prstGeom prst="rect">
+            <a:avLst/>
+          </a:prstGeom>
+          <a:noFill/>
+        </p:spPr>
+        <p:txBody>
+          <a:bodyPr wrap="square">
+            <a:spAutoFit/>
+          </a:bodyPr>
+          <a:lstStyle/>
+          <a:p>
+            <a:pPr algn="l">
+              <a:defRPr sz="1000" b="0">
+                <a:solidFill>
+                  <a:srgbClr val="666666"/>
+                </a:solidFill>
+              </a:defRPr>
+            </a:pPr>
+            <a:r>
+              <a:t>Profiles, Cache</a:t>
             </a:r>
             <a:br/>
             <a:r>
-              <a:t>LLM (Ollama)</a:t>
-            </a:r>
-          </a:p>
-        </p:txBody>
-      </p:sp>
-      <p:sp>
-        <p:nvSpPr>
-          <p:cNvPr id="24" name="Rounded Rectangle 23"/>
+              <a:t>Events, Cart</a:t>
+            </a:r>
+          </a:p>
+        </p:txBody>
+      </p:sp>
+      <p:sp>
+        <p:nvSpPr>
+          <p:cNvPr id="65" name="Rounded Rectangle 64"/>
           <p:cNvSpPr/>
           <p:nvPr/>
         </p:nvSpPr>
         <p:spPr>
           <a:xfrm>
-            <a:off x="5852160" y="3977640"/>
-            <a:ext cx="1280160" cy="548640"/>
+            <a:off x="6126480" y="4389120"/>
+            <a:ext cx="2560320" cy="1097280"/>
           </a:xfrm>
           <a:prstGeom prst="roundRect">
             <a:avLst/>
@@ -6672,7 +8197,7 @@
           </a:solidFill>
           <a:ln w="19050">
             <a:solidFill>
-              <a:srgbClr val="BBBBBB"/>
+              <a:srgbClr val="1976D2"/>
             </a:solidFill>
           </a:ln>
         </p:spPr>
@@ -6691,36 +8216,140 @@
           </a:fontRef>
         </p:style>
         <p:txBody>
-          <a:bodyPr rtlCol="0" anchor="ctr" wrap="square"/>
-          <a:lstStyle/>
-          <a:p>
-            <a:pPr algn="ctr">
-              <a:defRPr sz="800">
+          <a:bodyPr rtlCol="0" anchor="ctr"/>
+          <a:lstStyle/>
+          <a:p>
+            <a:pPr algn="ctr"/>
+          </a:p>
+        </p:txBody>
+      </p:sp>
+      <p:sp>
+        <p:nvSpPr>
+          <p:cNvPr id="66" name="Rectangle 65"/>
+          <p:cNvSpPr/>
+          <p:nvPr/>
+        </p:nvSpPr>
+        <p:spPr>
+          <a:xfrm>
+            <a:off x="6153912" y="4480560"/>
+            <a:ext cx="73152" cy="914400"/>
+          </a:xfrm>
+          <a:prstGeom prst="rect">
+            <a:avLst/>
+          </a:prstGeom>
+          <a:solidFill>
+            <a:srgbClr val="1976D2"/>
+          </a:solidFill>
+          <a:ln>
+            <a:noFill/>
+          </a:ln>
+        </p:spPr>
+        <p:style>
+          <a:lnRef idx="1">
+            <a:schemeClr val="accent1"/>
+          </a:lnRef>
+          <a:fillRef idx="3">
+            <a:schemeClr val="accent1"/>
+          </a:fillRef>
+          <a:effectRef idx="2">
+            <a:schemeClr val="accent1"/>
+          </a:effectRef>
+          <a:fontRef idx="minor">
+            <a:schemeClr val="lt1"/>
+          </a:fontRef>
+        </p:style>
+        <p:txBody>
+          <a:bodyPr rtlCol="0" anchor="ctr"/>
+          <a:lstStyle/>
+          <a:p>
+            <a:pPr algn="ctr"/>
+          </a:p>
+        </p:txBody>
+      </p:sp>
+      <p:sp>
+        <p:nvSpPr>
+          <p:cNvPr id="67" name="TextBox 66"/>
+          <p:cNvSpPr txBox="1"/>
+          <p:nvPr/>
+        </p:nvSpPr>
+        <p:spPr>
+          <a:xfrm>
+            <a:off x="6355080" y="4526280"/>
+            <a:ext cx="2194560" cy="365760"/>
+          </a:xfrm>
+          <a:prstGeom prst="rect">
+            <a:avLst/>
+          </a:prstGeom>
+          <a:noFill/>
+        </p:spPr>
+        <p:txBody>
+          <a:bodyPr wrap="square">
+            <a:spAutoFit/>
+          </a:bodyPr>
+          <a:lstStyle/>
+          <a:p>
+            <a:pPr algn="l">
+              <a:defRPr sz="1300" b="1">
                 <a:solidFill>
                   <a:srgbClr val="334059"/>
                 </a:solidFill>
               </a:defRPr>
             </a:pPr>
             <a:r>
-              <a:t>BM25 + fuzzy</a:t>
+              <a:t>PostgreSQL</a:t>
+            </a:r>
+          </a:p>
+        </p:txBody>
+      </p:sp>
+      <p:sp>
+        <p:nvSpPr>
+          <p:cNvPr id="68" name="TextBox 67"/>
+          <p:cNvSpPr txBox="1"/>
+          <p:nvPr/>
+        </p:nvSpPr>
+        <p:spPr>
+          <a:xfrm>
+            <a:off x="6355080" y="4892040"/>
+            <a:ext cx="2194560" cy="457200"/>
+          </a:xfrm>
+          <a:prstGeom prst="rect">
+            <a:avLst/>
+          </a:prstGeom>
+          <a:noFill/>
+        </p:spPr>
+        <p:txBody>
+          <a:bodyPr wrap="square">
+            <a:spAutoFit/>
+          </a:bodyPr>
+          <a:lstStyle/>
+          <a:p>
+            <a:pPr algn="l">
+              <a:defRPr sz="1000" b="0">
+                <a:solidFill>
+                  <a:srgbClr val="666666"/>
+                </a:solidFill>
+              </a:defRPr>
+            </a:pPr>
+            <a:r>
+              <a:t>2M Contracts</a:t>
             </a:r>
             <a:br/>
             <a:r>
-              <a:t>synonyms</a:t>
-            </a:r>
-          </a:p>
-        </p:txBody>
-      </p:sp>
-      <p:sp>
-        <p:nvSpPr>
-          <p:cNvPr id="25" name="Rounded Rectangle 24"/>
+              <a:t>Metrics, Sessions</a:t>
+            </a:r>
+          </a:p>
+        </p:txBody>
+      </p:sp>
+      <p:sp>
+        <p:nvSpPr>
+          <p:cNvPr id="69" name="Rounded Rectangle 68"/>
           <p:cNvSpPr/>
           <p:nvPr/>
         </p:nvSpPr>
         <p:spPr>
           <a:xfrm>
-            <a:off x="7406640" y="3977640"/>
-            <a:ext cx="1280160" cy="548640"/>
+            <a:off x="8961120" y="4389120"/>
+            <a:ext cx="2560320" cy="1097280"/>
           </a:xfrm>
           <a:prstGeom prst="roundRect">
             <a:avLst/>
@@ -6730,7 +8359,7 @@
           </a:solidFill>
           <a:ln w="19050">
             <a:solidFill>
-              <a:srgbClr val="BBBBBB"/>
+              <a:srgbClr val="7B1FA2"/>
             </a:solidFill>
           </a:ln>
         </p:spPr>
@@ -6749,47 +8378,32 @@
           </a:fontRef>
         </p:style>
         <p:txBody>
-          <a:bodyPr rtlCol="0" anchor="ctr" wrap="square"/>
-          <a:lstStyle/>
-          <a:p>
-            <a:pPr algn="ctr">
-              <a:defRPr sz="800">
-                <a:solidFill>
-                  <a:srgbClr val="334059"/>
-                </a:solidFill>
-              </a:defRPr>
-            </a:pPr>
-            <a:r>
-              <a:t>Aggregation</a:t>
-            </a:r>
-            <a:br/>
-            <a:r>
-              <a:t>категорий</a:t>
-            </a:r>
-          </a:p>
-        </p:txBody>
-      </p:sp>
-      <p:sp>
-        <p:nvSpPr>
-          <p:cNvPr id="26" name="Rounded Rectangle 25"/>
+          <a:bodyPr rtlCol="0" anchor="ctr"/>
+          <a:lstStyle/>
+          <a:p>
+            <a:pPr algn="ctr"/>
+          </a:p>
+        </p:txBody>
+      </p:sp>
+      <p:sp>
+        <p:nvSpPr>
+          <p:cNvPr id="70" name="Rectangle 69"/>
           <p:cNvSpPr/>
           <p:nvPr/>
         </p:nvSpPr>
         <p:spPr>
           <a:xfrm>
-            <a:off x="8961120" y="3977640"/>
-            <a:ext cx="1280160" cy="548640"/>
-          </a:xfrm>
-          <a:prstGeom prst="roundRect">
+            <a:off x="8988552" y="4480560"/>
+            <a:ext cx="73152" cy="914400"/>
+          </a:xfrm>
+          <a:prstGeom prst="rect">
             <a:avLst/>
           </a:prstGeom>
           <a:solidFill>
-            <a:srgbClr val="FFFFFF"/>
+            <a:srgbClr val="7B1FA2"/>
           </a:solidFill>
-          <a:ln w="19050">
-            <a:solidFill>
-              <a:srgbClr val="BBBBBB"/>
-            </a:solidFill>
+          <a:ln>
+            <a:noFill/>
           </a:ln>
         </p:spPr>
         <p:style>
@@ -6807,47 +8421,106 @@
           </a:fontRef>
         </p:style>
         <p:txBody>
-          <a:bodyPr rtlCol="0" anchor="ctr" wrap="square"/>
-          <a:lstStyle/>
-          <a:p>
-            <a:pPr algn="ctr">
-              <a:defRPr sz="800">
+          <a:bodyPr rtlCol="0" anchor="ctr"/>
+          <a:lstStyle/>
+          <a:p>
+            <a:pPr algn="ctr"/>
+          </a:p>
+        </p:txBody>
+      </p:sp>
+      <p:sp>
+        <p:nvSpPr>
+          <p:cNvPr id="71" name="TextBox 70"/>
+          <p:cNvSpPr txBox="1"/>
+          <p:nvPr/>
+        </p:nvSpPr>
+        <p:spPr>
+          <a:xfrm>
+            <a:off x="9189720" y="4526280"/>
+            <a:ext cx="2194560" cy="365760"/>
+          </a:xfrm>
+          <a:prstGeom prst="rect">
+            <a:avLst/>
+          </a:prstGeom>
+          <a:noFill/>
+        </p:spPr>
+        <p:txBody>
+          <a:bodyPr wrap="square">
+            <a:spAutoFit/>
+          </a:bodyPr>
+          <a:lstStyle/>
+          <a:p>
+            <a:pPr algn="l">
+              <a:defRPr sz="1300" b="1">
                 <a:solidFill>
                   <a:srgbClr val="334059"/>
                 </a:solidFill>
               </a:defRPr>
             </a:pPr>
             <a:r>
-              <a:t>Filtered</a:t>
+              <a:t>Ollama (CPU)</a:t>
+            </a:r>
+          </a:p>
+        </p:txBody>
+      </p:sp>
+      <p:sp>
+        <p:nvSpPr>
+          <p:cNvPr id="72" name="TextBox 71"/>
+          <p:cNvSpPr txBox="1"/>
+          <p:nvPr/>
+        </p:nvSpPr>
+        <p:spPr>
+          <a:xfrm>
+            <a:off x="9189720" y="4892040"/>
+            <a:ext cx="2194560" cy="457200"/>
+          </a:xfrm>
+          <a:prstGeom prst="rect">
+            <a:avLst/>
+          </a:prstGeom>
+          <a:noFill/>
+        </p:spPr>
+        <p:txBody>
+          <a:bodyPr wrap="square">
+            <a:spAutoFit/>
+          </a:bodyPr>
+          <a:lstStyle/>
+          <a:p>
+            <a:pPr algn="l">
+              <a:defRPr sz="1000" b="0">
+                <a:solidFill>
+                  <a:srgbClr val="666666"/>
+                </a:solidFill>
+              </a:defRPr>
+            </a:pPr>
+            <a:r>
+              <a:t>Qwen 2.5 7B</a:t>
             </a:r>
             <a:br/>
             <a:r>
-              <a:t>search</a:t>
-            </a:r>
-          </a:p>
-        </p:txBody>
-      </p:sp>
-      <p:sp>
-        <p:nvSpPr>
-          <p:cNvPr id="27" name="Rounded Rectangle 26"/>
+              <a:t>AI query expansion</a:t>
+            </a:r>
+          </a:p>
+        </p:txBody>
+      </p:sp>
+      <p:sp>
+        <p:nvSpPr>
+          <p:cNvPr id="73" name="Rectangle 72"/>
           <p:cNvSpPr/>
           <p:nvPr/>
         </p:nvSpPr>
         <p:spPr>
           <a:xfrm>
-            <a:off x="1645920" y="5349240"/>
-            <a:ext cx="1280160" cy="548640"/>
-          </a:xfrm>
-          <a:prstGeom prst="roundRect">
+            <a:off x="1346200" y="2240280"/>
+            <a:ext cx="50800" cy="411480"/>
+          </a:xfrm>
+          <a:prstGeom prst="rect">
             <a:avLst/>
           </a:prstGeom>
           <a:solidFill>
-            <a:srgbClr val="FFFFFF"/>
+            <a:srgbClr val="BBBBBB"/>
           </a:solidFill>
-          <a:ln w="19050">
-            <a:solidFill>
-              <a:srgbClr val="BBBBBB"/>
-            </a:solidFill>
+          <a:ln>
+            <a:noFill/>
           </a:ln>
         </p:spPr>
         <p:style>
@@ -6865,47 +8538,32 @@
           </a:fontRef>
         </p:style>
         <p:txBody>
-          <a:bodyPr rtlCol="0" anchor="ctr" wrap="square"/>
-          <a:lstStyle/>
-          <a:p>
-            <a:pPr algn="ctr">
-              <a:defRPr sz="800">
-                <a:solidFill>
-                  <a:srgbClr val="334059"/>
-                </a:solidFill>
-              </a:defRPr>
-            </a:pPr>
-            <a:r>
-              <a:t>Cold start</a:t>
-            </a:r>
-            <a:br/>
-            <a:r>
-              <a:t>PG → Redis</a:t>
-            </a:r>
-          </a:p>
-        </p:txBody>
-      </p:sp>
-      <p:sp>
-        <p:nvSpPr>
-          <p:cNvPr id="28" name="Rounded Rectangle 27"/>
+          <a:bodyPr rtlCol="0" anchor="ctr"/>
+          <a:lstStyle/>
+          <a:p>
+            <a:pPr algn="ctr"/>
+          </a:p>
+        </p:txBody>
+      </p:sp>
+      <p:sp>
+        <p:nvSpPr>
+          <p:cNvPr id="74" name="Rectangle 73"/>
           <p:cNvSpPr/>
           <p:nvPr/>
         </p:nvSpPr>
         <p:spPr>
           <a:xfrm>
-            <a:off x="3200400" y="5349240"/>
-            <a:ext cx="1280160" cy="548640"/>
-          </a:xfrm>
-          <a:prstGeom prst="roundRect">
+            <a:off x="3769360" y="2240280"/>
+            <a:ext cx="50800" cy="411480"/>
+          </a:xfrm>
+          <a:prstGeom prst="rect">
             <a:avLst/>
           </a:prstGeom>
           <a:solidFill>
-            <a:srgbClr val="FFFFFF"/>
+            <a:srgbClr val="BBBBBB"/>
           </a:solidFill>
-          <a:ln w="19050">
-            <a:solidFill>
-              <a:srgbClr val="BBBBBB"/>
-            </a:solidFill>
+          <a:ln>
+            <a:noFill/>
           </a:ln>
         </p:spPr>
         <p:style>
@@ -6923,47 +8581,32 @@
           </a:fontRef>
         </p:style>
         <p:txBody>
-          <a:bodyPr rtlCol="0" anchor="ctr" wrap="square"/>
-          <a:lstStyle/>
-          <a:p>
-            <a:pPr algn="ctr">
-              <a:defRPr sz="800">
-                <a:solidFill>
-                  <a:srgbClr val="334059"/>
-                </a:solidFill>
-              </a:defRPr>
-            </a:pPr>
-            <a:r>
-              <a:t>Product</a:t>
-            </a:r>
-            <a:br/>
-            <a:r>
-              <a:t>boosts</a:t>
-            </a:r>
-          </a:p>
-        </p:txBody>
-      </p:sp>
-      <p:sp>
-        <p:nvSpPr>
-          <p:cNvPr id="29" name="Rounded Rectangle 28"/>
+          <a:bodyPr rtlCol="0" anchor="ctr"/>
+          <a:lstStyle/>
+          <a:p>
+            <a:pPr algn="ctr"/>
+          </a:p>
+        </p:txBody>
+      </p:sp>
+      <p:sp>
+        <p:nvSpPr>
+          <p:cNvPr id="75" name="Rectangle 74"/>
           <p:cNvSpPr/>
           <p:nvPr/>
         </p:nvSpPr>
         <p:spPr>
           <a:xfrm>
-            <a:off x="4754880" y="5349240"/>
-            <a:ext cx="1280160" cy="548640"/>
-          </a:xfrm>
-          <a:prstGeom prst="roundRect">
+            <a:off x="6146800" y="2240280"/>
+            <a:ext cx="50800" cy="411480"/>
+          </a:xfrm>
+          <a:prstGeom prst="rect">
             <a:avLst/>
           </a:prstGeom>
           <a:solidFill>
-            <a:srgbClr val="FFFFFF"/>
+            <a:srgbClr val="BBBBBB"/>
           </a:solidFill>
-          <a:ln w="19050">
-            <a:solidFill>
-              <a:srgbClr val="BBBBBB"/>
-            </a:solidFill>
+          <a:ln>
+            <a:noFill/>
           </a:ln>
         </p:spPr>
         <p:style>
@@ -6981,47 +8624,32 @@
           </a:fontRef>
         </p:style>
         <p:txBody>
-          <a:bodyPr rtlCol="0" anchor="ctr" wrap="square"/>
-          <a:lstStyle/>
-          <a:p>
-            <a:pPr algn="ctr">
-              <a:defRPr sz="800">
-                <a:solidFill>
-                  <a:srgbClr val="334059"/>
-                </a:solidFill>
-              </a:defRPr>
-            </a:pPr>
-            <a:r>
-              <a:t>Category</a:t>
-            </a:r>
-            <a:br/>
-            <a:r>
-              <a:t>boosts</a:t>
-            </a:r>
-          </a:p>
-        </p:txBody>
-      </p:sp>
-      <p:sp>
-        <p:nvSpPr>
-          <p:cNvPr id="30" name="Rounded Rectangle 29"/>
+          <a:bodyPr rtlCol="0" anchor="ctr"/>
+          <a:lstStyle/>
+          <a:p>
+            <a:pPr algn="ctr"/>
+          </a:p>
+        </p:txBody>
+      </p:sp>
+      <p:sp>
+        <p:nvSpPr>
+          <p:cNvPr id="76" name="Rectangle 75"/>
           <p:cNvSpPr/>
           <p:nvPr/>
         </p:nvSpPr>
         <p:spPr>
           <a:xfrm>
-            <a:off x="8961120" y="5349240"/>
-            <a:ext cx="1280160" cy="548640"/>
-          </a:xfrm>
-          <a:prstGeom prst="roundRect">
+            <a:off x="8432800" y="2240280"/>
+            <a:ext cx="50800" cy="411480"/>
+          </a:xfrm>
+          <a:prstGeom prst="rect">
             <a:avLst/>
           </a:prstGeom>
           <a:solidFill>
-            <a:srgbClr val="FFFFFF"/>
+            <a:srgbClr val="BBBBBB"/>
           </a:solidFill>
-          <a:ln w="19050">
-            <a:solidFill>
-              <a:srgbClr val="BBBBBB"/>
-            </a:solidFill>
+          <a:ln>
+            <a:noFill/>
           </a:ln>
         </p:spPr>
         <p:style>
@@ -7039,42 +8667,29 @@
           </a:fontRef>
         </p:style>
         <p:txBody>
-          <a:bodyPr rtlCol="0" anchor="ctr" wrap="square"/>
-          <a:lstStyle/>
-          <a:p>
-            <a:pPr algn="ctr">
-              <a:defRPr sz="800">
-                <a:solidFill>
-                  <a:srgbClr val="334059"/>
-                </a:solidFill>
-              </a:defRPr>
-            </a:pPr>
-            <a:r>
-              <a:t>Track events</a:t>
-            </a:r>
-            <a:br/>
-            <a:r>
-              <a:t>log + session</a:t>
-            </a:r>
-          </a:p>
-        </p:txBody>
-      </p:sp>
-      <p:sp>
-        <p:nvSpPr>
-          <p:cNvPr id="31" name="Rectangle 30"/>
+          <a:bodyPr rtlCol="0" anchor="ctr"/>
+          <a:lstStyle/>
+          <a:p>
+            <a:pPr algn="ctr"/>
+          </a:p>
+        </p:txBody>
+      </p:sp>
+      <p:sp>
+        <p:nvSpPr>
+          <p:cNvPr id="77" name="Rectangle 76"/>
           <p:cNvSpPr/>
           <p:nvPr/>
         </p:nvSpPr>
         <p:spPr>
           <a:xfrm>
-            <a:off x="2011680" y="1496060"/>
-            <a:ext cx="1188720" cy="25400"/>
+            <a:off x="10627360" y="2240280"/>
+            <a:ext cx="50800" cy="411480"/>
           </a:xfrm>
           <a:prstGeom prst="rect">
             <a:avLst/>
           </a:prstGeom>
           <a:solidFill>
-            <a:srgbClr val="999999"/>
+            <a:srgbClr val="BBBBBB"/>
           </a:solidFill>
           <a:ln>
             <a:noFill/>
@@ -7104,20 +8719,20 @@
       </p:sp>
       <p:sp>
         <p:nvSpPr>
-          <p:cNvPr id="32" name="Rectangle 31"/>
+          <p:cNvPr id="78" name="Rectangle 77"/>
           <p:cNvSpPr/>
           <p:nvPr/>
         </p:nvSpPr>
         <p:spPr>
           <a:xfrm>
-            <a:off x="10228580" y="1508760"/>
-            <a:ext cx="25400" cy="1371600"/>
+            <a:off x="1711960" y="3886200"/>
+            <a:ext cx="50800" cy="411480"/>
           </a:xfrm>
           <a:prstGeom prst="rect">
             <a:avLst/>
           </a:prstGeom>
           <a:solidFill>
-            <a:srgbClr val="999999"/>
+            <a:srgbClr val="BBBBBB"/>
           </a:solidFill>
           <a:ln>
             <a:noFill/>
@@ -7147,20 +8762,20 @@
       </p:sp>
       <p:sp>
         <p:nvSpPr>
-          <p:cNvPr id="33" name="Rectangle 32"/>
+          <p:cNvPr id="79" name="Rectangle 78"/>
           <p:cNvSpPr/>
           <p:nvPr/>
         </p:nvSpPr>
         <p:spPr>
           <a:xfrm>
-            <a:off x="3827780" y="1783080"/>
-            <a:ext cx="25400" cy="822960"/>
+            <a:off x="4546600" y="3886200"/>
+            <a:ext cx="50800" cy="411480"/>
           </a:xfrm>
           <a:prstGeom prst="rect">
             <a:avLst/>
           </a:prstGeom>
           <a:solidFill>
-            <a:srgbClr val="999999"/>
+            <a:srgbClr val="BBBBBB"/>
           </a:solidFill>
           <a:ln>
             <a:noFill/>
@@ -7190,20 +8805,20 @@
       </p:sp>
       <p:sp>
         <p:nvSpPr>
-          <p:cNvPr id="34" name="Rectangle 33"/>
+          <p:cNvPr id="80" name="Rectangle 79"/>
           <p:cNvSpPr/>
           <p:nvPr/>
         </p:nvSpPr>
         <p:spPr>
           <a:xfrm>
-            <a:off x="2273300" y="1783080"/>
-            <a:ext cx="25400" cy="822960"/>
+            <a:off x="7381240" y="3886200"/>
+            <a:ext cx="50800" cy="411480"/>
           </a:xfrm>
           <a:prstGeom prst="rect">
             <a:avLst/>
           </a:prstGeom>
           <a:solidFill>
-            <a:srgbClr val="999999"/>
+            <a:srgbClr val="BBBBBB"/>
           </a:solidFill>
           <a:ln>
             <a:noFill/>
@@ -7233,20 +8848,20 @@
       </p:sp>
       <p:sp>
         <p:nvSpPr>
-          <p:cNvPr id="35" name="Rectangle 34"/>
+          <p:cNvPr id="81" name="Rectangle 80"/>
           <p:cNvSpPr/>
           <p:nvPr/>
         </p:nvSpPr>
         <p:spPr>
           <a:xfrm>
-            <a:off x="2926080" y="2867660"/>
-            <a:ext cx="274320" cy="25400"/>
+            <a:off x="10215880" y="3886200"/>
+            <a:ext cx="50800" cy="411480"/>
           </a:xfrm>
           <a:prstGeom prst="rect">
             <a:avLst/>
           </a:prstGeom>
           <a:solidFill>
-            <a:srgbClr val="999999"/>
+            <a:srgbClr val="BBBBBB"/>
           </a:solidFill>
           <a:ln>
             <a:noFill/>
@@ -7271,721 +8886,6 @@
           <a:lstStyle/>
           <a:p>
             <a:pPr algn="ctr"/>
-          </a:p>
-        </p:txBody>
-      </p:sp>
-      <p:sp>
-        <p:nvSpPr>
-          <p:cNvPr id="36" name="Rectangle 35"/>
-          <p:cNvSpPr/>
-          <p:nvPr/>
-        </p:nvSpPr>
-        <p:spPr>
-          <a:xfrm>
-            <a:off x="4480560" y="2867660"/>
-            <a:ext cx="640080" cy="25400"/>
-          </a:xfrm>
-          <a:prstGeom prst="rect">
-            <a:avLst/>
-          </a:prstGeom>
-          <a:solidFill>
-            <a:srgbClr val="999999"/>
-          </a:solidFill>
-          <a:ln>
-            <a:noFill/>
-          </a:ln>
-        </p:spPr>
-        <p:style>
-          <a:lnRef idx="1">
-            <a:schemeClr val="accent1"/>
-          </a:lnRef>
-          <a:fillRef idx="3">
-            <a:schemeClr val="accent1"/>
-          </a:fillRef>
-          <a:effectRef idx="2">
-            <a:schemeClr val="accent1"/>
-          </a:effectRef>
-          <a:fontRef idx="minor">
-            <a:schemeClr val="lt1"/>
-          </a:fontRef>
-        </p:style>
-        <p:txBody>
-          <a:bodyPr rtlCol="0" anchor="ctr"/>
-          <a:lstStyle/>
-          <a:p>
-            <a:pPr algn="ctr"/>
-          </a:p>
-        </p:txBody>
-      </p:sp>
-      <p:sp>
-        <p:nvSpPr>
-          <p:cNvPr id="37" name="Rectangle 36"/>
-          <p:cNvSpPr/>
-          <p:nvPr/>
-        </p:nvSpPr>
-        <p:spPr>
-          <a:xfrm>
-            <a:off x="5623560" y="2730500"/>
-            <a:ext cx="228600" cy="25400"/>
-          </a:xfrm>
-          <a:prstGeom prst="rect">
-            <a:avLst/>
-          </a:prstGeom>
-          <a:solidFill>
-            <a:srgbClr val="999999"/>
-          </a:solidFill>
-          <a:ln>
-            <a:noFill/>
-          </a:ln>
-        </p:spPr>
-        <p:style>
-          <a:lnRef idx="1">
-            <a:schemeClr val="accent1"/>
-          </a:lnRef>
-          <a:fillRef idx="3">
-            <a:schemeClr val="accent1"/>
-          </a:fillRef>
-          <a:effectRef idx="2">
-            <a:schemeClr val="accent1"/>
-          </a:effectRef>
-          <a:fontRef idx="minor">
-            <a:schemeClr val="lt1"/>
-          </a:fontRef>
-        </p:style>
-        <p:txBody>
-          <a:bodyPr rtlCol="0" anchor="ctr"/>
-          <a:lstStyle/>
-          <a:p>
-            <a:pPr algn="ctr"/>
-          </a:p>
-        </p:txBody>
-      </p:sp>
-      <p:sp>
-        <p:nvSpPr>
-          <p:cNvPr id="38" name="Rectangle 37"/>
-          <p:cNvSpPr/>
-          <p:nvPr/>
-        </p:nvSpPr>
-        <p:spPr>
-          <a:xfrm>
-            <a:off x="5623560" y="3004820"/>
-            <a:ext cx="228600" cy="25400"/>
-          </a:xfrm>
-          <a:prstGeom prst="rect">
-            <a:avLst/>
-          </a:prstGeom>
-          <a:solidFill>
-            <a:srgbClr val="999999"/>
-          </a:solidFill>
-          <a:ln>
-            <a:noFill/>
-          </a:ln>
-        </p:spPr>
-        <p:style>
-          <a:lnRef idx="1">
-            <a:schemeClr val="accent1"/>
-          </a:lnRef>
-          <a:fillRef idx="3">
-            <a:schemeClr val="accent1"/>
-          </a:fillRef>
-          <a:effectRef idx="2">
-            <a:schemeClr val="accent1"/>
-          </a:effectRef>
-          <a:fontRef idx="minor">
-            <a:schemeClr val="lt1"/>
-          </a:fontRef>
-        </p:style>
-        <p:txBody>
-          <a:bodyPr rtlCol="0" anchor="ctr"/>
-          <a:lstStyle/>
-          <a:p>
-            <a:pPr algn="ctr"/>
-          </a:p>
-        </p:txBody>
-      </p:sp>
-      <p:sp>
-        <p:nvSpPr>
-          <p:cNvPr id="39" name="Rectangle 38"/>
-          <p:cNvSpPr/>
-          <p:nvPr/>
-        </p:nvSpPr>
-        <p:spPr>
-          <a:xfrm>
-            <a:off x="7119620" y="2560320"/>
-            <a:ext cx="25400" cy="320040"/>
-          </a:xfrm>
-          <a:prstGeom prst="rect">
-            <a:avLst/>
-          </a:prstGeom>
-          <a:solidFill>
-            <a:srgbClr val="999999"/>
-          </a:solidFill>
-          <a:ln>
-            <a:noFill/>
-          </a:ln>
-        </p:spPr>
-        <p:style>
-          <a:lnRef idx="1">
-            <a:schemeClr val="accent1"/>
-          </a:lnRef>
-          <a:fillRef idx="3">
-            <a:schemeClr val="accent1"/>
-          </a:fillRef>
-          <a:effectRef idx="2">
-            <a:schemeClr val="accent1"/>
-          </a:effectRef>
-          <a:fontRef idx="minor">
-            <a:schemeClr val="lt1"/>
-          </a:fontRef>
-        </p:style>
-        <p:txBody>
-          <a:bodyPr rtlCol="0" anchor="ctr"/>
-          <a:lstStyle/>
-          <a:p>
-            <a:pPr algn="ctr"/>
-          </a:p>
-        </p:txBody>
-      </p:sp>
-      <p:sp>
-        <p:nvSpPr>
-          <p:cNvPr id="40" name="Rectangle 39"/>
-          <p:cNvSpPr/>
-          <p:nvPr/>
-        </p:nvSpPr>
-        <p:spPr>
-          <a:xfrm>
-            <a:off x="7119620" y="2880360"/>
-            <a:ext cx="25400" cy="320040"/>
-          </a:xfrm>
-          <a:prstGeom prst="rect">
-            <a:avLst/>
-          </a:prstGeom>
-          <a:solidFill>
-            <a:srgbClr val="999999"/>
-          </a:solidFill>
-          <a:ln>
-            <a:noFill/>
-          </a:ln>
-        </p:spPr>
-        <p:style>
-          <a:lnRef idx="1">
-            <a:schemeClr val="accent1"/>
-          </a:lnRef>
-          <a:fillRef idx="3">
-            <a:schemeClr val="accent1"/>
-          </a:fillRef>
-          <a:effectRef idx="2">
-            <a:schemeClr val="accent1"/>
-          </a:effectRef>
-          <a:fontRef idx="minor">
-            <a:schemeClr val="lt1"/>
-          </a:fontRef>
-        </p:style>
-        <p:txBody>
-          <a:bodyPr rtlCol="0" anchor="ctr"/>
-          <a:lstStyle/>
-          <a:p>
-            <a:pPr algn="ctr"/>
-          </a:p>
-        </p:txBody>
-      </p:sp>
-      <p:sp>
-        <p:nvSpPr>
-          <p:cNvPr id="41" name="Rectangle 40"/>
-          <p:cNvSpPr/>
-          <p:nvPr/>
-        </p:nvSpPr>
-        <p:spPr>
-          <a:xfrm>
-            <a:off x="8686800" y="2867660"/>
-            <a:ext cx="274320" cy="25400"/>
-          </a:xfrm>
-          <a:prstGeom prst="rect">
-            <a:avLst/>
-          </a:prstGeom>
-          <a:solidFill>
-            <a:srgbClr val="999999"/>
-          </a:solidFill>
-          <a:ln>
-            <a:noFill/>
-          </a:ln>
-        </p:spPr>
-        <p:style>
-          <a:lnRef idx="1">
-            <a:schemeClr val="accent1"/>
-          </a:lnRef>
-          <a:fillRef idx="3">
-            <a:schemeClr val="accent1"/>
-          </a:fillRef>
-          <a:effectRef idx="2">
-            <a:schemeClr val="accent1"/>
-          </a:effectRef>
-          <a:fontRef idx="minor">
-            <a:schemeClr val="lt1"/>
-          </a:fontRef>
-        </p:style>
-        <p:txBody>
-          <a:bodyPr rtlCol="0" anchor="ctr"/>
-          <a:lstStyle/>
-          <a:p>
-            <a:pPr algn="ctr"/>
-          </a:p>
-        </p:txBody>
-      </p:sp>
-      <p:sp>
-        <p:nvSpPr>
-          <p:cNvPr id="42" name="Rectangle 41"/>
-          <p:cNvSpPr/>
-          <p:nvPr/>
-        </p:nvSpPr>
-        <p:spPr>
-          <a:xfrm>
-            <a:off x="6479540" y="3474720"/>
-            <a:ext cx="25400" cy="502920"/>
-          </a:xfrm>
-          <a:prstGeom prst="rect">
-            <a:avLst/>
-          </a:prstGeom>
-          <a:solidFill>
-            <a:srgbClr val="999999"/>
-          </a:solidFill>
-          <a:ln>
-            <a:noFill/>
-          </a:ln>
-        </p:spPr>
-        <p:style>
-          <a:lnRef idx="1">
-            <a:schemeClr val="accent1"/>
-          </a:lnRef>
-          <a:fillRef idx="3">
-            <a:schemeClr val="accent1"/>
-          </a:fillRef>
-          <a:effectRef idx="2">
-            <a:schemeClr val="accent1"/>
-          </a:effectRef>
-          <a:fontRef idx="minor">
-            <a:schemeClr val="lt1"/>
-          </a:fontRef>
-        </p:style>
-        <p:txBody>
-          <a:bodyPr rtlCol="0" anchor="ctr"/>
-          <a:lstStyle/>
-          <a:p>
-            <a:pPr algn="ctr"/>
-          </a:p>
-        </p:txBody>
-      </p:sp>
-      <p:sp>
-        <p:nvSpPr>
-          <p:cNvPr id="43" name="Rectangle 42"/>
-          <p:cNvSpPr/>
-          <p:nvPr/>
-        </p:nvSpPr>
-        <p:spPr>
-          <a:xfrm>
-            <a:off x="8034020" y="3154680"/>
-            <a:ext cx="25400" cy="822960"/>
-          </a:xfrm>
-          <a:prstGeom prst="rect">
-            <a:avLst/>
-          </a:prstGeom>
-          <a:solidFill>
-            <a:srgbClr val="999999"/>
-          </a:solidFill>
-          <a:ln>
-            <a:noFill/>
-          </a:ln>
-        </p:spPr>
-        <p:style>
-          <a:lnRef idx="1">
-            <a:schemeClr val="accent1"/>
-          </a:lnRef>
-          <a:fillRef idx="3">
-            <a:schemeClr val="accent1"/>
-          </a:fillRef>
-          <a:effectRef idx="2">
-            <a:schemeClr val="accent1"/>
-          </a:effectRef>
-          <a:fontRef idx="minor">
-            <a:schemeClr val="lt1"/>
-          </a:fontRef>
-        </p:style>
-        <p:txBody>
-          <a:bodyPr rtlCol="0" anchor="ctr"/>
-          <a:lstStyle/>
-          <a:p>
-            <a:pPr algn="ctr"/>
-          </a:p>
-        </p:txBody>
-      </p:sp>
-      <p:sp>
-        <p:nvSpPr>
-          <p:cNvPr id="44" name="Rectangle 43"/>
-          <p:cNvSpPr/>
-          <p:nvPr/>
-        </p:nvSpPr>
-        <p:spPr>
-          <a:xfrm>
-            <a:off x="9588500" y="3154680"/>
-            <a:ext cx="25400" cy="822960"/>
-          </a:xfrm>
-          <a:prstGeom prst="rect">
-            <a:avLst/>
-          </a:prstGeom>
-          <a:solidFill>
-            <a:srgbClr val="999999"/>
-          </a:solidFill>
-          <a:ln>
-            <a:noFill/>
-          </a:ln>
-        </p:spPr>
-        <p:style>
-          <a:lnRef idx="1">
-            <a:schemeClr val="accent1"/>
-          </a:lnRef>
-          <a:fillRef idx="3">
-            <a:schemeClr val="accent1"/>
-          </a:fillRef>
-          <a:effectRef idx="2">
-            <a:schemeClr val="accent1"/>
-          </a:effectRef>
-          <a:fontRef idx="minor">
-            <a:schemeClr val="lt1"/>
-          </a:fontRef>
-        </p:style>
-        <p:txBody>
-          <a:bodyPr rtlCol="0" anchor="ctr"/>
-          <a:lstStyle/>
-          <a:p>
-            <a:pPr algn="ctr"/>
-          </a:p>
-        </p:txBody>
-      </p:sp>
-      <p:sp>
-        <p:nvSpPr>
-          <p:cNvPr id="45" name="Rectangle 44"/>
-          <p:cNvSpPr/>
-          <p:nvPr/>
-        </p:nvSpPr>
-        <p:spPr>
-          <a:xfrm>
-            <a:off x="7132320" y="4239260"/>
-            <a:ext cx="274320" cy="25400"/>
-          </a:xfrm>
-          <a:prstGeom prst="rect">
-            <a:avLst/>
-          </a:prstGeom>
-          <a:solidFill>
-            <a:srgbClr val="999999"/>
-          </a:solidFill>
-          <a:ln>
-            <a:noFill/>
-          </a:ln>
-        </p:spPr>
-        <p:style>
-          <a:lnRef idx="1">
-            <a:schemeClr val="accent1"/>
-          </a:lnRef>
-          <a:fillRef idx="3">
-            <a:schemeClr val="accent1"/>
-          </a:fillRef>
-          <a:effectRef idx="2">
-            <a:schemeClr val="accent1"/>
-          </a:effectRef>
-          <a:fontRef idx="minor">
-            <a:schemeClr val="lt1"/>
-          </a:fontRef>
-        </p:style>
-        <p:txBody>
-          <a:bodyPr rtlCol="0" anchor="ctr"/>
-          <a:lstStyle/>
-          <a:p>
-            <a:pPr algn="ctr"/>
-          </a:p>
-        </p:txBody>
-      </p:sp>
-      <p:sp>
-        <p:nvSpPr>
-          <p:cNvPr id="46" name="Rectangle 45"/>
-          <p:cNvSpPr/>
-          <p:nvPr/>
-        </p:nvSpPr>
-        <p:spPr>
-          <a:xfrm>
-            <a:off x="8686800" y="4239260"/>
-            <a:ext cx="274320" cy="25400"/>
-          </a:xfrm>
-          <a:prstGeom prst="rect">
-            <a:avLst/>
-          </a:prstGeom>
-          <a:solidFill>
-            <a:srgbClr val="999999"/>
-          </a:solidFill>
-          <a:ln>
-            <a:noFill/>
-          </a:ln>
-        </p:spPr>
-        <p:style>
-          <a:lnRef idx="1">
-            <a:schemeClr val="accent1"/>
-          </a:lnRef>
-          <a:fillRef idx="3">
-            <a:schemeClr val="accent1"/>
-          </a:fillRef>
-          <a:effectRef idx="2">
-            <a:schemeClr val="accent1"/>
-          </a:effectRef>
-          <a:fontRef idx="minor">
-            <a:schemeClr val="lt1"/>
-          </a:fontRef>
-        </p:style>
-        <p:txBody>
-          <a:bodyPr rtlCol="0" anchor="ctr"/>
-          <a:lstStyle/>
-          <a:p>
-            <a:pPr algn="ctr"/>
-          </a:p>
-        </p:txBody>
-      </p:sp>
-      <p:sp>
-        <p:nvSpPr>
-          <p:cNvPr id="47" name="Rectangle 46"/>
-          <p:cNvSpPr/>
-          <p:nvPr/>
-        </p:nvSpPr>
-        <p:spPr>
-          <a:xfrm>
-            <a:off x="2273300" y="3154680"/>
-            <a:ext cx="25400" cy="2194560"/>
-          </a:xfrm>
-          <a:prstGeom prst="rect">
-            <a:avLst/>
-          </a:prstGeom>
-          <a:solidFill>
-            <a:srgbClr val="999999"/>
-          </a:solidFill>
-          <a:ln>
-            <a:noFill/>
-          </a:ln>
-        </p:spPr>
-        <p:style>
-          <a:lnRef idx="1">
-            <a:schemeClr val="accent1"/>
-          </a:lnRef>
-          <a:fillRef idx="3">
-            <a:schemeClr val="accent1"/>
-          </a:fillRef>
-          <a:effectRef idx="2">
-            <a:schemeClr val="accent1"/>
-          </a:effectRef>
-          <a:fontRef idx="minor">
-            <a:schemeClr val="lt1"/>
-          </a:fontRef>
-        </p:style>
-        <p:txBody>
-          <a:bodyPr rtlCol="0" anchor="ctr"/>
-          <a:lstStyle/>
-          <a:p>
-            <a:pPr algn="ctr"/>
-          </a:p>
-        </p:txBody>
-      </p:sp>
-      <p:sp>
-        <p:nvSpPr>
-          <p:cNvPr id="48" name="Rectangle 47"/>
-          <p:cNvSpPr/>
-          <p:nvPr/>
-        </p:nvSpPr>
-        <p:spPr>
-          <a:xfrm>
-            <a:off x="9588500" y="3154680"/>
-            <a:ext cx="25400" cy="2194560"/>
-          </a:xfrm>
-          <a:prstGeom prst="rect">
-            <a:avLst/>
-          </a:prstGeom>
-          <a:solidFill>
-            <a:srgbClr val="999999"/>
-          </a:solidFill>
-          <a:ln>
-            <a:noFill/>
-          </a:ln>
-        </p:spPr>
-        <p:style>
-          <a:lnRef idx="1">
-            <a:schemeClr val="accent1"/>
-          </a:lnRef>
-          <a:fillRef idx="3">
-            <a:schemeClr val="accent1"/>
-          </a:fillRef>
-          <a:effectRef idx="2">
-            <a:schemeClr val="accent1"/>
-          </a:effectRef>
-          <a:fontRef idx="minor">
-            <a:schemeClr val="lt1"/>
-          </a:fontRef>
-        </p:style>
-        <p:txBody>
-          <a:bodyPr rtlCol="0" anchor="ctr"/>
-          <a:lstStyle/>
-          <a:p>
-            <a:pPr algn="ctr"/>
-          </a:p>
-        </p:txBody>
-      </p:sp>
-      <p:sp>
-        <p:nvSpPr>
-          <p:cNvPr id="49" name="Rectangle 48"/>
-          <p:cNvSpPr/>
-          <p:nvPr/>
-        </p:nvSpPr>
-        <p:spPr>
-          <a:xfrm>
-            <a:off x="2926080" y="5610860"/>
-            <a:ext cx="274320" cy="25400"/>
-          </a:xfrm>
-          <a:prstGeom prst="rect">
-            <a:avLst/>
-          </a:prstGeom>
-          <a:solidFill>
-            <a:srgbClr val="999999"/>
-          </a:solidFill>
-          <a:ln>
-            <a:noFill/>
-          </a:ln>
-        </p:spPr>
-        <p:style>
-          <a:lnRef idx="1">
-            <a:schemeClr val="accent1"/>
-          </a:lnRef>
-          <a:fillRef idx="3">
-            <a:schemeClr val="accent1"/>
-          </a:fillRef>
-          <a:effectRef idx="2">
-            <a:schemeClr val="accent1"/>
-          </a:effectRef>
-          <a:fontRef idx="minor">
-            <a:schemeClr val="lt1"/>
-          </a:fontRef>
-        </p:style>
-        <p:txBody>
-          <a:bodyPr rtlCol="0" anchor="ctr"/>
-          <a:lstStyle/>
-          <a:p>
-            <a:pPr algn="ctr"/>
-          </a:p>
-        </p:txBody>
-      </p:sp>
-      <p:sp>
-        <p:nvSpPr>
-          <p:cNvPr id="50" name="Rectangle 49"/>
-          <p:cNvSpPr/>
-          <p:nvPr/>
-        </p:nvSpPr>
-        <p:spPr>
-          <a:xfrm>
-            <a:off x="4480560" y="5610860"/>
-            <a:ext cx="274320" cy="25400"/>
-          </a:xfrm>
-          <a:prstGeom prst="rect">
-            <a:avLst/>
-          </a:prstGeom>
-          <a:solidFill>
-            <a:srgbClr val="999999"/>
-          </a:solidFill>
-          <a:ln>
-            <a:noFill/>
-          </a:ln>
-        </p:spPr>
-        <p:style>
-          <a:lnRef idx="1">
-            <a:schemeClr val="accent1"/>
-          </a:lnRef>
-          <a:fillRef idx="3">
-            <a:schemeClr val="accent1"/>
-          </a:fillRef>
-          <a:effectRef idx="2">
-            <a:schemeClr val="accent1"/>
-          </a:effectRef>
-          <a:fontRef idx="minor">
-            <a:schemeClr val="lt1"/>
-          </a:fontRef>
-        </p:style>
-        <p:txBody>
-          <a:bodyPr rtlCol="0" anchor="ctr"/>
-          <a:lstStyle/>
-          <a:p>
-            <a:pPr algn="ctr"/>
-          </a:p>
-        </p:txBody>
-      </p:sp>
-      <p:sp>
-        <p:nvSpPr>
-          <p:cNvPr id="51" name="TextBox 50"/>
-          <p:cNvSpPr txBox="1"/>
-          <p:nvPr/>
-        </p:nvSpPr>
-        <p:spPr>
-          <a:xfrm>
-            <a:off x="5257800" y="2103120"/>
-            <a:ext cx="457200" cy="182880"/>
-          </a:xfrm>
-          <a:prstGeom prst="rect">
-            <a:avLst/>
-          </a:prstGeom>
-          <a:noFill/>
-        </p:spPr>
-        <p:txBody>
-          <a:bodyPr wrap="square">
-            <a:spAutoFit/>
-          </a:bodyPr>
-          <a:lstStyle/>
-          <a:p>
-            <a:pPr algn="l">
-              <a:defRPr sz="700" b="1">
-                <a:solidFill>
-                  <a:srgbClr val="43A047"/>
-                </a:solidFill>
-              </a:defRPr>
-            </a:pPr>
-            <a:r>
-              <a:t>Да</a:t>
-            </a:r>
-          </a:p>
-        </p:txBody>
-      </p:sp>
-      <p:sp>
-        <p:nvSpPr>
-          <p:cNvPr id="52" name="TextBox 51"/>
-          <p:cNvSpPr txBox="1"/>
-          <p:nvPr/>
-        </p:nvSpPr>
-        <p:spPr>
-          <a:xfrm>
-            <a:off x="5257800" y="3246120"/>
-            <a:ext cx="457200" cy="182880"/>
-          </a:xfrm>
-          <a:prstGeom prst="rect">
-            <a:avLst/>
-          </a:prstGeom>
-          <a:noFill/>
-        </p:spPr>
-        <p:txBody>
-          <a:bodyPr wrap="square">
-            <a:spAutoFit/>
-          </a:bodyPr>
-          <a:lstStyle/>
-          <a:p>
-            <a:pPr algn="l">
-              <a:defRPr sz="700" b="1">
-                <a:solidFill>
-                  <a:srgbClr val="E53935"/>
-                </a:solidFill>
-              </a:defRPr>
-            </a:pPr>
-            <a:r>
-              <a:t>Нет</a:t>
-            </a:r>
           </a:p>
         </p:txBody>
       </p:sp>
@@ -12469,8 +13369,8 @@
         </p:nvSpPr>
         <p:spPr>
           <a:xfrm>
-            <a:off x="3474720" y="2090420"/>
-            <a:ext cx="640080" cy="25400"/>
+            <a:off x="3474720" y="2103120"/>
+            <a:ext cx="640080" cy="38100"/>
           </a:xfrm>
           <a:prstGeom prst="rect">
             <a:avLst/>
@@ -12512,8 +13412,8 @@
         </p:nvSpPr>
         <p:spPr>
           <a:xfrm>
-            <a:off x="5382260" y="2834640"/>
-            <a:ext cx="25400" cy="640080"/>
+            <a:off x="5394960" y="2834640"/>
+            <a:ext cx="38100" cy="640080"/>
           </a:xfrm>
           <a:prstGeom prst="rect">
             <a:avLst/>
@@ -12555,8 +13455,8 @@
         </p:nvSpPr>
         <p:spPr>
           <a:xfrm>
-            <a:off x="2181860" y="2834640"/>
-            <a:ext cx="25400" cy="640080"/>
+            <a:off x="2194560" y="2834640"/>
+            <a:ext cx="38100" cy="640080"/>
           </a:xfrm>
           <a:prstGeom prst="rect">
             <a:avLst/>
@@ -12598,8 +13498,8 @@
         </p:nvSpPr>
         <p:spPr>
           <a:xfrm>
-            <a:off x="6675120" y="2090420"/>
-            <a:ext cx="640080" cy="25400"/>
+            <a:off x="6675120" y="2103120"/>
+            <a:ext cx="640080" cy="38100"/>
           </a:xfrm>
           <a:prstGeom prst="rect">
             <a:avLst/>
@@ -12641,8 +13541,8 @@
         </p:nvSpPr>
         <p:spPr>
           <a:xfrm>
-            <a:off x="6675120" y="4193540"/>
-            <a:ext cx="640080" cy="25400"/>
+            <a:off x="6675120" y="4206240"/>
+            <a:ext cx="640080" cy="38100"/>
           </a:xfrm>
           <a:prstGeom prst="rect">
             <a:avLst/>

</xml_diff>